<commit_message>
feat: deck v5 story (build log + frontend showcase)
</commit_message>
<xml_diff>
--- a/docs/slides-deck.pptx
+++ b/docs/slides-deck.pptx
@@ -511,7 +511,7 @@
           <a:lstStyle/>
           <a:p>
             <a:r>
-              <a:t>Открываем спокойно: кто мы, что построили, главная цифра. Score 0.654 — валидный воспроизводимый результат. Дальше — как пришли.</a:t>
+              <a:t>Сразу показываем что готово, без прелюдий.</a:t>
             </a:r>
           </a:p>
         </p:txBody>
@@ -581,7 +581,7 @@
           <a:lstStyle/>
           <a:p>
             <a:r>
-              <a:t>Финал: коротко поблагодарить, предложить вопросы. Не оправдываться за 0.654 — подавать как честный инженерный результат.</a:t>
+              <a:t>Коротко и уверенно. Дальше — вопросы и живое демо.</a:t>
             </a:r>
           </a:p>
         </p:txBody>
@@ -651,7 +651,7 @@
           <a:lstStyle/>
           <a:p>
             <a:r>
-              <a:t>Мотивация: дежурным нужны чистые точки без ложных выездов, региону — контуры гарей для восстановления леса и расчёта ущерба.</a:t>
+              <a:t>EDA за полминуты CPU-проходом. Тут видно что мы реально смотрели в данные.</a:t>
             </a:r>
           </a:p>
         </p:txBody>
@@ -721,7 +721,7 @@
           <a:lstStyle/>
           <a:p>
             <a:r>
-              <a:t>Три выхода кейса. Подчеркнуть: всё считается автоматически, без ручных операций с растрами.</a:t>
+              <a:t>AF — наша сильная сторона. Картинка справа — предсказание модели.</a:t>
             </a:r>
           </a:p>
         </p:txBody>
@@ -791,7 +791,7 @@
           <a:lstStyle/>
           <a:p>
             <a:r>
-              <a:t>Ключевое для жюри: честность протокола. Сплит без утечек, тест не трогаем руками, повторный прогон даёт тот же файл.</a:t>
+              <a:t>История про инженерную честность: убивать нерабочее — тоже работа.</a:t>
             </a:r>
           </a:p>
         </p:txBody>
@@ -861,7 +861,7 @@
           <a:lstStyle/>
           <a:p>
             <a:r>
-              <a:t>AF — сильная сторона. Ночной разрыв объяснить: ночью видны только тепловые каналы.</a:t>
+              <a:t>Цифры медленно. В топе чата 0.8+, но наш файл валиден и честен.</a:t>
             </a:r>
           </a:p>
         </p:txBody>
@@ -931,7 +931,7 @@
           <a:lstStyle/>
           <a:p>
             <a:r>
-              <a:t>Здесь показать инженерную зрелость: убивать нерабочие ветки — тоже результат. Пашня даёт ложные контуры — следующий шаг.</a:t>
+              <a:t>Пауза. Это не мокап — живой фронт на нашем API: 17 точек, контуры по степеням, справка.</a:t>
             </a:r>
           </a:p>
         </p:txBody>
@@ -1001,7 +1001,7 @@
           <a:lstStyle/>
           <a:p>
             <a:r>
-              <a:t>Цифры называть медленно. Акцент: файл валиден и воспроизводим — это дорогого стоит.</a:t>
+              <a:t>Слои выключаются, степени фильтруются, справка пересчитывается из слоёв.</a:t>
             </a:r>
           </a:p>
         </p:txBody>
@@ -1071,7 +1071,7 @@
           <a:lstStyle/>
           <a:p>
             <a:r>
-              <a:t>Пауза и показ: точки, полигоны по степеням, справка с гектарами. Если спросят про привязку — честно: demo-сетка, гео теста скрыто.</a:t>
+              <a:t>API делали под фронт, фронт — под жюри. Всё состыковано.</a:t>
             </a:r>
           </a:p>
         </p:txBody>
@@ -1141,7 +1141,7 @@
           <a:lstStyle/>
           <a:p>
             <a:r>
-              <a:t>Для оргов главное — воспроизводимость. Веса в репо, CPU-фолбэк, инструкция в README.</a:t>
+              <a:t>Оргам важно: воспроизводимость, CPU-фолбэк, инструкция в README.</a:t>
             </a:r>
           </a:p>
         </p:txBody>
@@ -4163,8 +4163,8 @@
         </p:nvSpPr>
         <p:spPr>
           <a:xfrm>
-            <a:off x="640080" y="457200"/>
-            <a:ext cx="10881360" cy="365760"/>
+            <a:off x="640080" y="548640"/>
+            <a:ext cx="10881360" cy="914400"/>
           </a:xfrm>
           <a:prstGeom prst="rect">
             <a:avLst/>
@@ -4179,85 +4179,71 @@
           <a:p>
             <a:pPr algn="l"/>
             <a:r>
-              <a:rPr sz="1400" b="1">
-                <a:solidFill>
-                  <a:srgbClr val="FF6B35"/>
-                </a:solidFill>
-                <a:latin typeface="Inter"/>
-              </a:rPr>
-              <a:t>КОСМОХАКАТОН 2026 · КЕЙС «МОНИТОРИНГ ПРИРОДНЫХ ПОЖАРОВ»</a:t>
-            </a:r>
-          </a:p>
-        </p:txBody>
-      </p:sp>
-      <p:sp>
-        <p:nvSpPr>
-          <p:cNvPr id="3" name="TextBox 2"/>
-          <p:cNvSpPr txBox="1"/>
-          <p:nvPr/>
-        </p:nvSpPr>
-        <p:spPr>
-          <a:xfrm>
-            <a:off x="640080" y="1005840"/>
-            <a:ext cx="10881360" cy="1280160"/>
-          </a:xfrm>
-          <a:prstGeom prst="rect">
-            <a:avLst/>
-          </a:prstGeom>
-          <a:noFill/>
-        </p:spPr>
-        <p:txBody>
-          <a:bodyPr wrap="square">
-            <a:spAutoFit/>
-          </a:bodyPr>
-          <a:lstStyle/>
-          <a:p>
-            <a:pPr algn="l"/>
-            <a:r>
-              <a:rPr sz="6400" b="1">
+              <a:rPr sz="6000" b="1">
                 <a:solidFill>
                   <a:srgbClr val="F2F4F5"/>
                 </a:solidFill>
                 <a:latin typeface="Inter"/>
               </a:rPr>
-              <a:t>Жим Ногами</a:t>
-            </a:r>
-            <a:r>
-              <a:rPr sz="2200" b="0">
+              <a:t>ЖИМ НОГАМИ</a:t>
+            </a:r>
+          </a:p>
+        </p:txBody>
+      </p:sp>
+      <p:sp>
+        <p:nvSpPr>
+          <p:cNvPr id="3" name="TextBox 2"/>
+          <p:cNvSpPr txBox="1"/>
+          <p:nvPr/>
+        </p:nvSpPr>
+        <p:spPr>
+          <a:xfrm>
+            <a:off x="640080" y="1737360"/>
+            <a:ext cx="10881360" cy="640080"/>
+          </a:xfrm>
+          <a:prstGeom prst="rect">
+            <a:avLst/>
+          </a:prstGeom>
+          <a:noFill/>
+        </p:spPr>
+        <p:txBody>
+          <a:bodyPr wrap="square">
+            <a:spAutoFit/>
+          </a:bodyPr>
+          <a:lstStyle/>
+          <a:p>
+            <a:pPr algn="l"/>
+            <a:r>
+              <a:rPr sz="2100" b="0">
                 <a:solidFill>
                   <a:srgbClr val="B8C0C8"/>
                 </a:solidFill>
                 <a:latin typeface="Inter"/>
               </a:rPr>
-              <a:t>
-Двухэтапный мониторинг пожаров по спутниковым данным</a:t>
-            </a:r>
-          </a:p>
-        </p:txBody>
-      </p:sp>
-      <p:sp>
-        <p:nvSpPr>
-          <p:cNvPr id="4" name="Rounded Rectangle 3"/>
+              <a:t>Мониторинг лесных пожаров: от сырых снимков до живой карты за один уикенд</a:t>
+            </a:r>
+          </a:p>
+        </p:txBody>
+      </p:sp>
+      <p:sp>
+        <p:nvSpPr>
+          <p:cNvPr id="4" name="Oval 3"/>
           <p:cNvSpPr/>
           <p:nvPr/>
         </p:nvSpPr>
         <p:spPr>
           <a:xfrm>
-            <a:off x="640080" y="3931920"/>
-            <a:ext cx="3657600" cy="1371600"/>
-          </a:xfrm>
-          <a:prstGeom prst="roundRect">
-            <a:avLst>
-              <a:gd name="adj" fmla="val 7000"/>
-            </a:avLst>
+            <a:off x="914400" y="2962656"/>
+            <a:ext cx="155448" cy="155448"/>
+          </a:xfrm>
+          <a:prstGeom prst="ellipse">
+            <a:avLst/>
           </a:prstGeom>
           <a:solidFill>
-            <a:srgbClr val="0D1217"/>
+            <a:srgbClr val="62D99A"/>
           </a:solidFill>
-          <a:ln w="12700">
-            <a:solidFill>
-              <a:srgbClr val="2A333D"/>
-            </a:solidFill>
+          <a:ln>
+            <a:noFill/>
           </a:ln>
         </p:spPr>
         <p:style>
@@ -4290,8 +4276,8 @@
         </p:nvSpPr>
         <p:spPr>
           <a:xfrm>
-            <a:off x="640080" y="4069080"/>
-            <a:ext cx="3657600" cy="1097280"/>
+            <a:off x="1280160" y="2761488"/>
+            <a:ext cx="10241280" cy="868680"/>
           </a:xfrm>
           <a:prstGeom prst="rect">
             <a:avLst/>
@@ -4304,42 +4290,48 @@
           </a:bodyPr>
           <a:lstStyle/>
           <a:p>
-            <a:pPr algn="ctr"/>
-            <a:r>
-              <a:rPr sz="4000" b="1">
+            <a:pPr algn="l"/>
+            <a:r>
+              <a:rPr sz="2100" b="0">
                 <a:solidFill>
-                  <a:srgbClr val="62D99A"/>
+                  <a:srgbClr val="F2F4F5"/>
                 </a:solidFill>
                 <a:latin typeface="Inter"/>
               </a:rPr>
-              <a:t>Score 0.654</a:t>
-            </a:r>
-          </a:p>
-        </p:txBody>
-      </p:sp>
-      <p:sp>
-        <p:nvSpPr>
-          <p:cNvPr id="6" name="Rounded Rectangle 5"/>
+              <a:t>Обучили две нейросети — детектор огня и картировальщик гарей</a:t>
+            </a:r>
+            <a:r>
+              <a:rPr sz="1400" b="0">
+                <a:solidFill>
+                  <a:srgbClr val="7D8690"/>
+                </a:solidFill>
+                <a:latin typeface="Inter"/>
+              </a:rPr>
+              <a:t>
+Score 0.654 · файл-ответ валиден и воспроизводим</a:t>
+            </a:r>
+          </a:p>
+        </p:txBody>
+      </p:sp>
+      <p:sp>
+        <p:nvSpPr>
+          <p:cNvPr id="6" name="Oval 5"/>
           <p:cNvSpPr/>
           <p:nvPr/>
         </p:nvSpPr>
         <p:spPr>
           <a:xfrm>
-            <a:off x="4480560" y="3931920"/>
-            <a:ext cx="3657600" cy="1371600"/>
-          </a:xfrm>
-          <a:prstGeom prst="roundRect">
-            <a:avLst>
-              <a:gd name="adj" fmla="val 7000"/>
-            </a:avLst>
+            <a:off x="914400" y="4059935"/>
+            <a:ext cx="155448" cy="155448"/>
+          </a:xfrm>
+          <a:prstGeom prst="ellipse">
+            <a:avLst/>
           </a:prstGeom>
           <a:solidFill>
-            <a:srgbClr val="0D1217"/>
+            <a:srgbClr val="FF6B35"/>
           </a:solidFill>
-          <a:ln w="12700">
-            <a:solidFill>
-              <a:srgbClr val="2A333D"/>
-            </a:solidFill>
+          <a:ln>
+            <a:noFill/>
           </a:ln>
         </p:spPr>
         <p:style>
@@ -4372,8 +4364,8 @@
         </p:nvSpPr>
         <p:spPr>
           <a:xfrm>
-            <a:off x="4480560" y="4069080"/>
-            <a:ext cx="3657600" cy="1097280"/>
+            <a:off x="1280160" y="3858768"/>
+            <a:ext cx="10241280" cy="868680"/>
           </a:xfrm>
           <a:prstGeom prst="rect">
             <a:avLst/>
@@ -4386,42 +4378,48 @@
           </a:bodyPr>
           <a:lstStyle/>
           <a:p>
-            <a:pPr algn="ctr"/>
-            <a:r>
-              <a:rPr sz="3000" b="1">
+            <a:pPr algn="l"/>
+            <a:r>
+              <a:rPr sz="2100" b="0">
                 <a:solidFill>
                   <a:srgbClr val="F2F4F5"/>
                 </a:solidFill>
                 <a:latin typeface="Inter"/>
               </a:rPr>
-              <a:t>submission FINAL</a:t>
-            </a:r>
-          </a:p>
-        </p:txBody>
-      </p:sp>
-      <p:sp>
-        <p:nvSpPr>
-          <p:cNvPr id="8" name="Rounded Rectangle 7"/>
+              <a:t>Подняли сервис и тёмную веб-карту с точками, контурами и справкой</a:t>
+            </a:r>
+            <a:r>
+              <a:rPr sz="1400" b="0">
+                <a:solidFill>
+                  <a:srgbClr val="7D8690"/>
+                </a:solidFill>
+                <a:latin typeface="Inter"/>
+              </a:rPr>
+              <a:t>
+то, что вы увидите дальше — работает прямо сейчас</a:t>
+            </a:r>
+          </a:p>
+        </p:txBody>
+      </p:sp>
+      <p:sp>
+        <p:nvSpPr>
+          <p:cNvPr id="8" name="Oval 7"/>
           <p:cNvSpPr/>
           <p:nvPr/>
         </p:nvSpPr>
         <p:spPr>
           <a:xfrm>
-            <a:off x="8321040" y="3931920"/>
-            <a:ext cx="3200400" cy="1371600"/>
-          </a:xfrm>
-          <a:prstGeom prst="roundRect">
-            <a:avLst>
-              <a:gd name="adj" fmla="val 7000"/>
-            </a:avLst>
+            <a:off x="914400" y="5157216"/>
+            <a:ext cx="155448" cy="155448"/>
+          </a:xfrm>
+          <a:prstGeom prst="ellipse">
+            <a:avLst/>
           </a:prstGeom>
           <a:solidFill>
-            <a:srgbClr val="0D1217"/>
+            <a:srgbClr val="F2F4F5"/>
           </a:solidFill>
-          <a:ln w="12700">
-            <a:solidFill>
-              <a:srgbClr val="2A333D"/>
-            </a:solidFill>
+          <a:ln>
+            <a:noFill/>
           </a:ln>
         </p:spPr>
         <p:style>
@@ -4454,8 +4452,8 @@
         </p:nvSpPr>
         <p:spPr>
           <a:xfrm>
-            <a:off x="8321040" y="4069080"/>
-            <a:ext cx="3200400" cy="1097280"/>
+            <a:off x="1280160" y="4956048"/>
+            <a:ext cx="10241280" cy="868680"/>
           </a:xfrm>
           <a:prstGeom prst="rect">
             <a:avLst/>
@@ -4468,15 +4466,25 @@
           </a:bodyPr>
           <a:lstStyle/>
           <a:p>
-            <a:pPr algn="ctr"/>
-            <a:r>
-              <a:rPr sz="3000" b="1">
+            <a:pPr algn="l"/>
+            <a:r>
+              <a:rPr sz="2100" b="0">
                 <a:solidFill>
-                  <a:srgbClr val="FF6B35"/>
+                  <a:srgbClr val="F2F4F5"/>
                 </a:solidFill>
                 <a:latin typeface="Inter"/>
               </a:rPr>
-              <a:t>сервис LIVE</a:t>
+              <a:t>Всё открыто: код, веса, отчёт</a:t>
+            </a:r>
+            <a:r>
+              <a:rPr sz="1400" b="0">
+                <a:solidFill>
+                  <a:srgbClr val="7D8690"/>
+                </a:solidFill>
+                <a:latin typeface="Inter"/>
+              </a:rPr>
+              <a:t>
+клонируй и запускай одной командой</a:t>
             </a:r>
           </a:p>
         </p:txBody>
@@ -4515,7 +4523,7 @@
         </p:nvSpPr>
         <p:spPr>
           <a:xfrm>
-            <a:off x="640080" y="1463040"/>
+            <a:off x="640080" y="1645920"/>
             <a:ext cx="10881360" cy="1097280"/>
           </a:xfrm>
           <a:prstGeom prst="rect">
@@ -4537,7 +4545,7 @@
                 </a:solidFill>
                 <a:latin typeface="Inter"/>
               </a:rPr>
-              <a:t>Жим Ногами</a:t>
+              <a:t>ЖИМ НОГАМИ</a:t>
             </a:r>
           </a:p>
         </p:txBody>
@@ -4550,7 +4558,7 @@
         </p:nvSpPr>
         <p:spPr>
           <a:xfrm>
-            <a:off x="640080" y="2834640"/>
+            <a:off x="640080" y="3017520"/>
             <a:ext cx="10881360" cy="731520"/>
           </a:xfrm>
           <a:prstGeom prst="rect">
@@ -4572,55 +4580,20 @@
                 </a:solidFill>
                 <a:latin typeface="Inter"/>
               </a:rPr>
-              <a:t>спасибо · вопросы — по коду в репозитории</a:t>
-            </a:r>
-          </a:p>
-        </p:txBody>
-      </p:sp>
-      <p:sp>
-        <p:nvSpPr>
-          <p:cNvPr id="4" name="TextBox 3"/>
-          <p:cNvSpPr txBox="1"/>
-          <p:nvPr/>
-        </p:nvSpPr>
-        <p:spPr>
-          <a:xfrm>
-            <a:off x="640080" y="3931920"/>
-            <a:ext cx="10881360" cy="548640"/>
-          </a:xfrm>
-          <a:prstGeom prst="rect">
-            <a:avLst/>
-          </a:prstGeom>
-          <a:noFill/>
-        </p:spPr>
-        <p:txBody>
-          <a:bodyPr wrap="square">
-            <a:spAutoFit/>
-          </a:bodyPr>
-          <a:lstStyle/>
-          <a:p>
-            <a:pPr algn="ctr"/>
-            <a:r>
-              <a:rPr sz="1600" b="0">
-                <a:solidFill>
-                  <a:srgbClr val="7D8690"/>
-                </a:solidFill>
-                <a:latin typeface="Inter"/>
-              </a:rPr>
-              <a:t>github.com/izislesar/kosmohack · gitverse · Score 0.654</a:t>
-            </a:r>
-          </a:p>
-        </p:txBody>
-      </p:sp>
-      <p:sp>
-        <p:nvSpPr>
-          <p:cNvPr id="5" name="Oval 4"/>
+              <a:t>код, веса и отчёт — в репозитории · вопросы?</a:t>
+            </a:r>
+          </a:p>
+        </p:txBody>
+      </p:sp>
+      <p:sp>
+        <p:nvSpPr>
+          <p:cNvPr id="4" name="Oval 3"/>
           <p:cNvSpPr/>
           <p:nvPr/>
         </p:nvSpPr>
         <p:spPr>
           <a:xfrm>
-            <a:off x="5989320" y="5120640"/>
+            <a:off x="5989320" y="4389120"/>
             <a:ext cx="182880" cy="182880"/>
           </a:xfrm>
           <a:prstGeom prst="ellipse">
@@ -4690,7 +4663,7 @@
         <p:spPr>
           <a:xfrm>
             <a:off x="640080" y="274320"/>
-            <a:ext cx="4572000" cy="365760"/>
+            <a:ext cx="10881360" cy="365760"/>
           </a:xfrm>
           <a:prstGeom prst="rect">
             <a:avLst/>
@@ -4704,15 +4677,6 @@
           <a:lstStyle/>
           <a:p>
             <a:pPr algn="l"/>
-            <a:r>
-              <a:rPr sz="1200" b="1">
-                <a:solidFill>
-                  <a:srgbClr val="7D8690"/>
-                </a:solidFill>
-                <a:latin typeface="Inter"/>
-              </a:rPr>
-              <a:t>02 / 10   </a:t>
-            </a:r>
             <a:r>
               <a:rPr sz="1200" b="1">
                 <a:solidFill>
@@ -4733,7 +4697,7 @@
         </p:nvSpPr>
         <p:spPr>
           <a:xfrm>
-            <a:off x="11612880" y="384048"/>
+            <a:off x="11658600" y="384048"/>
             <a:ext cx="128016" cy="128016"/>
           </a:xfrm>
           <a:prstGeom prst="ellipse">
@@ -4776,8 +4740,8 @@
         </p:nvSpPr>
         <p:spPr>
           <a:xfrm>
-            <a:off x="640080" y="822960"/>
-            <a:ext cx="10881360" cy="1188720"/>
+            <a:off x="640080" y="777240"/>
+            <a:ext cx="10881360" cy="1097280"/>
           </a:xfrm>
           <a:prstGeom prst="rect">
             <a:avLst/>
@@ -4792,14 +4756,13 @@
           <a:p>
             <a:pPr algn="l"/>
             <a:r>
-              <a:rPr sz="4000" b="1">
+              <a:rPr sz="3800" b="1">
                 <a:solidFill>
                   <a:srgbClr val="F2F4F5"/>
                 </a:solidFill>
                 <a:latin typeface="Inter"/>
               </a:rPr>
-              <a:t>Пожары видно из космоса.
-Беда — отличить их от заводов</a:t>
+              <a:t>Сначала — разобрали данные до винтика</a:t>
             </a:r>
           </a:p>
         </p:txBody>
@@ -4812,14 +4775,14 @@
         </p:nvSpPr>
         <p:spPr>
           <a:xfrm>
-            <a:off x="914400" y="2779776"/>
+            <a:off x="914400" y="2414016"/>
             <a:ext cx="155448" cy="155448"/>
           </a:xfrm>
           <a:prstGeom prst="ellipse">
             <a:avLst/>
           </a:prstGeom>
           <a:solidFill>
-            <a:srgbClr val="EF5B5B"/>
+            <a:srgbClr val="E6C65C"/>
           </a:solidFill>
           <a:ln>
             <a:noFill/>
@@ -4855,8 +4818,8 @@
         </p:nvSpPr>
         <p:spPr>
           <a:xfrm>
-            <a:off x="1280160" y="2578608"/>
-            <a:ext cx="10332720" cy="822960"/>
+            <a:off x="1280160" y="2212848"/>
+            <a:ext cx="10241280" cy="868680"/>
           </a:xfrm>
           <a:prstGeom prst="rect">
             <a:avLst/>
@@ -4871,23 +4834,23 @@
           <a:p>
             <a:pPr algn="l"/>
             <a:r>
-              <a:rPr sz="2200" b="0">
+              <a:rPr sz="2100" b="0">
                 <a:solidFill>
                   <a:srgbClr val="F2F4F5"/>
                 </a:solidFill>
                 <a:latin typeface="Inter"/>
               </a:rPr>
-              <a:t>Леса и степи горят с апреля по октябрь</a:t>
-            </a:r>
-            <a:r>
-              <a:rPr sz="1500" b="0">
+              <a:t>Огня в выборке 0.035% — 21 пиксель на снимок</a:t>
+            </a:r>
+            <a:r>
+              <a:rPr sz="1400" b="0">
                 <a:solidFill>
                   <a:srgbClr val="7D8690"/>
                 </a:solidFill>
                 <a:latin typeface="Inter"/>
               </a:rPr>
               <a:t>
-скорость степного фронта — километры в час</a:t>
+поэтому oversample, Dice+Focal и порог по micro-метрике, а не по средней</a:t>
             </a:r>
           </a:p>
         </p:txBody>
@@ -4900,14 +4863,14 @@
         </p:nvSpPr>
         <p:spPr>
           <a:xfrm>
-            <a:off x="914400" y="3831335"/>
+            <a:off x="914400" y="3557016"/>
             <a:ext cx="155448" cy="155448"/>
           </a:xfrm>
           <a:prstGeom prst="ellipse">
             <a:avLst/>
           </a:prstGeom>
           <a:solidFill>
-            <a:srgbClr val="E6C65C"/>
+            <a:srgbClr val="FF6B35"/>
           </a:solidFill>
           <a:ln>
             <a:noFill/>
@@ -4943,8 +4906,8 @@
         </p:nvSpPr>
         <p:spPr>
           <a:xfrm>
-            <a:off x="1280160" y="3630168"/>
-            <a:ext cx="10332720" cy="822960"/>
+            <a:off x="1280160" y="3355848"/>
+            <a:ext cx="10241280" cy="868680"/>
           </a:xfrm>
           <a:prstGeom prst="rect">
             <a:avLst/>
@@ -4959,23 +4922,23 @@
           <a:p>
             <a:pPr algn="l"/>
             <a:r>
-              <a:rPr sz="2200" b="0">
+              <a:rPr sz="2100" b="0">
                 <a:solidFill>
                   <a:srgbClr val="F2F4F5"/>
                 </a:solidFill>
                 <a:latin typeface="Inter"/>
               </a:rPr>
-              <a:t>Глобальные продукты врут</a:t>
-            </a:r>
-            <a:r>
-              <a:rPr sz="1500" b="0">
+              <a:t>Метаданным не поверили и правильно сделали</a:t>
+            </a:r>
+            <a:r>
+              <a:rPr sz="1400" b="0">
                 <a:solidFill>
                   <a:srgbClr val="7D8690"/>
                 </a:solidFill>
                 <a:latin typeface="Inter"/>
               </a:rPr>
               <a:t>
-FIRMS сыплет ложняками на факелах и ТЭЦ, пропускает малые очаги</a:t>
+облачность из таблицы не сошлась с растрами — взяли маску из снимков</a:t>
             </a:r>
           </a:p>
         </p:txBody>
@@ -4988,14 +4951,14 @@
         </p:nvSpPr>
         <p:spPr>
           <a:xfrm>
-            <a:off x="914400" y="4882895"/>
+            <a:off x="914400" y="4700016"/>
             <a:ext cx="155448" cy="155448"/>
           </a:xfrm>
           <a:prstGeom prst="ellipse">
             <a:avLst/>
           </a:prstGeom>
           <a:solidFill>
-            <a:srgbClr val="FF6B35"/>
+            <a:srgbClr val="62D99A"/>
           </a:solidFill>
           <a:ln>
             <a:noFill/>
@@ -5031,8 +4994,8 @@
         </p:nvSpPr>
         <p:spPr>
           <a:xfrm>
-            <a:off x="1280160" y="4681727"/>
-            <a:ext cx="10332720" cy="822960"/>
+            <a:off x="1280160" y="4498848"/>
+            <a:ext cx="10241280" cy="868680"/>
           </a:xfrm>
           <a:prstGeom prst="rect">
             <a:avLst/>
@@ -5047,23 +5010,23 @@
           <a:p>
             <a:pPr algn="l"/>
             <a:r>
-              <a:rPr sz="2200" b="0">
+              <a:rPr sz="2100" b="0">
                 <a:solidFill>
                   <a:srgbClr val="F2F4F5"/>
                 </a:solidFill>
                 <a:latin typeface="Inter"/>
               </a:rPr>
-              <a:t>Гари считают вручную</a:t>
-            </a:r>
-            <a:r>
-              <a:rPr sz="1500" b="0">
+              <a:t>Пороги гарей вывели под каждый ландшафт</a:t>
+            </a:r>
+            <a:r>
+              <a:rPr sz="1400" b="0">
                 <a:solidFill>
                   <a:srgbClr val="7D8690"/>
                 </a:solidFill>
                 <a:latin typeface="Inter"/>
               </a:rPr>
               <a:t>
-выборочно, с задержкой в недели, без единой методики</a:t>
+лес, степь, пашня и пойма горят по-разному — один порог врёт всем</a:t>
             </a:r>
           </a:p>
         </p:txBody>
@@ -5103,7 +5066,7 @@
         <p:spPr>
           <a:xfrm>
             <a:off x="640080" y="274320"/>
-            <a:ext cx="4572000" cy="365760"/>
+            <a:ext cx="10881360" cy="365760"/>
           </a:xfrm>
           <a:prstGeom prst="rect">
             <a:avLst/>
@@ -5117,15 +5080,6 @@
           <a:lstStyle/>
           <a:p>
             <a:pPr algn="l"/>
-            <a:r>
-              <a:rPr sz="1200" b="1">
-                <a:solidFill>
-                  <a:srgbClr val="7D8690"/>
-                </a:solidFill>
-                <a:latin typeface="Inter"/>
-              </a:rPr>
-              <a:t>03 / 10   </a:t>
-            </a:r>
             <a:r>
               <a:rPr sz="1200" b="1">
                 <a:solidFill>
@@ -5146,7 +5100,7 @@
         </p:nvSpPr>
         <p:spPr>
           <a:xfrm>
-            <a:off x="11612880" y="384048"/>
+            <a:off x="11658600" y="384048"/>
             <a:ext cx="128016" cy="128016"/>
           </a:xfrm>
           <a:prstGeom prst="ellipse">
@@ -5189,8 +5143,8 @@
         </p:nvSpPr>
         <p:spPr>
           <a:xfrm>
-            <a:off x="640080" y="822960"/>
-            <a:ext cx="10881360" cy="1188720"/>
+            <a:off x="640080" y="777240"/>
+            <a:ext cx="10881360" cy="1097280"/>
           </a:xfrm>
           <a:prstGeom prst="rect">
             <a:avLst/>
@@ -5205,40 +5159,36 @@
           <a:p>
             <a:pPr algn="l"/>
             <a:r>
-              <a:rPr sz="4000" b="1">
+              <a:rPr sz="3800" b="1">
                 <a:solidFill>
                   <a:srgbClr val="F2F4F5"/>
                 </a:solidFill>
                 <a:latin typeface="Inter"/>
               </a:rPr>
-              <a:t>Что требовалось построить</a:t>
-            </a:r>
-          </a:p>
-        </p:txBody>
-      </p:sp>
-      <p:sp>
-        <p:nvSpPr>
-          <p:cNvPr id="5" name="Rounded Rectangle 4"/>
+              <a:t>Детектор огня: 5 минут — и готово</a:t>
+            </a:r>
+          </a:p>
+        </p:txBody>
+      </p:sp>
+      <p:sp>
+        <p:nvSpPr>
+          <p:cNvPr id="5" name="Oval 4"/>
           <p:cNvSpPr/>
           <p:nvPr/>
         </p:nvSpPr>
         <p:spPr>
           <a:xfrm>
-            <a:off x="594360" y="2468880"/>
-            <a:ext cx="3474720" cy="2011680"/>
-          </a:xfrm>
-          <a:prstGeom prst="roundRect">
-            <a:avLst>
-              <a:gd name="adj" fmla="val 7000"/>
-            </a:avLst>
+            <a:off x="914400" y="2414016"/>
+            <a:ext cx="155448" cy="155448"/>
+          </a:xfrm>
+          <a:prstGeom prst="ellipse">
+            <a:avLst/>
           </a:prstGeom>
           <a:solidFill>
-            <a:srgbClr val="0D1217"/>
+            <a:srgbClr val="62D99A"/>
           </a:solidFill>
-          <a:ln w="12700">
-            <a:solidFill>
-              <a:srgbClr val="2A333D"/>
-            </a:solidFill>
+          <a:ln>
+            <a:noFill/>
           </a:ln>
         </p:spPr>
         <p:style>
@@ -5271,8 +5221,8 @@
         </p:nvSpPr>
         <p:spPr>
           <a:xfrm>
-            <a:off x="594360" y="2788920"/>
-            <a:ext cx="3474720" cy="822960"/>
+            <a:off x="1280160" y="2212848"/>
+            <a:ext cx="10241280" cy="868680"/>
           </a:xfrm>
           <a:prstGeom prst="rect">
             <a:avLst/>
@@ -5285,78 +5235,48 @@
           </a:bodyPr>
           <a:lstStyle/>
           <a:p>
-            <a:pPr algn="ctr"/>
-            <a:r>
-              <a:rPr sz="4400" b="1">
+            <a:pPr algn="l"/>
+            <a:r>
+              <a:rPr sz="2100" b="0">
                 <a:solidFill>
-                  <a:srgbClr val="FF6B35"/>
+                  <a:srgbClr val="F2F4F5"/>
                 </a:solidFill>
                 <a:latin typeface="Inter"/>
               </a:rPr>
-              <a:t>AF</a:t>
-            </a:r>
-          </a:p>
-        </p:txBody>
-      </p:sp>
-      <p:sp>
-        <p:nvSpPr>
-          <p:cNvPr id="7" name="TextBox 6"/>
-          <p:cNvSpPr txBox="1"/>
-          <p:nvPr/>
-        </p:nvSpPr>
-        <p:spPr>
-          <a:xfrm>
-            <a:off x="594360" y="3703320"/>
-            <a:ext cx="3474720" cy="548640"/>
-          </a:xfrm>
-          <a:prstGeom prst="rect">
-            <a:avLst/>
-          </a:prstGeom>
-          <a:noFill/>
-        </p:spPr>
-        <p:txBody>
-          <a:bodyPr wrap="square">
-            <a:spAutoFit/>
-          </a:bodyPr>
-          <a:lstStyle/>
-          <a:p>
-            <a:pPr algn="ctr"/>
-            <a:r>
-              <a:rPr sz="1500" b="0">
+              <a:t>Unet + EfficientNet-B4 · 12 каналов: видимый, тепло, покров, рельеф, погода</a:t>
+            </a:r>
+            <a:r>
+              <a:rPr sz="1400" b="0">
                 <a:solidFill>
-                  <a:srgbClr val="B8C0C8"/>
+                  <a:srgbClr val="7D8690"/>
                 </a:solidFill>
                 <a:latin typeface="Inter"/>
               </a:rPr>
-              <a:t>пиксели горения
-по VIIRS, 375 м</a:t>
-            </a:r>
-          </a:p>
-        </p:txBody>
-      </p:sp>
-      <p:sp>
-        <p:nvSpPr>
-          <p:cNvPr id="8" name="Rounded Rectangle 7"/>
+              <a:t>
+полное обучение за 295 секунд на арендной RTX PRO 4500</a:t>
+            </a:r>
+          </a:p>
+        </p:txBody>
+      </p:sp>
+      <p:sp>
+        <p:nvSpPr>
+          <p:cNvPr id="7" name="Oval 6"/>
           <p:cNvSpPr/>
           <p:nvPr/>
         </p:nvSpPr>
         <p:spPr>
           <a:xfrm>
-            <a:off x="4251960" y="2468880"/>
-            <a:ext cx="3474720" cy="2011680"/>
-          </a:xfrm>
-          <a:prstGeom prst="roundRect">
-            <a:avLst>
-              <a:gd name="adj" fmla="val 7000"/>
-            </a:avLst>
+            <a:off x="914400" y="3557016"/>
+            <a:ext cx="155448" cy="155448"/>
+          </a:xfrm>
+          <a:prstGeom prst="ellipse">
+            <a:avLst/>
           </a:prstGeom>
           <a:solidFill>
-            <a:srgbClr val="0D1217"/>
+            <a:srgbClr val="F2F4F5"/>
           </a:solidFill>
-          <a:ln w="12700">
-            <a:solidFill>
-              <a:srgbClr val="2A333D"/>
-            </a:solidFill>
+          <a:ln>
+            <a:noFill/>
           </a:ln>
         </p:spPr>
         <p:style>
@@ -5383,14 +5303,14 @@
       </p:sp>
       <p:sp>
         <p:nvSpPr>
-          <p:cNvPr id="9" name="TextBox 8"/>
+          <p:cNvPr id="8" name="TextBox 7"/>
           <p:cNvSpPr txBox="1"/>
           <p:nvPr/>
         </p:nvSpPr>
         <p:spPr>
           <a:xfrm>
-            <a:off x="4251960" y="2788920"/>
-            <a:ext cx="3474720" cy="822960"/>
+            <a:off x="1280160" y="3355848"/>
+            <a:ext cx="10241280" cy="868680"/>
           </a:xfrm>
           <a:prstGeom prst="rect">
             <a:avLst/>
@@ -5403,78 +5323,48 @@
           </a:bodyPr>
           <a:lstStyle/>
           <a:p>
-            <a:pPr algn="ctr"/>
-            <a:r>
-              <a:rPr sz="4400" b="1">
+            <a:pPr algn="l"/>
+            <a:r>
+              <a:rPr sz="2100" b="0">
                 <a:solidFill>
-                  <a:srgbClr val="E6C65C"/>
+                  <a:srgbClr val="F2F4F5"/>
                 </a:solidFill>
                 <a:latin typeface="Inter"/>
               </a:rPr>
-              <a:t>BS</a:t>
-            </a:r>
-          </a:p>
-        </p:txBody>
-      </p:sp>
-      <p:sp>
-        <p:nvSpPr>
-          <p:cNvPr id="10" name="TextBox 9"/>
-          <p:cNvSpPr txBox="1"/>
-          <p:nvPr/>
-        </p:nvSpPr>
-        <p:spPr>
-          <a:xfrm>
-            <a:off x="4251960" y="3703320"/>
-            <a:ext cx="3474720" cy="548640"/>
-          </a:xfrm>
-          <a:prstGeom prst="rect">
-            <a:avLst/>
-          </a:prstGeom>
-          <a:noFill/>
-        </p:spPr>
-        <p:txBody>
-          <a:bodyPr wrap="square">
-            <a:spAutoFit/>
-          </a:bodyPr>
-          <a:lstStyle/>
-          <a:p>
-            <a:pPr algn="ctr"/>
-            <a:r>
-              <a:rPr sz="1500" b="0">
+              <a:t>F1 0.8434 · днём 0.85, ночью 0.80</a:t>
+            </a:r>
+            <a:r>
+              <a:rPr sz="1400" b="0">
                 <a:solidFill>
-                  <a:srgbClr val="B8C0C8"/>
+                  <a:srgbClr val="7D8690"/>
                 </a:solidFill>
                 <a:latin typeface="Inter"/>
               </a:rPr>
-              <a:t>контуры + 3 степени
-по Sentinel-2, 20 м</a:t>
-            </a:r>
-          </a:p>
-        </p:txBody>
-      </p:sp>
-      <p:sp>
-        <p:nvSpPr>
-          <p:cNvPr id="11" name="Rounded Rectangle 10"/>
+              <a:t>
+ночью видны только тепловые каналы — отсюда разрыв</a:t>
+            </a:r>
+          </a:p>
+        </p:txBody>
+      </p:sp>
+      <p:sp>
+        <p:nvSpPr>
+          <p:cNvPr id="9" name="Oval 8"/>
           <p:cNvSpPr/>
           <p:nvPr/>
         </p:nvSpPr>
         <p:spPr>
           <a:xfrm>
-            <a:off x="7909560" y="2468880"/>
-            <a:ext cx="3474720" cy="2011680"/>
-          </a:xfrm>
-          <a:prstGeom prst="roundRect">
-            <a:avLst>
-              <a:gd name="adj" fmla="val 7000"/>
-            </a:avLst>
+            <a:off x="914400" y="4700016"/>
+            <a:ext cx="155448" cy="155448"/>
+          </a:xfrm>
+          <a:prstGeom prst="ellipse">
+            <a:avLst/>
           </a:prstGeom>
           <a:solidFill>
-            <a:srgbClr val="0D1217"/>
+            <a:srgbClr val="E6C65C"/>
           </a:solidFill>
-          <a:ln w="12700">
-            <a:solidFill>
-              <a:srgbClr val="2A333D"/>
-            </a:solidFill>
+          <a:ln>
+            <a:noFill/>
           </a:ln>
         </p:spPr>
         <p:style>
@@ -5501,14 +5391,14 @@
       </p:sp>
       <p:sp>
         <p:nvSpPr>
-          <p:cNvPr id="12" name="TextBox 11"/>
+          <p:cNvPr id="10" name="TextBox 9"/>
           <p:cNvSpPr txBox="1"/>
           <p:nvPr/>
         </p:nvSpPr>
         <p:spPr>
           <a:xfrm>
-            <a:off x="7909560" y="2788920"/>
-            <a:ext cx="3474720" cy="822960"/>
+            <a:off x="1280160" y="4498848"/>
+            <a:ext cx="10241280" cy="868680"/>
           </a:xfrm>
           <a:prstGeom prst="rect">
             <a:avLst/>
@@ -5521,90 +5411,53 @@
           </a:bodyPr>
           <a:lstStyle/>
           <a:p>
-            <a:pPr algn="ctr"/>
-            <a:r>
-              <a:rPr sz="4400" b="1">
+            <a:pPr algn="l"/>
+            <a:r>
+              <a:rPr sz="2100" b="0">
                 <a:solidFill>
-                  <a:srgbClr val="62D99A"/>
+                  <a:srgbClr val="F2F4F5"/>
                 </a:solidFill>
                 <a:latin typeface="Inter"/>
               </a:rPr>
-              <a:t>API</a:t>
-            </a:r>
-          </a:p>
-        </p:txBody>
-      </p:sp>
-      <p:sp>
-        <p:nvSpPr>
-          <p:cNvPr id="13" name="TextBox 12"/>
-          <p:cNvSpPr txBox="1"/>
-          <p:nvPr/>
-        </p:nvSpPr>
-        <p:spPr>
-          <a:xfrm>
-            <a:off x="7909560" y="3703320"/>
-            <a:ext cx="3474720" cy="548640"/>
-          </a:xfrm>
-          <a:prstGeom prst="rect">
-            <a:avLst/>
-          </a:prstGeom>
-          <a:noFill/>
-        </p:spPr>
-        <p:txBody>
-          <a:bodyPr wrap="square">
-            <a:spAutoFit/>
-          </a:bodyPr>
-          <a:lstStyle/>
-          <a:p>
-            <a:pPr algn="ctr"/>
-            <a:r>
-              <a:rPr sz="1500" b="0">
-                <a:solidFill>
-                  <a:srgbClr val="B8C0C8"/>
-                </a:solidFill>
-                <a:latin typeface="Inter"/>
-              </a:rPr>
-              <a:t>карта + справка
-по запросу</a:t>
-            </a:r>
-          </a:p>
-        </p:txBody>
-      </p:sp>
-      <p:sp>
-        <p:nvSpPr>
-          <p:cNvPr id="14" name="TextBox 13"/>
-          <p:cNvSpPr txBox="1"/>
-          <p:nvPr/>
-        </p:nvSpPr>
-        <p:spPr>
-          <a:xfrm>
-            <a:off x="640080" y="5120640"/>
-            <a:ext cx="10881360" cy="640080"/>
-          </a:xfrm>
-          <a:prstGeom prst="rect">
-            <a:avLst/>
-          </a:prstGeom>
-          <a:noFill/>
-        </p:spPr>
-        <p:txBody>
-          <a:bodyPr wrap="square">
-            <a:spAutoFit/>
-          </a:bodyPr>
-          <a:lstStyle/>
-          <a:p>
-            <a:pPr algn="ctr"/>
-            <a:r>
-              <a:rPr sz="1800" b="0">
+              <a:t>Факелы от пожаров на одном снимке неотличимы</a:t>
+            </a:r>
+            <a:r>
+              <a:rPr sz="1400" b="0">
                 <a:solidFill>
                   <a:srgbClr val="7D8690"/>
                 </a:solidFill>
                 <a:latin typeface="Inter"/>
               </a:rPr>
-              <a:t>Плюс единый submission.csv на 447 строк и воспроизводимый запуск одной командой</a:t>
-            </a:r>
-          </a:p>
-        </p:txBody>
-      </p:sp>
+              <a:t>
+давим их контекстом застройки и историей — честно пишем в отчёт</a:t>
+            </a:r>
+          </a:p>
+        </p:txBody>
+      </p:sp>
+      <p:pic>
+        <p:nvPicPr>
+          <p:cNvPr id="11" name="Picture 10" descr="af_viz_sample.png"/>
+          <p:cNvPicPr>
+            <a:picLocks noChangeAspect="1"/>
+          </p:cNvPicPr>
+          <p:nvPr/>
+        </p:nvPicPr>
+        <p:blipFill>
+          <a:blip r:embed="rId2"/>
+          <a:stretch>
+            <a:fillRect/>
+          </a:stretch>
+        </p:blipFill>
+        <p:spPr>
+          <a:xfrm>
+            <a:off x="9144000" y="4480560"/>
+            <a:ext cx="2377440" cy="792480"/>
+          </a:xfrm>
+          <a:prstGeom prst="rect">
+            <a:avLst/>
+          </a:prstGeom>
+        </p:spPr>
+      </p:pic>
     </p:spTree>
   </p:cSld>
   <p:clrMapOvr>
@@ -5640,7 +5493,7 @@
         <p:spPr>
           <a:xfrm>
             <a:off x="640080" y="274320"/>
-            <a:ext cx="4572000" cy="365760"/>
+            <a:ext cx="10881360" cy="365760"/>
           </a:xfrm>
           <a:prstGeom prst="rect">
             <a:avLst/>
@@ -5654,15 +5507,6 @@
           <a:lstStyle/>
           <a:p>
             <a:pPr algn="l"/>
-            <a:r>
-              <a:rPr sz="1200" b="1">
-                <a:solidFill>
-                  <a:srgbClr val="7D8690"/>
-                </a:solidFill>
-                <a:latin typeface="Inter"/>
-              </a:rPr>
-              <a:t>04 / 10   </a:t>
-            </a:r>
             <a:r>
               <a:rPr sz="1200" b="1">
                 <a:solidFill>
@@ -5683,7 +5527,7 @@
         </p:nvSpPr>
         <p:spPr>
           <a:xfrm>
-            <a:off x="11612880" y="384048"/>
+            <a:off x="11658600" y="384048"/>
             <a:ext cx="128016" cy="128016"/>
           </a:xfrm>
           <a:prstGeom prst="ellipse">
@@ -5726,8 +5570,8 @@
         </p:nvSpPr>
         <p:spPr>
           <a:xfrm>
-            <a:off x="640080" y="822960"/>
-            <a:ext cx="10881360" cy="1188720"/>
+            <a:off x="640080" y="777240"/>
+            <a:ext cx="10881360" cy="1097280"/>
           </a:xfrm>
           <a:prstGeom prst="rect">
             <a:avLst/>
@@ -5742,40 +5586,36 @@
           <a:p>
             <a:pPr algn="l"/>
             <a:r>
-              <a:rPr sz="4000" b="1">
+              <a:rPr sz="3800" b="1">
                 <a:solidFill>
                   <a:srgbClr val="F2F4F5"/>
                 </a:solidFill>
                 <a:latin typeface="Inter"/>
               </a:rPr>
-              <a:t>Подход: две сегментации + строгий протокол</a:t>
-            </a:r>
-          </a:p>
-        </p:txBody>
-      </p:sp>
-      <p:sp>
-        <p:nvSpPr>
-          <p:cNvPr id="5" name="Rounded Rectangle 4"/>
+              <a:t>Гари: похоронили гиганта, выиграл трудяга</a:t>
+            </a:r>
+          </a:p>
+        </p:txBody>
+      </p:sp>
+      <p:sp>
+        <p:nvSpPr>
+          <p:cNvPr id="5" name="Oval 4"/>
           <p:cNvSpPr/>
           <p:nvPr/>
         </p:nvSpPr>
         <p:spPr>
           <a:xfrm>
-            <a:off x="594360" y="2468880"/>
-            <a:ext cx="2011680" cy="1554480"/>
-          </a:xfrm>
-          <a:prstGeom prst="roundRect">
-            <a:avLst>
-              <a:gd name="adj" fmla="val 7000"/>
-            </a:avLst>
+            <a:off x="914400" y="2414016"/>
+            <a:ext cx="155448" cy="155448"/>
+          </a:xfrm>
+          <a:prstGeom prst="ellipse">
+            <a:avLst/>
           </a:prstGeom>
           <a:solidFill>
-            <a:srgbClr val="0D1217"/>
+            <a:srgbClr val="EF5B5B"/>
           </a:solidFill>
-          <a:ln w="12700">
-            <a:solidFill>
-              <a:srgbClr val="2A333D"/>
-            </a:solidFill>
+          <a:ln>
+            <a:noFill/>
           </a:ln>
         </p:spPr>
         <p:style>
@@ -5808,8 +5648,8 @@
         </p:nvSpPr>
         <p:spPr>
           <a:xfrm>
-            <a:off x="594360" y="2743200"/>
-            <a:ext cx="2011680" cy="1097280"/>
+            <a:off x="1280160" y="2212848"/>
+            <a:ext cx="10241280" cy="868680"/>
           </a:xfrm>
           <a:prstGeom prst="rect">
             <a:avLst/>
@@ -5822,78 +5662,48 @@
           </a:bodyPr>
           <a:lstStyle/>
           <a:p>
-            <a:pPr algn="ctr"/>
-            <a:r>
-              <a:rPr sz="1900" b="1">
+            <a:pPr algn="l"/>
+            <a:r>
+              <a:rPr sz="2100" b="0">
                 <a:solidFill>
                   <a:srgbClr val="F2F4F5"/>
                 </a:solidFill>
                 <a:latin typeface="Inter"/>
               </a:rPr>
-              <a:t>VIIRS
-AF Unet</a:t>
-            </a:r>
-          </a:p>
-        </p:txBody>
-      </p:sp>
-      <p:sp>
-        <p:nvSpPr>
-          <p:cNvPr id="7" name="TextBox 6"/>
-          <p:cNvSpPr txBox="1"/>
-          <p:nvPr/>
-        </p:nvSpPr>
-        <p:spPr>
-          <a:xfrm>
-            <a:off x="2606040" y="2971800"/>
-            <a:ext cx="365760" cy="457200"/>
-          </a:xfrm>
-          <a:prstGeom prst="rect">
-            <a:avLst/>
-          </a:prstGeom>
-          <a:noFill/>
-        </p:spPr>
-        <p:txBody>
-          <a:bodyPr wrap="square">
-            <a:spAutoFit/>
-          </a:bodyPr>
-          <a:lstStyle/>
-          <a:p>
-            <a:pPr algn="ctr"/>
-            <a:r>
-              <a:rPr sz="2600" b="0">
+              <a:t>Prithvi-300M сдох: IoU 0.16 — хуже тупого бейзлайна плюс nan-лосс</a:t>
+            </a:r>
+            <a:r>
+              <a:rPr sz="1400" b="0">
                 <a:solidFill>
-                  <a:srgbClr val="FF6B35"/>
+                  <a:srgbClr val="7D8690"/>
                 </a:solidFill>
                 <a:latin typeface="Inter"/>
               </a:rPr>
-              <a:t>→</a:t>
-            </a:r>
-          </a:p>
-        </p:txBody>
-      </p:sp>
-      <p:sp>
-        <p:nvSpPr>
-          <p:cNvPr id="8" name="Rounded Rectangle 7"/>
+              <a:t>
+закрыли ветку без сантиментов</a:t>
+            </a:r>
+          </a:p>
+        </p:txBody>
+      </p:sp>
+      <p:sp>
+        <p:nvSpPr>
+          <p:cNvPr id="7" name="Oval 6"/>
           <p:cNvSpPr/>
           <p:nvPr/>
         </p:nvSpPr>
         <p:spPr>
           <a:xfrm>
-            <a:off x="2926079" y="2468880"/>
-            <a:ext cx="2011680" cy="1554480"/>
-          </a:xfrm>
-          <a:prstGeom prst="roundRect">
-            <a:avLst>
-              <a:gd name="adj" fmla="val 7000"/>
-            </a:avLst>
+            <a:off x="914400" y="3557016"/>
+            <a:ext cx="155448" cy="155448"/>
+          </a:xfrm>
+          <a:prstGeom prst="ellipse">
+            <a:avLst/>
           </a:prstGeom>
           <a:solidFill>
-            <a:srgbClr val="0D1217"/>
+            <a:srgbClr val="62D99A"/>
           </a:solidFill>
-          <a:ln w="12700">
-            <a:solidFill>
-              <a:srgbClr val="2A333D"/>
-            </a:solidFill>
+          <a:ln>
+            <a:noFill/>
           </a:ln>
         </p:spPr>
         <p:style>
@@ -5920,14 +5730,14 @@
       </p:sp>
       <p:sp>
         <p:nvSpPr>
-          <p:cNvPr id="9" name="TextBox 8"/>
+          <p:cNvPr id="8" name="TextBox 7"/>
           <p:cNvSpPr txBox="1"/>
           <p:nvPr/>
         </p:nvSpPr>
         <p:spPr>
           <a:xfrm>
-            <a:off x="2926079" y="2743200"/>
-            <a:ext cx="2011680" cy="1097280"/>
+            <a:off x="1280160" y="3355848"/>
+            <a:ext cx="10241280" cy="868680"/>
           </a:xfrm>
           <a:prstGeom prst="rect">
             <a:avLst/>
@@ -5940,78 +5750,48 @@
           </a:bodyPr>
           <a:lstStyle/>
           <a:p>
-            <a:pPr algn="ctr"/>
-            <a:r>
-              <a:rPr sz="1900" b="1">
+            <a:pPr algn="l"/>
+            <a:r>
+              <a:rPr sz="2100" b="0">
                 <a:solidFill>
                   <a:srgbClr val="F2F4F5"/>
                 </a:solidFill>
                 <a:latin typeface="Inter"/>
               </a:rPr>
-              <a:t>Sentinel
-BS Unet</a:t>
-            </a:r>
-          </a:p>
-        </p:txBody>
-      </p:sp>
-      <p:sp>
-        <p:nvSpPr>
-          <p:cNvPr id="10" name="TextBox 9"/>
-          <p:cNvSpPr txBox="1"/>
-          <p:nvPr/>
-        </p:nvSpPr>
-        <p:spPr>
-          <a:xfrm>
-            <a:off x="4937760" y="2971800"/>
-            <a:ext cx="365760" cy="457200"/>
-          </a:xfrm>
-          <a:prstGeom prst="rect">
-            <a:avLst/>
-          </a:prstGeom>
-          <a:noFill/>
-        </p:spPr>
-        <p:txBody>
-          <a:bodyPr wrap="square">
-            <a:spAutoFit/>
-          </a:bodyPr>
-          <a:lstStyle/>
-          <a:p>
-            <a:pPr algn="ctr"/>
-            <a:r>
-              <a:rPr sz="2600" b="0">
+              <a:t>Обычный Unet выиграл: IoU 0.52 · mIoU 0.54</a:t>
+            </a:r>
+            <a:r>
+              <a:rPr sz="1400" b="0">
                 <a:solidFill>
-                  <a:srgbClr val="FF6B35"/>
+                  <a:srgbClr val="7D8690"/>
                 </a:solidFill>
                 <a:latin typeface="Inter"/>
               </a:rPr>
-              <a:t>→</a:t>
-            </a:r>
-          </a:p>
-        </p:txBody>
-      </p:sp>
-      <p:sp>
-        <p:nvSpPr>
-          <p:cNvPr id="11" name="Rounded Rectangle 10"/>
+              <a:t>
+27 каналов, 91 эпоха — фриз, который сдаём</a:t>
+            </a:r>
+          </a:p>
+        </p:txBody>
+      </p:sp>
+      <p:sp>
+        <p:nvSpPr>
+          <p:cNvPr id="9" name="Oval 8"/>
           <p:cNvSpPr/>
           <p:nvPr/>
         </p:nvSpPr>
         <p:spPr>
           <a:xfrm>
-            <a:off x="5257800" y="2468880"/>
-            <a:ext cx="2011680" cy="1554480"/>
-          </a:xfrm>
-          <a:prstGeom prst="roundRect">
-            <a:avLst>
-              <a:gd name="adj" fmla="val 7000"/>
-            </a:avLst>
+            <a:off x="914400" y="4700016"/>
+            <a:ext cx="155448" cy="155448"/>
+          </a:xfrm>
+          <a:prstGeom prst="ellipse">
+            <a:avLst/>
           </a:prstGeom>
           <a:solidFill>
-            <a:srgbClr val="0D1217"/>
+            <a:srgbClr val="FF6B35"/>
           </a:solidFill>
-          <a:ln w="12700">
-            <a:solidFill>
-              <a:srgbClr val="2A333D"/>
-            </a:solidFill>
+          <a:ln>
+            <a:noFill/>
           </a:ln>
         </p:spPr>
         <p:style>
@@ -6038,14 +5818,14 @@
       </p:sp>
       <p:sp>
         <p:nvSpPr>
-          <p:cNvPr id="12" name="TextBox 11"/>
+          <p:cNvPr id="10" name="TextBox 9"/>
           <p:cNvSpPr txBox="1"/>
           <p:nvPr/>
         </p:nvSpPr>
         <p:spPr>
           <a:xfrm>
-            <a:off x="5257800" y="2743200"/>
-            <a:ext cx="2011680" cy="1097280"/>
+            <a:off x="1280160" y="4498848"/>
+            <a:ext cx="10241280" cy="868680"/>
           </a:xfrm>
           <a:prstGeom prst="rect">
             <a:avLst/>
@@ -6058,287 +5838,25 @@
           </a:bodyPr>
           <a:lstStyle/>
           <a:p>
-            <a:pPr algn="ctr"/>
-            <a:r>
-              <a:rPr sz="1900" b="1">
+            <a:pPr algn="l"/>
+            <a:r>
+              <a:rPr sz="2100" b="0">
                 <a:solidFill>
                   <a:srgbClr val="F2F4F5"/>
                 </a:solidFill>
                 <a:latin typeface="Inter"/>
               </a:rPr>
-              <a:t>inference
-детерминирован</a:t>
-            </a:r>
-          </a:p>
-        </p:txBody>
-      </p:sp>
-      <p:sp>
-        <p:nvSpPr>
-          <p:cNvPr id="13" name="TextBox 12"/>
-          <p:cNvSpPr txBox="1"/>
-          <p:nvPr/>
-        </p:nvSpPr>
-        <p:spPr>
-          <a:xfrm>
-            <a:off x="7269479" y="2971800"/>
-            <a:ext cx="365760" cy="457200"/>
-          </a:xfrm>
-          <a:prstGeom prst="rect">
-            <a:avLst/>
-          </a:prstGeom>
-          <a:noFill/>
-        </p:spPr>
-        <p:txBody>
-          <a:bodyPr wrap="square">
-            <a:spAutoFit/>
-          </a:bodyPr>
-          <a:lstStyle/>
-          <a:p>
-            <a:pPr algn="ctr"/>
-            <a:r>
-              <a:rPr sz="2600" b="0">
-                <a:solidFill>
-                  <a:srgbClr val="FF6B35"/>
-                </a:solidFill>
-                <a:latin typeface="Inter"/>
-              </a:rPr>
-              <a:t>→</a:t>
-            </a:r>
-          </a:p>
-        </p:txBody>
-      </p:sp>
-      <p:sp>
-        <p:nvSpPr>
-          <p:cNvPr id="14" name="Rounded Rectangle 13"/>
-          <p:cNvSpPr/>
-          <p:nvPr/>
-        </p:nvSpPr>
-        <p:spPr>
-          <a:xfrm>
-            <a:off x="7589519" y="2468880"/>
-            <a:ext cx="2011680" cy="1554480"/>
-          </a:xfrm>
-          <a:prstGeom prst="roundRect">
-            <a:avLst>
-              <a:gd name="adj" fmla="val 7000"/>
-            </a:avLst>
-          </a:prstGeom>
-          <a:solidFill>
-            <a:srgbClr val="0D1217"/>
-          </a:solidFill>
-          <a:ln w="12700">
-            <a:solidFill>
-              <a:srgbClr val="2A333D"/>
-            </a:solidFill>
-          </a:ln>
-        </p:spPr>
-        <p:style>
-          <a:lnRef idx="1">
-            <a:schemeClr val="accent1"/>
-          </a:lnRef>
-          <a:fillRef idx="3">
-            <a:schemeClr val="accent1"/>
-          </a:fillRef>
-          <a:effectRef idx="2">
-            <a:schemeClr val="accent1"/>
-          </a:effectRef>
-          <a:fontRef idx="minor">
-            <a:schemeClr val="lt1"/>
-          </a:fontRef>
-        </p:style>
-        <p:txBody>
-          <a:bodyPr rtlCol="0" anchor="ctr"/>
-          <a:lstStyle/>
-          <a:p>
-            <a:pPr algn="ctr"/>
-          </a:p>
-        </p:txBody>
-      </p:sp>
-      <p:sp>
-        <p:nvSpPr>
-          <p:cNvPr id="15" name="TextBox 14"/>
-          <p:cNvSpPr txBox="1"/>
-          <p:nvPr/>
-        </p:nvSpPr>
-        <p:spPr>
-          <a:xfrm>
-            <a:off x="7589519" y="2743200"/>
-            <a:ext cx="2011680" cy="1097280"/>
-          </a:xfrm>
-          <a:prstGeom prst="rect">
-            <a:avLst/>
-          </a:prstGeom>
-          <a:noFill/>
-        </p:spPr>
-        <p:txBody>
-          <a:bodyPr wrap="square">
-            <a:spAutoFit/>
-          </a:bodyPr>
-          <a:lstStyle/>
-          <a:p>
-            <a:pPr algn="ctr"/>
-            <a:r>
-              <a:rPr sz="1900" b="1">
-                <a:solidFill>
-                  <a:srgbClr val="F2F4F5"/>
-                </a:solidFill>
-                <a:latin typeface="Inter"/>
-              </a:rPr>
-              <a:t>submission
-447 строк</a:t>
-            </a:r>
-          </a:p>
-        </p:txBody>
-      </p:sp>
-      <p:sp>
-        <p:nvSpPr>
-          <p:cNvPr id="16" name="TextBox 15"/>
-          <p:cNvSpPr txBox="1"/>
-          <p:nvPr/>
-        </p:nvSpPr>
-        <p:spPr>
-          <a:xfrm>
-            <a:off x="9601200" y="2971800"/>
-            <a:ext cx="365760" cy="457200"/>
-          </a:xfrm>
-          <a:prstGeom prst="rect">
-            <a:avLst/>
-          </a:prstGeom>
-          <a:noFill/>
-        </p:spPr>
-        <p:txBody>
-          <a:bodyPr wrap="square">
-            <a:spAutoFit/>
-          </a:bodyPr>
-          <a:lstStyle/>
-          <a:p>
-            <a:pPr algn="ctr"/>
-            <a:r>
-              <a:rPr sz="2600" b="0">
-                <a:solidFill>
-                  <a:srgbClr val="FF6B35"/>
-                </a:solidFill>
-                <a:latin typeface="Inter"/>
-              </a:rPr>
-              <a:t>→</a:t>
-            </a:r>
-          </a:p>
-        </p:txBody>
-      </p:sp>
-      <p:sp>
-        <p:nvSpPr>
-          <p:cNvPr id="17" name="Rounded Rectangle 16"/>
-          <p:cNvSpPr/>
-          <p:nvPr/>
-        </p:nvSpPr>
-        <p:spPr>
-          <a:xfrm>
-            <a:off x="9921240" y="2468880"/>
-            <a:ext cx="2011680" cy="1554480"/>
-          </a:xfrm>
-          <a:prstGeom prst="roundRect">
-            <a:avLst>
-              <a:gd name="adj" fmla="val 7000"/>
-            </a:avLst>
-          </a:prstGeom>
-          <a:solidFill>
-            <a:srgbClr val="0D1217"/>
-          </a:solidFill>
-          <a:ln w="12700">
-            <a:solidFill>
-              <a:srgbClr val="2A333D"/>
-            </a:solidFill>
-          </a:ln>
-        </p:spPr>
-        <p:style>
-          <a:lnRef idx="1">
-            <a:schemeClr val="accent1"/>
-          </a:lnRef>
-          <a:fillRef idx="3">
-            <a:schemeClr val="accent1"/>
-          </a:fillRef>
-          <a:effectRef idx="2">
-            <a:schemeClr val="accent1"/>
-          </a:effectRef>
-          <a:fontRef idx="minor">
-            <a:schemeClr val="lt1"/>
-          </a:fontRef>
-        </p:style>
-        <p:txBody>
-          <a:bodyPr rtlCol="0" anchor="ctr"/>
-          <a:lstStyle/>
-          <a:p>
-            <a:pPr algn="ctr"/>
-          </a:p>
-        </p:txBody>
-      </p:sp>
-      <p:sp>
-        <p:nvSpPr>
-          <p:cNvPr id="18" name="TextBox 17"/>
-          <p:cNvSpPr txBox="1"/>
-          <p:nvPr/>
-        </p:nvSpPr>
-        <p:spPr>
-          <a:xfrm>
-            <a:off x="9921240" y="2743200"/>
-            <a:ext cx="2011680" cy="1097280"/>
-          </a:xfrm>
-          <a:prstGeom prst="rect">
-            <a:avLst/>
-          </a:prstGeom>
-          <a:noFill/>
-        </p:spPr>
-        <p:txBody>
-          <a:bodyPr wrap="square">
-            <a:spAutoFit/>
-          </a:bodyPr>
-          <a:lstStyle/>
-          <a:p>
-            <a:pPr algn="ctr"/>
-            <a:r>
-              <a:rPr sz="1900" b="1">
-                <a:solidFill>
-                  <a:srgbClr val="F2F4F5"/>
-                </a:solidFill>
-                <a:latin typeface="Inter"/>
-              </a:rPr>
-              <a:t>сервис
-карта + API</a:t>
-            </a:r>
-          </a:p>
-        </p:txBody>
-      </p:sp>
-      <p:sp>
-        <p:nvSpPr>
-          <p:cNvPr id="19" name="TextBox 18"/>
-          <p:cNvSpPr txBox="1"/>
-          <p:nvPr/>
-        </p:nvSpPr>
-        <p:spPr>
-          <a:xfrm>
-            <a:off x="640080" y="4572000"/>
-            <a:ext cx="10881360" cy="1280160"/>
-          </a:xfrm>
-          <a:prstGeom prst="rect">
-            <a:avLst/>
-          </a:prstGeom>
-          <a:noFill/>
-        </p:spPr>
-        <p:txBody>
-          <a:bodyPr wrap="square">
-            <a:spAutoFit/>
-          </a:bodyPr>
-          <a:lstStyle/>
-          <a:p>
-            <a:pPr algn="ctr"/>
-            <a:r>
-              <a:rPr sz="1800" b="0">
+              <a:t>Две добивки проиграли фризу (0.62 и 0.63 против 0.65)</a:t>
+            </a:r>
+            <a:r>
+              <a:rPr sz="1400" b="0">
                 <a:solidFill>
                   <a:srgbClr val="7D8690"/>
                 </a:solidFill>
                 <a:latin typeface="Inter"/>
               </a:rPr>
-              <a:t>Сплит по очагам без утечек · сиды 19 · тест де-идентифицирован — гео не восстанавливаем</a:t>
+              <a:t>
+поэтому сдаём проверенное, а не последнее</a:t>
             </a:r>
           </a:p>
         </p:txBody>
@@ -6378,7 +5896,7 @@
         <p:spPr>
           <a:xfrm>
             <a:off x="640080" y="274320"/>
-            <a:ext cx="4572000" cy="365760"/>
+            <a:ext cx="10881360" cy="365760"/>
           </a:xfrm>
           <a:prstGeom prst="rect">
             <a:avLst/>
@@ -6392,15 +5910,6 @@
           <a:lstStyle/>
           <a:p>
             <a:pPr algn="l"/>
-            <a:r>
-              <a:rPr sz="1200" b="1">
-                <a:solidFill>
-                  <a:srgbClr val="7D8690"/>
-                </a:solidFill>
-                <a:latin typeface="Inter"/>
-              </a:rPr>
-              <a:t>05 / 10   </a:t>
-            </a:r>
             <a:r>
               <a:rPr sz="1200" b="1">
                 <a:solidFill>
@@ -6421,7 +5930,7 @@
         </p:nvSpPr>
         <p:spPr>
           <a:xfrm>
-            <a:off x="11612880" y="384048"/>
+            <a:off x="11658600" y="384048"/>
             <a:ext cx="128016" cy="128016"/>
           </a:xfrm>
           <a:prstGeom prst="ellipse">
@@ -6464,8 +5973,8 @@
         </p:nvSpPr>
         <p:spPr>
           <a:xfrm>
-            <a:off x="640080" y="822960"/>
-            <a:ext cx="10881360" cy="1188720"/>
+            <a:off x="640080" y="777240"/>
+            <a:ext cx="10881360" cy="1097280"/>
           </a:xfrm>
           <a:prstGeom prst="rect">
             <a:avLst/>
@@ -6480,36 +5989,40 @@
           <a:p>
             <a:pPr algn="l"/>
             <a:r>
-              <a:rPr sz="4000" b="1">
+              <a:rPr sz="3800" b="1">
                 <a:solidFill>
                   <a:srgbClr val="F2F4F5"/>
                 </a:solidFill>
                 <a:latin typeface="Inter"/>
               </a:rPr>
-              <a:t>Горение находим: F1 0.8434</a:t>
-            </a:r>
-          </a:p>
-        </p:txBody>
-      </p:sp>
-      <p:sp>
-        <p:nvSpPr>
-          <p:cNvPr id="5" name="Oval 4"/>
+              <a:t>Итог: 0.654 — честные</a:t>
+            </a:r>
+          </a:p>
+        </p:txBody>
+      </p:sp>
+      <p:sp>
+        <p:nvSpPr>
+          <p:cNvPr id="5" name="Rounded Rectangle 4"/>
           <p:cNvSpPr/>
           <p:nvPr/>
         </p:nvSpPr>
         <p:spPr>
           <a:xfrm>
-            <a:off x="914400" y="2596896"/>
-            <a:ext cx="155448" cy="155448"/>
-          </a:xfrm>
-          <a:prstGeom prst="ellipse">
-            <a:avLst/>
+            <a:off x="640080" y="2194560"/>
+            <a:ext cx="10881360" cy="1463040"/>
+          </a:xfrm>
+          <a:prstGeom prst="roundRect">
+            <a:avLst>
+              <a:gd name="adj" fmla="val 7000"/>
+            </a:avLst>
           </a:prstGeom>
           <a:solidFill>
-            <a:srgbClr val="62D99A"/>
+            <a:srgbClr val="0D1217"/>
           </a:solidFill>
-          <a:ln>
-            <a:noFill/>
+          <a:ln w="12700">
+            <a:solidFill>
+              <a:srgbClr val="2A333D"/>
+            </a:solidFill>
           </a:ln>
         </p:spPr>
         <p:style>
@@ -6542,8 +6055,8 @@
         </p:nvSpPr>
         <p:spPr>
           <a:xfrm>
-            <a:off x="1280160" y="2395728"/>
-            <a:ext cx="10332720" cy="822960"/>
+            <a:off x="914400" y="2377440"/>
+            <a:ext cx="10332720" cy="1097280"/>
           </a:xfrm>
           <a:prstGeom prst="rect">
             <a:avLst/>
@@ -6558,13 +6071,13 @@
           <a:p>
             <a:pPr algn="l"/>
             <a:r>
-              <a:rPr sz="2100" b="0">
+              <a:rPr sz="2700" b="1">
                 <a:solidFill>
                   <a:srgbClr val="F2F4F5"/>
                 </a:solidFill>
                 <a:latin typeface="Inter"/>
               </a:rPr>
-              <a:t>12 каналов: видимый + I4 + разность I4−I5 + покров, рельеф, метео</a:t>
+              <a:t>0.35 × 0.8434  +  0.35 × 0.5239  +  0.30 × 0.5430  =  0.654</a:t>
             </a:r>
             <a:r>
               <a:rPr sz="1500" b="0">
@@ -6574,7 +6087,7 @@
                 <a:latin typeface="Inter"/>
               </a:rPr>
               <a:t>
-Unet + EfficientNet-B4 · обучение — 5 минут</a:t>
+447 строк · RLE валиден · два прогона идентичны · md5 зафиксирован</a:t>
             </a:r>
           </a:p>
         </p:txBody>
@@ -6587,14 +6100,14 @@
         </p:nvSpPr>
         <p:spPr>
           <a:xfrm>
-            <a:off x="914400" y="3602736"/>
+            <a:off x="914400" y="4334255"/>
             <a:ext cx="155448" cy="155448"/>
           </a:xfrm>
           <a:prstGeom prst="ellipse">
             <a:avLst/>
           </a:prstGeom>
           <a:solidFill>
-            <a:srgbClr val="F2F4F5"/>
+            <a:srgbClr val="62D99A"/>
           </a:solidFill>
           <a:ln>
             <a:noFill/>
@@ -6630,8 +6143,8 @@
         </p:nvSpPr>
         <p:spPr>
           <a:xfrm>
-            <a:off x="1280160" y="3401568"/>
-            <a:ext cx="10332720" cy="822960"/>
+            <a:off x="1280160" y="4133087"/>
+            <a:ext cx="10241280" cy="868680"/>
           </a:xfrm>
           <a:prstGeom prst="rect">
             <a:avLst/>
@@ -6646,139 +6159,27 @@
           <a:p>
             <a:pPr algn="l"/>
             <a:r>
-              <a:rPr sz="2100" b="0">
+              <a:rPr sz="1900" b="0">
                 <a:solidFill>
                   <a:srgbClr val="F2F4F5"/>
                 </a:solidFill>
                 <a:latin typeface="Inter"/>
               </a:rPr>
-              <a:t>Порог 0.15 + фильтр застройки</a:t>
-            </a:r>
-            <a:r>
-              <a:rPr sz="1500" b="0">
+              <a:t>Файл примут с первого раза</a:t>
+            </a:r>
+            <a:r>
+              <a:rPr sz="1400" b="0">
                 <a:solidFill>
                   <a:srgbClr val="7D8690"/>
                 </a:solidFill>
                 <a:latin typeface="Inter"/>
               </a:rPr>
               <a:t>
-день 0.85 · ночь 0.80</a:t>
-            </a:r>
-          </a:p>
-        </p:txBody>
-      </p:sp>
-      <p:sp>
-        <p:nvSpPr>
-          <p:cNvPr id="9" name="Oval 8"/>
-          <p:cNvSpPr/>
-          <p:nvPr/>
-        </p:nvSpPr>
-        <p:spPr>
-          <a:xfrm>
-            <a:off x="914400" y="4608576"/>
-            <a:ext cx="155448" cy="155448"/>
-          </a:xfrm>
-          <a:prstGeom prst="ellipse">
-            <a:avLst/>
-          </a:prstGeom>
-          <a:solidFill>
-            <a:srgbClr val="E6C65C"/>
-          </a:solidFill>
-          <a:ln>
-            <a:noFill/>
-          </a:ln>
-        </p:spPr>
-        <p:style>
-          <a:lnRef idx="1">
-            <a:schemeClr val="accent1"/>
-          </a:lnRef>
-          <a:fillRef idx="3">
-            <a:schemeClr val="accent1"/>
-          </a:fillRef>
-          <a:effectRef idx="2">
-            <a:schemeClr val="accent1"/>
-          </a:effectRef>
-          <a:fontRef idx="minor">
-            <a:schemeClr val="lt1"/>
-          </a:fontRef>
-        </p:style>
-        <p:txBody>
-          <a:bodyPr rtlCol="0" anchor="ctr"/>
-          <a:lstStyle/>
-          <a:p>
-            <a:pPr algn="ctr"/>
-          </a:p>
-        </p:txBody>
-      </p:sp>
-      <p:sp>
-        <p:nvSpPr>
-          <p:cNvPr id="10" name="TextBox 9"/>
-          <p:cNvSpPr txBox="1"/>
-          <p:nvPr/>
-        </p:nvSpPr>
-        <p:spPr>
-          <a:xfrm>
-            <a:off x="1280160" y="4407408"/>
-            <a:ext cx="10332720" cy="822960"/>
-          </a:xfrm>
-          <a:prstGeom prst="rect">
-            <a:avLst/>
-          </a:prstGeom>
-          <a:noFill/>
-        </p:spPr>
-        <p:txBody>
-          <a:bodyPr wrap="square">
-            <a:spAutoFit/>
-          </a:bodyPr>
-          <a:lstStyle/>
-          <a:p>
-            <a:pPr algn="l"/>
-            <a:r>
-              <a:rPr sz="2100" b="0">
-                <a:solidFill>
-                  <a:srgbClr val="F2F4F5"/>
-                </a:solidFill>
-                <a:latin typeface="Inter"/>
-              </a:rPr>
-              <a:t>Ограничение признаём</a:t>
-            </a:r>
-            <a:r>
-              <a:rPr sz="1500" b="0">
-                <a:solidFill>
-                  <a:srgbClr val="7D8690"/>
-                </a:solidFill>
-                <a:latin typeface="Inter"/>
-              </a:rPr>
-              <a:t>
-факел на одном снимке неотличим от пожара — нужна история</a:t>
-            </a:r>
-          </a:p>
-        </p:txBody>
-      </p:sp>
-      <p:pic>
-        <p:nvPicPr>
-          <p:cNvPr id="11" name="Picture 10" descr="af_viz_sample.png"/>
-          <p:cNvPicPr>
-            <a:picLocks noChangeAspect="1"/>
-          </p:cNvPicPr>
-          <p:nvPr/>
-        </p:nvPicPr>
-        <p:blipFill>
-          <a:blip r:embed="rId2"/>
-          <a:stretch>
-            <a:fillRect/>
-          </a:stretch>
-        </p:blipFill>
-        <p:spPr>
-          <a:xfrm>
-            <a:off x="8412480" y="2377440"/>
-            <a:ext cx="3108960" cy="1036320"/>
-          </a:xfrm>
-          <a:prstGeom prst="rect">
-            <a:avLst/>
-          </a:prstGeom>
-        </p:spPr>
-      </p:pic>
+пары совпадают с шаблоном, NaN ноль, пересечений ноль</a:t>
+            </a:r>
+          </a:p>
+        </p:txBody>
+      </p:sp>
     </p:spTree>
   </p:cSld>
   <p:clrMapOvr>
@@ -6788,814 +6189,6 @@
 </file>
 
 <file path=ppt/slides/slide6.xml><?xml version="1.0" encoding="utf-8"?>
-<p:sld xmlns:a="http://schemas.openxmlformats.org/drawingml/2006/main" xmlns:p="http://schemas.openxmlformats.org/presentationml/2006/main" xmlns:r="http://schemas.openxmlformats.org/officeDocument/2006/relationships">
-  <p:cSld>
-    <p:bg>
-      <p:bgPr>
-        <a:solidFill>
-          <a:srgbClr val="070A0D"/>
-        </a:solidFill>
-        <a:effectLst/>
-      </p:bgPr>
-    </p:bg>
-    <p:spTree>
-      <p:nvGrpSpPr>
-        <p:cNvPr id="1" name=""/>
-        <p:cNvGrpSpPr/>
-        <p:nvPr/>
-      </p:nvGrpSpPr>
-      <p:grpSpPr/>
-      <p:sp>
-        <p:nvSpPr>
-          <p:cNvPr id="2" name="TextBox 1"/>
-          <p:cNvSpPr txBox="1"/>
-          <p:nvPr/>
-        </p:nvSpPr>
-        <p:spPr>
-          <a:xfrm>
-            <a:off x="640080" y="274320"/>
-            <a:ext cx="4572000" cy="365760"/>
-          </a:xfrm>
-          <a:prstGeom prst="rect">
-            <a:avLst/>
-          </a:prstGeom>
-          <a:noFill/>
-        </p:spPr>
-        <p:txBody>
-          <a:bodyPr wrap="square">
-            <a:spAutoFit/>
-          </a:bodyPr>
-          <a:lstStyle/>
-          <a:p>
-            <a:pPr algn="l"/>
-            <a:r>
-              <a:rPr sz="1200" b="1">
-                <a:solidFill>
-                  <a:srgbClr val="7D8690"/>
-                </a:solidFill>
-                <a:latin typeface="Inter"/>
-              </a:rPr>
-              <a:t>06 / 10   </a:t>
-            </a:r>
-            <a:r>
-              <a:rPr sz="1200" b="1">
-                <a:solidFill>
-                  <a:srgbClr val="7D8690"/>
-                </a:solidFill>
-                <a:latin typeface="Inter"/>
-              </a:rPr>
-              <a:t>ЖИМ НОГАМИ · KOSMOHACK</a:t>
-            </a:r>
-          </a:p>
-        </p:txBody>
-      </p:sp>
-      <p:sp>
-        <p:nvSpPr>
-          <p:cNvPr id="3" name="Oval 2"/>
-          <p:cNvSpPr/>
-          <p:nvPr/>
-        </p:nvSpPr>
-        <p:spPr>
-          <a:xfrm>
-            <a:off x="11612880" y="384048"/>
-            <a:ext cx="128016" cy="128016"/>
-          </a:xfrm>
-          <a:prstGeom prst="ellipse">
-            <a:avLst/>
-          </a:prstGeom>
-          <a:solidFill>
-            <a:srgbClr val="62D99A"/>
-          </a:solidFill>
-          <a:ln>
-            <a:noFill/>
-          </a:ln>
-        </p:spPr>
-        <p:style>
-          <a:lnRef idx="1">
-            <a:schemeClr val="accent1"/>
-          </a:lnRef>
-          <a:fillRef idx="3">
-            <a:schemeClr val="accent1"/>
-          </a:fillRef>
-          <a:effectRef idx="2">
-            <a:schemeClr val="accent1"/>
-          </a:effectRef>
-          <a:fontRef idx="minor">
-            <a:schemeClr val="lt1"/>
-          </a:fontRef>
-        </p:style>
-        <p:txBody>
-          <a:bodyPr rtlCol="0" anchor="ctr"/>
-          <a:lstStyle/>
-          <a:p>
-            <a:pPr algn="ctr"/>
-          </a:p>
-        </p:txBody>
-      </p:sp>
-      <p:sp>
-        <p:nvSpPr>
-          <p:cNvPr id="4" name="TextBox 3"/>
-          <p:cNvSpPr txBox="1"/>
-          <p:nvPr/>
-        </p:nvSpPr>
-        <p:spPr>
-          <a:xfrm>
-            <a:off x="640080" y="822960"/>
-            <a:ext cx="10881360" cy="1188720"/>
-          </a:xfrm>
-          <a:prstGeom prst="rect">
-            <a:avLst/>
-          </a:prstGeom>
-          <a:noFill/>
-        </p:spPr>
-        <p:txBody>
-          <a:bodyPr wrap="square">
-            <a:spAutoFit/>
-          </a:bodyPr>
-          <a:lstStyle/>
-          <a:p>
-            <a:pPr algn="l"/>
-            <a:r>
-              <a:rPr sz="4000" b="1">
-                <a:solidFill>
-                  <a:srgbClr val="F2F4F5"/>
-                </a:solidFill>
-                <a:latin typeface="Inter"/>
-              </a:rPr>
-              <a:t>Гари картируем: IoU 0.52 · mIoU 0.54</a:t>
-            </a:r>
-          </a:p>
-        </p:txBody>
-      </p:sp>
-      <p:sp>
-        <p:nvSpPr>
-          <p:cNvPr id="5" name="Oval 4"/>
-          <p:cNvSpPr/>
-          <p:nvPr/>
-        </p:nvSpPr>
-        <p:spPr>
-          <a:xfrm>
-            <a:off x="914400" y="2596896"/>
-            <a:ext cx="155448" cy="155448"/>
-          </a:xfrm>
-          <a:prstGeom prst="ellipse">
-            <a:avLst/>
-          </a:prstGeom>
-          <a:solidFill>
-            <a:srgbClr val="62D99A"/>
-          </a:solidFill>
-          <a:ln>
-            <a:noFill/>
-          </a:ln>
-        </p:spPr>
-        <p:style>
-          <a:lnRef idx="1">
-            <a:schemeClr val="accent1"/>
-          </a:lnRef>
-          <a:fillRef idx="3">
-            <a:schemeClr val="accent1"/>
-          </a:fillRef>
-          <a:effectRef idx="2">
-            <a:schemeClr val="accent1"/>
-          </a:effectRef>
-          <a:fontRef idx="minor">
-            <a:schemeClr val="lt1"/>
-          </a:fontRef>
-        </p:style>
-        <p:txBody>
-          <a:bodyPr rtlCol="0" anchor="ctr"/>
-          <a:lstStyle/>
-          <a:p>
-            <a:pPr algn="ctr"/>
-          </a:p>
-        </p:txBody>
-      </p:sp>
-      <p:sp>
-        <p:nvSpPr>
-          <p:cNvPr id="6" name="TextBox 5"/>
-          <p:cNvSpPr txBox="1"/>
-          <p:nvPr/>
-        </p:nvSpPr>
-        <p:spPr>
-          <a:xfrm>
-            <a:off x="1280160" y="2395728"/>
-            <a:ext cx="10332720" cy="822960"/>
-          </a:xfrm>
-          <a:prstGeom prst="rect">
-            <a:avLst/>
-          </a:prstGeom>
-          <a:noFill/>
-        </p:spPr>
-        <p:txBody>
-          <a:bodyPr wrap="square">
-            <a:spAutoFit/>
-          </a:bodyPr>
-          <a:lstStyle/>
-          <a:p>
-            <a:pPr algn="l"/>
-            <a:r>
-              <a:rPr sz="2100" b="0">
-                <a:solidFill>
-                  <a:srgbClr val="F2F4F5"/>
-                </a:solidFill>
-                <a:latin typeface="Inter"/>
-              </a:rPr>
-              <a:t>27 каналов + пороги dNBR под каждый тип покрова</a:t>
-            </a:r>
-            <a:r>
-              <a:rPr sz="1500" b="0">
-                <a:solidFill>
-                  <a:srgbClr val="7D8690"/>
-                </a:solidFill>
-                <a:latin typeface="Inter"/>
-              </a:rPr>
-              <a:t>
-лес, степь, пашня и пойма горят по-разному — один порог врёт</a:t>
-            </a:r>
-          </a:p>
-        </p:txBody>
-      </p:sp>
-      <p:sp>
-        <p:nvSpPr>
-          <p:cNvPr id="7" name="Oval 6"/>
-          <p:cNvSpPr/>
-          <p:nvPr/>
-        </p:nvSpPr>
-        <p:spPr>
-          <a:xfrm>
-            <a:off x="914400" y="3602736"/>
-            <a:ext cx="155448" cy="155448"/>
-          </a:xfrm>
-          <a:prstGeom prst="ellipse">
-            <a:avLst/>
-          </a:prstGeom>
-          <a:solidFill>
-            <a:srgbClr val="E6C65C"/>
-          </a:solidFill>
-          <a:ln>
-            <a:noFill/>
-          </a:ln>
-        </p:spPr>
-        <p:style>
-          <a:lnRef idx="1">
-            <a:schemeClr val="accent1"/>
-          </a:lnRef>
-          <a:fillRef idx="3">
-            <a:schemeClr val="accent1"/>
-          </a:fillRef>
-          <a:effectRef idx="2">
-            <a:schemeClr val="accent1"/>
-          </a:effectRef>
-          <a:fontRef idx="minor">
-            <a:schemeClr val="lt1"/>
-          </a:fontRef>
-        </p:style>
-        <p:txBody>
-          <a:bodyPr rtlCol="0" anchor="ctr"/>
-          <a:lstStyle/>
-          <a:p>
-            <a:pPr algn="ctr"/>
-          </a:p>
-        </p:txBody>
-      </p:sp>
-      <p:sp>
-        <p:nvSpPr>
-          <p:cNvPr id="8" name="TextBox 7"/>
-          <p:cNvSpPr txBox="1"/>
-          <p:nvPr/>
-        </p:nvSpPr>
-        <p:spPr>
-          <a:xfrm>
-            <a:off x="1280160" y="3401568"/>
-            <a:ext cx="10332720" cy="822960"/>
-          </a:xfrm>
-          <a:prstGeom prst="rect">
-            <a:avLst/>
-          </a:prstGeom>
-          <a:noFill/>
-        </p:spPr>
-        <p:txBody>
-          <a:bodyPr wrap="square">
-            <a:spAutoFit/>
-          </a:bodyPr>
-          <a:lstStyle/>
-          <a:p>
-            <a:pPr algn="l"/>
-            <a:r>
-              <a:rPr sz="2100" b="0">
-                <a:solidFill>
-                  <a:srgbClr val="F2F4F5"/>
-                </a:solidFill>
-                <a:latin typeface="Inter"/>
-              </a:rPr>
-              <a:t>Prithvi-300M не взлетел</a:t>
-            </a:r>
-            <a:r>
-              <a:rPr sz="1500" b="0">
-                <a:solidFill>
-                  <a:srgbClr val="7D8690"/>
-                </a:solidFill>
-                <a:latin typeface="Inter"/>
-              </a:rPr>
-              <a:t>
-IoU 0.16 — честно убили ветку, а не прячем</a:t>
-            </a:r>
-          </a:p>
-        </p:txBody>
-      </p:sp>
-      <p:sp>
-        <p:nvSpPr>
-          <p:cNvPr id="9" name="Oval 8"/>
-          <p:cNvSpPr/>
-          <p:nvPr/>
-        </p:nvSpPr>
-        <p:spPr>
-          <a:xfrm>
-            <a:off x="914400" y="4608576"/>
-            <a:ext cx="155448" cy="155448"/>
-          </a:xfrm>
-          <a:prstGeom prst="ellipse">
-            <a:avLst/>
-          </a:prstGeom>
-          <a:solidFill>
-            <a:srgbClr val="F2F4F5"/>
-          </a:solidFill>
-          <a:ln>
-            <a:noFill/>
-          </a:ln>
-        </p:spPr>
-        <p:style>
-          <a:lnRef idx="1">
-            <a:schemeClr val="accent1"/>
-          </a:lnRef>
-          <a:fillRef idx="3">
-            <a:schemeClr val="accent1"/>
-          </a:fillRef>
-          <a:effectRef idx="2">
-            <a:schemeClr val="accent1"/>
-          </a:effectRef>
-          <a:fontRef idx="minor">
-            <a:schemeClr val="lt1"/>
-          </a:fontRef>
-        </p:style>
-        <p:txBody>
-          <a:bodyPr rtlCol="0" anchor="ctr"/>
-          <a:lstStyle/>
-          <a:p>
-            <a:pPr algn="ctr"/>
-          </a:p>
-        </p:txBody>
-      </p:sp>
-      <p:sp>
-        <p:nvSpPr>
-          <p:cNvPr id="10" name="TextBox 9"/>
-          <p:cNvSpPr txBox="1"/>
-          <p:nvPr/>
-        </p:nvSpPr>
-        <p:spPr>
-          <a:xfrm>
-            <a:off x="1280160" y="4407408"/>
-            <a:ext cx="10332720" cy="822960"/>
-          </a:xfrm>
-          <a:prstGeom prst="rect">
-            <a:avLst/>
-          </a:prstGeom>
-          <a:noFill/>
-        </p:spPr>
-        <p:txBody>
-          <a:bodyPr wrap="square">
-            <a:spAutoFit/>
-          </a:bodyPr>
-          <a:lstStyle/>
-          <a:p>
-            <a:pPr algn="l"/>
-            <a:r>
-              <a:rPr sz="2100" b="0">
-                <a:solidFill>
-                  <a:srgbClr val="F2F4F5"/>
-                </a:solidFill>
-                <a:latin typeface="Inter"/>
-              </a:rPr>
-              <a:t>Два retry тоже проиграли фризу</a:t>
-            </a:r>
-            <a:r>
-              <a:rPr sz="1500" b="0">
-                <a:solidFill>
-                  <a:srgbClr val="7D8690"/>
-                </a:solidFill>
-                <a:latin typeface="Inter"/>
-              </a:rPr>
-              <a:t>
-сдаём проверенный вариант, а не последний</a:t>
-            </a:r>
-          </a:p>
-        </p:txBody>
-      </p:sp>
-    </p:spTree>
-  </p:cSld>
-  <p:clrMapOvr>
-    <a:masterClrMapping/>
-  </p:clrMapOvr>
-</p:sld>
-</file>
-
-<file path=ppt/slides/slide7.xml><?xml version="1.0" encoding="utf-8"?>
-<p:sld xmlns:a="http://schemas.openxmlformats.org/drawingml/2006/main" xmlns:p="http://schemas.openxmlformats.org/presentationml/2006/main" xmlns:r="http://schemas.openxmlformats.org/officeDocument/2006/relationships">
-  <p:cSld>
-    <p:bg>
-      <p:bgPr>
-        <a:solidFill>
-          <a:srgbClr val="070A0D"/>
-        </a:solidFill>
-        <a:effectLst/>
-      </p:bgPr>
-    </p:bg>
-    <p:spTree>
-      <p:nvGrpSpPr>
-        <p:cNvPr id="1" name=""/>
-        <p:cNvGrpSpPr/>
-        <p:nvPr/>
-      </p:nvGrpSpPr>
-      <p:grpSpPr/>
-      <p:sp>
-        <p:nvSpPr>
-          <p:cNvPr id="2" name="TextBox 1"/>
-          <p:cNvSpPr txBox="1"/>
-          <p:nvPr/>
-        </p:nvSpPr>
-        <p:spPr>
-          <a:xfrm>
-            <a:off x="640080" y="274320"/>
-            <a:ext cx="4572000" cy="365760"/>
-          </a:xfrm>
-          <a:prstGeom prst="rect">
-            <a:avLst/>
-          </a:prstGeom>
-          <a:noFill/>
-        </p:spPr>
-        <p:txBody>
-          <a:bodyPr wrap="square">
-            <a:spAutoFit/>
-          </a:bodyPr>
-          <a:lstStyle/>
-          <a:p>
-            <a:pPr algn="l"/>
-            <a:r>
-              <a:rPr sz="1200" b="1">
-                <a:solidFill>
-                  <a:srgbClr val="7D8690"/>
-                </a:solidFill>
-                <a:latin typeface="Inter"/>
-              </a:rPr>
-              <a:t>07 / 10   </a:t>
-            </a:r>
-            <a:r>
-              <a:rPr sz="1200" b="1">
-                <a:solidFill>
-                  <a:srgbClr val="7D8690"/>
-                </a:solidFill>
-                <a:latin typeface="Inter"/>
-              </a:rPr>
-              <a:t>ЖИМ НОГАМИ · KOSMOHACK</a:t>
-            </a:r>
-          </a:p>
-        </p:txBody>
-      </p:sp>
-      <p:sp>
-        <p:nvSpPr>
-          <p:cNvPr id="3" name="Oval 2"/>
-          <p:cNvSpPr/>
-          <p:nvPr/>
-        </p:nvSpPr>
-        <p:spPr>
-          <a:xfrm>
-            <a:off x="11612880" y="384048"/>
-            <a:ext cx="128016" cy="128016"/>
-          </a:xfrm>
-          <a:prstGeom prst="ellipse">
-            <a:avLst/>
-          </a:prstGeom>
-          <a:solidFill>
-            <a:srgbClr val="62D99A"/>
-          </a:solidFill>
-          <a:ln>
-            <a:noFill/>
-          </a:ln>
-        </p:spPr>
-        <p:style>
-          <a:lnRef idx="1">
-            <a:schemeClr val="accent1"/>
-          </a:lnRef>
-          <a:fillRef idx="3">
-            <a:schemeClr val="accent1"/>
-          </a:fillRef>
-          <a:effectRef idx="2">
-            <a:schemeClr val="accent1"/>
-          </a:effectRef>
-          <a:fontRef idx="minor">
-            <a:schemeClr val="lt1"/>
-          </a:fontRef>
-        </p:style>
-        <p:txBody>
-          <a:bodyPr rtlCol="0" anchor="ctr"/>
-          <a:lstStyle/>
-          <a:p>
-            <a:pPr algn="ctr"/>
-          </a:p>
-        </p:txBody>
-      </p:sp>
-      <p:sp>
-        <p:nvSpPr>
-          <p:cNvPr id="4" name="TextBox 3"/>
-          <p:cNvSpPr txBox="1"/>
-          <p:nvPr/>
-        </p:nvSpPr>
-        <p:spPr>
-          <a:xfrm>
-            <a:off x="640080" y="822960"/>
-            <a:ext cx="10881360" cy="1188720"/>
-          </a:xfrm>
-          <a:prstGeom prst="rect">
-            <a:avLst/>
-          </a:prstGeom>
-          <a:noFill/>
-        </p:spPr>
-        <p:txBody>
-          <a:bodyPr wrap="square">
-            <a:spAutoFit/>
-          </a:bodyPr>
-          <a:lstStyle/>
-          <a:p>
-            <a:pPr algn="l"/>
-            <a:r>
-              <a:rPr sz="4000" b="1">
-                <a:solidFill>
-                  <a:srgbClr val="F2F4F5"/>
-                </a:solidFill>
-                <a:latin typeface="Inter"/>
-              </a:rPr>
-              <a:t>Итог метрики: 0.654</a:t>
-            </a:r>
-          </a:p>
-        </p:txBody>
-      </p:sp>
-      <p:sp>
-        <p:nvSpPr>
-          <p:cNvPr id="5" name="Rounded Rectangle 4"/>
-          <p:cNvSpPr/>
-          <p:nvPr/>
-        </p:nvSpPr>
-        <p:spPr>
-          <a:xfrm>
-            <a:off x="640080" y="2286000"/>
-            <a:ext cx="10881360" cy="1463040"/>
-          </a:xfrm>
-          <a:prstGeom prst="roundRect">
-            <a:avLst>
-              <a:gd name="adj" fmla="val 7000"/>
-            </a:avLst>
-          </a:prstGeom>
-          <a:solidFill>
-            <a:srgbClr val="0D1217"/>
-          </a:solidFill>
-          <a:ln w="12700">
-            <a:solidFill>
-              <a:srgbClr val="2A333D"/>
-            </a:solidFill>
-          </a:ln>
-        </p:spPr>
-        <p:style>
-          <a:lnRef idx="1">
-            <a:schemeClr val="accent1"/>
-          </a:lnRef>
-          <a:fillRef idx="3">
-            <a:schemeClr val="accent1"/>
-          </a:fillRef>
-          <a:effectRef idx="2">
-            <a:schemeClr val="accent1"/>
-          </a:effectRef>
-          <a:fontRef idx="minor">
-            <a:schemeClr val="lt1"/>
-          </a:fontRef>
-        </p:style>
-        <p:txBody>
-          <a:bodyPr rtlCol="0" anchor="ctr"/>
-          <a:lstStyle/>
-          <a:p>
-            <a:pPr algn="ctr"/>
-          </a:p>
-        </p:txBody>
-      </p:sp>
-      <p:sp>
-        <p:nvSpPr>
-          <p:cNvPr id="6" name="TextBox 5"/>
-          <p:cNvSpPr txBox="1"/>
-          <p:nvPr/>
-        </p:nvSpPr>
-        <p:spPr>
-          <a:xfrm>
-            <a:off x="914400" y="2468880"/>
-            <a:ext cx="10332720" cy="1097280"/>
-          </a:xfrm>
-          <a:prstGeom prst="rect">
-            <a:avLst/>
-          </a:prstGeom>
-          <a:noFill/>
-        </p:spPr>
-        <p:txBody>
-          <a:bodyPr wrap="square">
-            <a:spAutoFit/>
-          </a:bodyPr>
-          <a:lstStyle/>
-          <a:p>
-            <a:pPr algn="l"/>
-            <a:r>
-              <a:rPr sz="2700" b="1">
-                <a:solidFill>
-                  <a:srgbClr val="F2F4F5"/>
-                </a:solidFill>
-                <a:latin typeface="Inter"/>
-              </a:rPr>
-              <a:t>0.35 × 0.8434  +  0.35 × 0.5239  +  0.30 × 0.5430  =  0.654</a:t>
-            </a:r>
-            <a:r>
-              <a:rPr sz="1600" b="0">
-                <a:solidFill>
-                  <a:srgbClr val="7D8690"/>
-                </a:solidFill>
-                <a:latin typeface="Inter"/>
-              </a:rPr>
-              <a:t>
-micro-pool по всем пикселям — устойчиво к редкости горения</a:t>
-            </a:r>
-          </a:p>
-        </p:txBody>
-      </p:sp>
-      <p:sp>
-        <p:nvSpPr>
-          <p:cNvPr id="7" name="Oval 6"/>
-          <p:cNvSpPr/>
-          <p:nvPr/>
-        </p:nvSpPr>
-        <p:spPr>
-          <a:xfrm>
-            <a:off x="914400" y="4334255"/>
-            <a:ext cx="155448" cy="155448"/>
-          </a:xfrm>
-          <a:prstGeom prst="ellipse">
-            <a:avLst/>
-          </a:prstGeom>
-          <a:solidFill>
-            <a:srgbClr val="62D99A"/>
-          </a:solidFill>
-          <a:ln>
-            <a:noFill/>
-          </a:ln>
-        </p:spPr>
-        <p:style>
-          <a:lnRef idx="1">
-            <a:schemeClr val="accent1"/>
-          </a:lnRef>
-          <a:fillRef idx="3">
-            <a:schemeClr val="accent1"/>
-          </a:fillRef>
-          <a:effectRef idx="2">
-            <a:schemeClr val="accent1"/>
-          </a:effectRef>
-          <a:fontRef idx="minor">
-            <a:schemeClr val="lt1"/>
-          </a:fontRef>
-        </p:style>
-        <p:txBody>
-          <a:bodyPr rtlCol="0" anchor="ctr"/>
-          <a:lstStyle/>
-          <a:p>
-            <a:pPr algn="ctr"/>
-          </a:p>
-        </p:txBody>
-      </p:sp>
-      <p:sp>
-        <p:nvSpPr>
-          <p:cNvPr id="8" name="TextBox 7"/>
-          <p:cNvSpPr txBox="1"/>
-          <p:nvPr/>
-        </p:nvSpPr>
-        <p:spPr>
-          <a:xfrm>
-            <a:off x="1280160" y="4133087"/>
-            <a:ext cx="10332720" cy="822960"/>
-          </a:xfrm>
-          <a:prstGeom prst="rect">
-            <a:avLst/>
-          </a:prstGeom>
-          <a:noFill/>
-        </p:spPr>
-        <p:txBody>
-          <a:bodyPr wrap="square">
-            <a:spAutoFit/>
-          </a:bodyPr>
-          <a:lstStyle/>
-          <a:p>
-            <a:pPr algn="l"/>
-            <a:r>
-              <a:rPr sz="1900" b="0">
-                <a:solidFill>
-                  <a:srgbClr val="F2F4F5"/>
-                </a:solidFill>
-                <a:latin typeface="Inter"/>
-              </a:rPr>
-              <a:t>447 строк = шаблону · RLE валиден · NaN 0 · пересечений 0</a:t>
-            </a:r>
-          </a:p>
-        </p:txBody>
-      </p:sp>
-      <p:sp>
-        <p:nvSpPr>
-          <p:cNvPr id="9" name="Oval 8"/>
-          <p:cNvSpPr/>
-          <p:nvPr/>
-        </p:nvSpPr>
-        <p:spPr>
-          <a:xfrm>
-            <a:off x="914400" y="5157216"/>
-            <a:ext cx="155448" cy="155448"/>
-          </a:xfrm>
-          <a:prstGeom prst="ellipse">
-            <a:avLst/>
-          </a:prstGeom>
-          <a:solidFill>
-            <a:srgbClr val="F2F4F5"/>
-          </a:solidFill>
-          <a:ln>
-            <a:noFill/>
-          </a:ln>
-        </p:spPr>
-        <p:style>
-          <a:lnRef idx="1">
-            <a:schemeClr val="accent1"/>
-          </a:lnRef>
-          <a:fillRef idx="3">
-            <a:schemeClr val="accent1"/>
-          </a:fillRef>
-          <a:effectRef idx="2">
-            <a:schemeClr val="accent1"/>
-          </a:effectRef>
-          <a:fontRef idx="minor">
-            <a:schemeClr val="lt1"/>
-          </a:fontRef>
-        </p:style>
-        <p:txBody>
-          <a:bodyPr rtlCol="0" anchor="ctr"/>
-          <a:lstStyle/>
-          <a:p>
-            <a:pPr algn="ctr"/>
-          </a:p>
-        </p:txBody>
-      </p:sp>
-      <p:sp>
-        <p:nvSpPr>
-          <p:cNvPr id="10" name="TextBox 9"/>
-          <p:cNvSpPr txBox="1"/>
-          <p:nvPr/>
-        </p:nvSpPr>
-        <p:spPr>
-          <a:xfrm>
-            <a:off x="1280160" y="4956048"/>
-            <a:ext cx="10332720" cy="822960"/>
-          </a:xfrm>
-          <a:prstGeom prst="rect">
-            <a:avLst/>
-          </a:prstGeom>
-          <a:noFill/>
-        </p:spPr>
-        <p:txBody>
-          <a:bodyPr wrap="square">
-            <a:spAutoFit/>
-          </a:bodyPr>
-          <a:lstStyle/>
-          <a:p>
-            <a:pPr algn="l"/>
-            <a:r>
-              <a:rPr sz="1900" b="0">
-                <a:solidFill>
-                  <a:srgbClr val="F2F4F5"/>
-                </a:solidFill>
-                <a:latin typeface="Inter"/>
-              </a:rPr>
-              <a:t>Два прогона — побайтово идентичны · md5 зафиксирован</a:t>
-            </a:r>
-          </a:p>
-        </p:txBody>
-      </p:sp>
-    </p:spTree>
-  </p:cSld>
-  <p:clrMapOvr>
-    <a:masterClrMapping/>
-  </p:clrMapOvr>
-</p:sld>
-</file>
-
-<file path=ppt/slides/slide8.xml><?xml version="1.0" encoding="utf-8"?>
 <p:sld xmlns:a="http://schemas.openxmlformats.org/drawingml/2006/main" xmlns:p="http://schemas.openxmlformats.org/presentationml/2006/main" xmlns:r="http://schemas.openxmlformats.org/officeDocument/2006/relationships">
   <p:cSld>
     <p:bg>
@@ -7645,6 +6238,596 @@
 </p:sld>
 </file>
 
+<file path=ppt/slides/slide7.xml><?xml version="1.0" encoding="utf-8"?>
+<p:sld xmlns:a="http://schemas.openxmlformats.org/drawingml/2006/main" xmlns:p="http://schemas.openxmlformats.org/presentationml/2006/main" xmlns:r="http://schemas.openxmlformats.org/officeDocument/2006/relationships">
+  <p:cSld>
+    <p:bg>
+      <p:bgPr>
+        <a:solidFill>
+          <a:srgbClr val="070A0D"/>
+        </a:solidFill>
+        <a:effectLst/>
+      </p:bgPr>
+    </p:bg>
+    <p:spTree>
+      <p:nvGrpSpPr>
+        <p:cNvPr id="1" name=""/>
+        <p:cNvGrpSpPr/>
+        <p:nvPr/>
+      </p:nvGrpSpPr>
+      <p:grpSpPr/>
+      <p:sp>
+        <p:nvSpPr>
+          <p:cNvPr id="2" name="TextBox 1"/>
+          <p:cNvSpPr txBox="1"/>
+          <p:nvPr/>
+        </p:nvSpPr>
+        <p:spPr>
+          <a:xfrm>
+            <a:off x="640080" y="274320"/>
+            <a:ext cx="10881360" cy="365760"/>
+          </a:xfrm>
+          <a:prstGeom prst="rect">
+            <a:avLst/>
+          </a:prstGeom>
+          <a:noFill/>
+        </p:spPr>
+        <p:txBody>
+          <a:bodyPr wrap="square">
+            <a:spAutoFit/>
+          </a:bodyPr>
+          <a:lstStyle/>
+          <a:p>
+            <a:pPr algn="l"/>
+            <a:r>
+              <a:rPr sz="1200" b="1">
+                <a:solidFill>
+                  <a:srgbClr val="7D8690"/>
+                </a:solidFill>
+                <a:latin typeface="Inter"/>
+              </a:rPr>
+              <a:t>ЖИМ НОГАМИ · KOSMOHACK</a:t>
+            </a:r>
+          </a:p>
+        </p:txBody>
+      </p:sp>
+      <p:sp>
+        <p:nvSpPr>
+          <p:cNvPr id="3" name="Oval 2"/>
+          <p:cNvSpPr/>
+          <p:nvPr/>
+        </p:nvSpPr>
+        <p:spPr>
+          <a:xfrm>
+            <a:off x="11658600" y="384048"/>
+            <a:ext cx="128016" cy="128016"/>
+          </a:xfrm>
+          <a:prstGeom prst="ellipse">
+            <a:avLst/>
+          </a:prstGeom>
+          <a:solidFill>
+            <a:srgbClr val="62D99A"/>
+          </a:solidFill>
+          <a:ln>
+            <a:noFill/>
+          </a:ln>
+        </p:spPr>
+        <p:style>
+          <a:lnRef idx="1">
+            <a:schemeClr val="accent1"/>
+          </a:lnRef>
+          <a:fillRef idx="3">
+            <a:schemeClr val="accent1"/>
+          </a:fillRef>
+          <a:effectRef idx="2">
+            <a:schemeClr val="accent1"/>
+          </a:effectRef>
+          <a:fontRef idx="minor">
+            <a:schemeClr val="lt1"/>
+          </a:fontRef>
+        </p:style>
+        <p:txBody>
+          <a:bodyPr rtlCol="0" anchor="ctr"/>
+          <a:lstStyle/>
+          <a:p>
+            <a:pPr algn="ctr"/>
+          </a:p>
+        </p:txBody>
+      </p:sp>
+      <p:sp>
+        <p:nvSpPr>
+          <p:cNvPr id="4" name="TextBox 3"/>
+          <p:cNvSpPr txBox="1"/>
+          <p:nvPr/>
+        </p:nvSpPr>
+        <p:spPr>
+          <a:xfrm>
+            <a:off x="640080" y="640080"/>
+            <a:ext cx="10881360" cy="1097280"/>
+          </a:xfrm>
+          <a:prstGeom prst="rect">
+            <a:avLst/>
+          </a:prstGeom>
+          <a:noFill/>
+        </p:spPr>
+        <p:txBody>
+          <a:bodyPr wrap="square">
+            <a:spAutoFit/>
+          </a:bodyPr>
+          <a:lstStyle/>
+          <a:p>
+            <a:pPr algn="l"/>
+            <a:r>
+              <a:rPr sz="3400" b="1">
+                <a:solidFill>
+                  <a:srgbClr val="F2F4F5"/>
+                </a:solidFill>
+                <a:latin typeface="Inter"/>
+              </a:rPr>
+              <a:t>Карта умеет: слои, степени, справка</a:t>
+            </a:r>
+          </a:p>
+        </p:txBody>
+      </p:sp>
+      <p:pic>
+        <p:nvPicPr>
+          <p:cNvPr id="5" name="Picture 4" descr="02-burned-only.png"/>
+          <p:cNvPicPr>
+            <a:picLocks noChangeAspect="1"/>
+          </p:cNvPicPr>
+          <p:nvPr/>
+        </p:nvPicPr>
+        <p:blipFill>
+          <a:blip r:embed="rId2"/>
+          <a:stretch>
+            <a:fillRect/>
+          </a:stretch>
+        </p:blipFill>
+        <p:spPr>
+          <a:xfrm>
+            <a:off x="640080" y="1828800"/>
+            <a:ext cx="6949440" cy="3909060"/>
+          </a:xfrm>
+          <a:prstGeom prst="rect">
+            <a:avLst/>
+          </a:prstGeom>
+        </p:spPr>
+      </p:pic>
+      <p:pic>
+        <p:nvPicPr>
+          <p:cNvPr id="6" name="Picture 5" descr="03-analytics.png"/>
+          <p:cNvPicPr>
+            <a:picLocks noChangeAspect="1"/>
+          </p:cNvPicPr>
+          <p:nvPr/>
+        </p:nvPicPr>
+        <p:blipFill>
+          <a:blip r:embed="rId3"/>
+          <a:stretch>
+            <a:fillRect/>
+          </a:stretch>
+        </p:blipFill>
+        <p:spPr>
+          <a:xfrm>
+            <a:off x="7863840" y="2926080"/>
+            <a:ext cx="3657600" cy="467617"/>
+          </a:xfrm>
+          <a:prstGeom prst="rect">
+            <a:avLst/>
+          </a:prstGeom>
+        </p:spPr>
+      </p:pic>
+    </p:spTree>
+  </p:cSld>
+  <p:clrMapOvr>
+    <a:masterClrMapping/>
+  </p:clrMapOvr>
+</p:sld>
+</file>
+
+<file path=ppt/slides/slide8.xml><?xml version="1.0" encoding="utf-8"?>
+<p:sld xmlns:a="http://schemas.openxmlformats.org/drawingml/2006/main" xmlns:p="http://schemas.openxmlformats.org/presentationml/2006/main" xmlns:r="http://schemas.openxmlformats.org/officeDocument/2006/relationships">
+  <p:cSld>
+    <p:bg>
+      <p:bgPr>
+        <a:solidFill>
+          <a:srgbClr val="070A0D"/>
+        </a:solidFill>
+        <a:effectLst/>
+      </p:bgPr>
+    </p:bg>
+    <p:spTree>
+      <p:nvGrpSpPr>
+        <p:cNvPr id="1" name=""/>
+        <p:cNvGrpSpPr/>
+        <p:nvPr/>
+      </p:nvGrpSpPr>
+      <p:grpSpPr/>
+      <p:sp>
+        <p:nvSpPr>
+          <p:cNvPr id="2" name="TextBox 1"/>
+          <p:cNvSpPr txBox="1"/>
+          <p:nvPr/>
+        </p:nvSpPr>
+        <p:spPr>
+          <a:xfrm>
+            <a:off x="640080" y="274320"/>
+            <a:ext cx="10881360" cy="365760"/>
+          </a:xfrm>
+          <a:prstGeom prst="rect">
+            <a:avLst/>
+          </a:prstGeom>
+          <a:noFill/>
+        </p:spPr>
+        <p:txBody>
+          <a:bodyPr wrap="square">
+            <a:spAutoFit/>
+          </a:bodyPr>
+          <a:lstStyle/>
+          <a:p>
+            <a:pPr algn="l"/>
+            <a:r>
+              <a:rPr sz="1200" b="1">
+                <a:solidFill>
+                  <a:srgbClr val="7D8690"/>
+                </a:solidFill>
+                <a:latin typeface="Inter"/>
+              </a:rPr>
+              <a:t>ЖИМ НОГАМИ · KOSMOHACK</a:t>
+            </a:r>
+          </a:p>
+        </p:txBody>
+      </p:sp>
+      <p:sp>
+        <p:nvSpPr>
+          <p:cNvPr id="3" name="Oval 2"/>
+          <p:cNvSpPr/>
+          <p:nvPr/>
+        </p:nvSpPr>
+        <p:spPr>
+          <a:xfrm>
+            <a:off x="11658600" y="384048"/>
+            <a:ext cx="128016" cy="128016"/>
+          </a:xfrm>
+          <a:prstGeom prst="ellipse">
+            <a:avLst/>
+          </a:prstGeom>
+          <a:solidFill>
+            <a:srgbClr val="62D99A"/>
+          </a:solidFill>
+          <a:ln>
+            <a:noFill/>
+          </a:ln>
+        </p:spPr>
+        <p:style>
+          <a:lnRef idx="1">
+            <a:schemeClr val="accent1"/>
+          </a:lnRef>
+          <a:fillRef idx="3">
+            <a:schemeClr val="accent1"/>
+          </a:fillRef>
+          <a:effectRef idx="2">
+            <a:schemeClr val="accent1"/>
+          </a:effectRef>
+          <a:fontRef idx="minor">
+            <a:schemeClr val="lt1"/>
+          </a:fontRef>
+        </p:style>
+        <p:txBody>
+          <a:bodyPr rtlCol="0" anchor="ctr"/>
+          <a:lstStyle/>
+          <a:p>
+            <a:pPr algn="ctr"/>
+          </a:p>
+        </p:txBody>
+      </p:sp>
+      <p:sp>
+        <p:nvSpPr>
+          <p:cNvPr id="4" name="TextBox 3"/>
+          <p:cNvSpPr txBox="1"/>
+          <p:nvPr/>
+        </p:nvSpPr>
+        <p:spPr>
+          <a:xfrm>
+            <a:off x="640080" y="777240"/>
+            <a:ext cx="10881360" cy="1097280"/>
+          </a:xfrm>
+          <a:prstGeom prst="rect">
+            <a:avLst/>
+          </a:prstGeom>
+          <a:noFill/>
+        </p:spPr>
+        <p:txBody>
+          <a:bodyPr wrap="square">
+            <a:spAutoFit/>
+          </a:bodyPr>
+          <a:lstStyle/>
+          <a:p>
+            <a:pPr algn="l"/>
+            <a:r>
+              <a:rPr sz="3800" b="1">
+                <a:solidFill>
+                  <a:srgbClr val="F2F4F5"/>
+                </a:solidFill>
+                <a:latin typeface="Inter"/>
+              </a:rPr>
+              <a:t>Под картой — настоящее API</a:t>
+            </a:r>
+          </a:p>
+        </p:txBody>
+      </p:sp>
+      <p:sp>
+        <p:nvSpPr>
+          <p:cNvPr id="5" name="Oval 4"/>
+          <p:cNvSpPr/>
+          <p:nvPr/>
+        </p:nvSpPr>
+        <p:spPr>
+          <a:xfrm>
+            <a:off x="914400" y="2414016"/>
+            <a:ext cx="155448" cy="155448"/>
+          </a:xfrm>
+          <a:prstGeom prst="ellipse">
+            <a:avLst/>
+          </a:prstGeom>
+          <a:solidFill>
+            <a:srgbClr val="62D99A"/>
+          </a:solidFill>
+          <a:ln>
+            <a:noFill/>
+          </a:ln>
+        </p:spPr>
+        <p:style>
+          <a:lnRef idx="1">
+            <a:schemeClr val="accent1"/>
+          </a:lnRef>
+          <a:fillRef idx="3">
+            <a:schemeClr val="accent1"/>
+          </a:fillRef>
+          <a:effectRef idx="2">
+            <a:schemeClr val="accent1"/>
+          </a:effectRef>
+          <a:fontRef idx="minor">
+            <a:schemeClr val="lt1"/>
+          </a:fontRef>
+        </p:style>
+        <p:txBody>
+          <a:bodyPr rtlCol="0" anchor="ctr"/>
+          <a:lstStyle/>
+          <a:p>
+            <a:pPr algn="ctr"/>
+          </a:p>
+        </p:txBody>
+      </p:sp>
+      <p:sp>
+        <p:nvSpPr>
+          <p:cNvPr id="6" name="TextBox 5"/>
+          <p:cNvSpPr txBox="1"/>
+          <p:nvPr/>
+        </p:nvSpPr>
+        <p:spPr>
+          <a:xfrm>
+            <a:off x="1280160" y="2212848"/>
+            <a:ext cx="10241280" cy="868680"/>
+          </a:xfrm>
+          <a:prstGeom prst="rect">
+            <a:avLst/>
+          </a:prstGeom>
+          <a:noFill/>
+        </p:spPr>
+        <p:txBody>
+          <a:bodyPr wrap="square">
+            <a:spAutoFit/>
+          </a:bodyPr>
+          <a:lstStyle/>
+          <a:p>
+            <a:pPr algn="l"/>
+            <a:r>
+              <a:rPr sz="2100" b="0">
+                <a:solidFill>
+                  <a:srgbClr val="F2F4F5"/>
+                </a:solidFill>
+                <a:latin typeface="Inter"/>
+              </a:rPr>
+              <a:t>3 GET по прямоугольнику + 3 POST по полигону</a:t>
+            </a:r>
+            <a:r>
+              <a:rPr sz="1400" b="0">
+                <a:solidFill>
+                  <a:srgbClr val="7D8690"/>
+                </a:solidFill>
+                <a:latin typeface="Inter"/>
+              </a:rPr>
+              <a:t>
+точки, полигоны, аналитика — geojson, json, shp-архив</a:t>
+            </a:r>
+          </a:p>
+        </p:txBody>
+      </p:sp>
+      <p:sp>
+        <p:nvSpPr>
+          <p:cNvPr id="7" name="Oval 6"/>
+          <p:cNvSpPr/>
+          <p:nvPr/>
+        </p:nvSpPr>
+        <p:spPr>
+          <a:xfrm>
+            <a:off x="914400" y="3557016"/>
+            <a:ext cx="155448" cy="155448"/>
+          </a:xfrm>
+          <a:prstGeom prst="ellipse">
+            <a:avLst/>
+          </a:prstGeom>
+          <a:solidFill>
+            <a:srgbClr val="F2F4F5"/>
+          </a:solidFill>
+          <a:ln>
+            <a:noFill/>
+          </a:ln>
+        </p:spPr>
+        <p:style>
+          <a:lnRef idx="1">
+            <a:schemeClr val="accent1"/>
+          </a:lnRef>
+          <a:fillRef idx="3">
+            <a:schemeClr val="accent1"/>
+          </a:fillRef>
+          <a:effectRef idx="2">
+            <a:schemeClr val="accent1"/>
+          </a:effectRef>
+          <a:fontRef idx="minor">
+            <a:schemeClr val="lt1"/>
+          </a:fontRef>
+        </p:style>
+        <p:txBody>
+          <a:bodyPr rtlCol="0" anchor="ctr"/>
+          <a:lstStyle/>
+          <a:p>
+            <a:pPr algn="ctr"/>
+          </a:p>
+        </p:txBody>
+      </p:sp>
+      <p:sp>
+        <p:nvSpPr>
+          <p:cNvPr id="8" name="TextBox 7"/>
+          <p:cNvSpPr txBox="1"/>
+          <p:nvPr/>
+        </p:nvSpPr>
+        <p:spPr>
+          <a:xfrm>
+            <a:off x="1280160" y="3355848"/>
+            <a:ext cx="10241280" cy="868680"/>
+          </a:xfrm>
+          <a:prstGeom prst="rect">
+            <a:avLst/>
+          </a:prstGeom>
+          <a:noFill/>
+        </p:spPr>
+        <p:txBody>
+          <a:bodyPr wrap="square">
+            <a:spAutoFit/>
+          </a:bodyPr>
+          <a:lstStyle/>
+          <a:p>
+            <a:pPr algn="l"/>
+            <a:r>
+              <a:rPr sz="2100" b="0">
+                <a:solidFill>
+                  <a:srgbClr val="F2F4F5"/>
+                </a:solidFill>
+                <a:latin typeface="Inter"/>
+              </a:rPr>
+              <a:t>Проверено серией из 9 curl-запросов</a:t>
+            </a:r>
+            <a:r>
+              <a:rPr sz="1400" b="0">
+                <a:solidFill>
+                  <a:srgbClr val="7D8690"/>
+                </a:solidFill>
+                <a:latin typeface="Inter"/>
+              </a:rPr>
+              <a:t>
+все зелёные — файл серии лежит в репозитории</a:t>
+            </a:r>
+          </a:p>
+        </p:txBody>
+      </p:sp>
+      <p:sp>
+        <p:nvSpPr>
+          <p:cNvPr id="9" name="Oval 8"/>
+          <p:cNvSpPr/>
+          <p:nvPr/>
+        </p:nvSpPr>
+        <p:spPr>
+          <a:xfrm>
+            <a:off x="914400" y="4700016"/>
+            <a:ext cx="155448" cy="155448"/>
+          </a:xfrm>
+          <a:prstGeom prst="ellipse">
+            <a:avLst/>
+          </a:prstGeom>
+          <a:solidFill>
+            <a:srgbClr val="E6C65C"/>
+          </a:solidFill>
+          <a:ln>
+            <a:noFill/>
+          </a:ln>
+        </p:spPr>
+        <p:style>
+          <a:lnRef idx="1">
+            <a:schemeClr val="accent1"/>
+          </a:lnRef>
+          <a:fillRef idx="3">
+            <a:schemeClr val="accent1"/>
+          </a:fillRef>
+          <a:effectRef idx="2">
+            <a:schemeClr val="accent1"/>
+          </a:effectRef>
+          <a:fontRef idx="minor">
+            <a:schemeClr val="lt1"/>
+          </a:fontRef>
+        </p:style>
+        <p:txBody>
+          <a:bodyPr rtlCol="0" anchor="ctr"/>
+          <a:lstStyle/>
+          <a:p>
+            <a:pPr algn="ctr"/>
+          </a:p>
+        </p:txBody>
+      </p:sp>
+      <p:sp>
+        <p:nvSpPr>
+          <p:cNvPr id="10" name="TextBox 9"/>
+          <p:cNvSpPr txBox="1"/>
+          <p:nvPr/>
+        </p:nvSpPr>
+        <p:spPr>
+          <a:xfrm>
+            <a:off x="1280160" y="4498848"/>
+            <a:ext cx="10241280" cy="868680"/>
+          </a:xfrm>
+          <a:prstGeom prst="rect">
+            <a:avLst/>
+          </a:prstGeom>
+          <a:noFill/>
+        </p:spPr>
+        <p:txBody>
+          <a:bodyPr wrap="square">
+            <a:spAutoFit/>
+          </a:bodyPr>
+          <a:lstStyle/>
+          <a:p>
+            <a:pPr algn="l"/>
+            <a:r>
+              <a:rPr sz="2100" b="0">
+                <a:solidFill>
+                  <a:srgbClr val="F2F4F5"/>
+                </a:solidFill>
+                <a:latin typeface="Inter"/>
+              </a:rPr>
+              <a:t>Без базы данных — файловый бэкенд</a:t>
+            </a:r>
+            <a:r>
+              <a:rPr sz="1400" b="0">
+                <a:solidFill>
+                  <a:srgbClr val="7D8690"/>
+                </a:solidFill>
+                <a:latin typeface="Inter"/>
+              </a:rPr>
+              <a:t>
+нечему падать на защите</a:t>
+            </a:r>
+          </a:p>
+        </p:txBody>
+      </p:sp>
+    </p:spTree>
+  </p:cSld>
+  <p:clrMapOvr>
+    <a:masterClrMapping/>
+  </p:clrMapOvr>
+</p:sld>
+</file>
+
 <file path=ppt/slides/slide9.xml><?xml version="1.0" encoding="utf-8"?>
 <p:sld xmlns:a="http://schemas.openxmlformats.org/drawingml/2006/main" xmlns:p="http://schemas.openxmlformats.org/presentationml/2006/main" xmlns:r="http://schemas.openxmlformats.org/officeDocument/2006/relationships">
   <p:cSld>
@@ -7672,7 +6855,7 @@
         <p:spPr>
           <a:xfrm>
             <a:off x="640080" y="274320"/>
-            <a:ext cx="4572000" cy="365760"/>
+            <a:ext cx="10881360" cy="365760"/>
           </a:xfrm>
           <a:prstGeom prst="rect">
             <a:avLst/>
@@ -7686,15 +6869,6 @@
           <a:lstStyle/>
           <a:p>
             <a:pPr algn="l"/>
-            <a:r>
-              <a:rPr sz="1200" b="1">
-                <a:solidFill>
-                  <a:srgbClr val="7D8690"/>
-                </a:solidFill>
-                <a:latin typeface="Inter"/>
-              </a:rPr>
-              <a:t>09 / 10   </a:t>
-            </a:r>
             <a:r>
               <a:rPr sz="1200" b="1">
                 <a:solidFill>
@@ -7715,7 +6889,7 @@
         </p:nvSpPr>
         <p:spPr>
           <a:xfrm>
-            <a:off x="11612880" y="384048"/>
+            <a:off x="11658600" y="384048"/>
             <a:ext cx="128016" cy="128016"/>
           </a:xfrm>
           <a:prstGeom prst="ellipse">
@@ -7758,8 +6932,8 @@
         </p:nvSpPr>
         <p:spPr>
           <a:xfrm>
-            <a:off x="640080" y="822960"/>
-            <a:ext cx="10881360" cy="1188720"/>
+            <a:off x="640080" y="777240"/>
+            <a:ext cx="10881360" cy="1097280"/>
           </a:xfrm>
           <a:prstGeom prst="rect">
             <a:avLst/>
@@ -7774,13 +6948,13 @@
           <a:p>
             <a:pPr algn="l"/>
             <a:r>
-              <a:rPr sz="4000" b="1">
+              <a:rPr sz="3800" b="1">
                 <a:solidFill>
                   <a:srgbClr val="F2F4F5"/>
                 </a:solidFill>
                 <a:latin typeface="Inter"/>
               </a:rPr>
-              <a:t>Запуск — одна команда. У вас тоже заведётся</a:t>
+              <a:t>Заведётся и у вас</a:t>
             </a:r>
           </a:p>
         </p:txBody>
@@ -7793,7 +6967,7 @@
         </p:nvSpPr>
         <p:spPr>
           <a:xfrm>
-            <a:off x="914400" y="2596896"/>
+            <a:off x="914400" y="2414016"/>
             <a:ext cx="155448" cy="155448"/>
           </a:xfrm>
           <a:prstGeom prst="ellipse">
@@ -7836,8 +7010,8 @@
         </p:nvSpPr>
         <p:spPr>
           <a:xfrm>
-            <a:off x="1280160" y="2395728"/>
-            <a:ext cx="10332720" cy="822960"/>
+            <a:off x="1280160" y="2212848"/>
+            <a:ext cx="10241280" cy="868680"/>
           </a:xfrm>
           <a:prstGeom prst="rect">
             <a:avLst/>
@@ -7852,7 +7026,7 @@
           <a:p>
             <a:pPr algn="l"/>
             <a:r>
-              <a:rPr sz="2100" b="0">
+              <a:rPr sz="2200" b="0">
                 <a:solidFill>
                   <a:srgbClr val="F2F4F5"/>
                 </a:solidFill>
@@ -7861,14 +7035,14 @@
               <a:t>Веса лежат в репозитории</a:t>
             </a:r>
             <a:r>
-              <a:rPr sz="1500" b="0">
+              <a:rPr sz="1400" b="0">
                 <a:solidFill>
                   <a:srgbClr val="7D8690"/>
                 </a:solidFill>
                 <a:latin typeface="Inter"/>
               </a:rPr>
               <a:t>
-докачивать нечего · pip install + requirements.lock</a:t>
+докачивать нечего</a:t>
             </a:r>
           </a:p>
         </p:txBody>
@@ -7925,7 +7099,7 @@
         <p:spPr>
           <a:xfrm>
             <a:off x="1280160" y="3401568"/>
-            <a:ext cx="10332720" cy="822960"/>
+            <a:ext cx="10241280" cy="868680"/>
           </a:xfrm>
           <a:prstGeom prst="rect">
             <a:avLst/>
@@ -7940,23 +7114,23 @@
           <a:p>
             <a:pPr algn="l"/>
             <a:r>
-              <a:rPr sz="2100" b="0">
+              <a:rPr sz="2200" b="0">
                 <a:solidFill>
                   <a:srgbClr val="F2F4F5"/>
                 </a:solidFill>
                 <a:latin typeface="Inter"/>
               </a:rPr>
-              <a:t>inference.py --data-dir --output</a:t>
-            </a:r>
-            <a:r>
-              <a:rPr sz="1500" b="0">
+              <a:t>Одна команда инференса — ~28 секунд</a:t>
+            </a:r>
+            <a:r>
+              <a:rPr sz="1400" b="0">
                 <a:solidFill>
                   <a:srgbClr val="7D8690"/>
                 </a:solidFill>
                 <a:latin typeface="Inter"/>
               </a:rPr>
               <a:t>
-~28 секунд на GPU · на CPU дольше, результат тот же</a:t>
+на CPU дольше, результат тот же</a:t>
             </a:r>
           </a:p>
         </p:txBody>
@@ -7969,7 +7143,7 @@
         </p:nvSpPr>
         <p:spPr>
           <a:xfrm>
-            <a:off x="914400" y="4608576"/>
+            <a:off x="914400" y="4791455"/>
             <a:ext cx="155448" cy="155448"/>
           </a:xfrm>
           <a:prstGeom prst="ellipse">
@@ -8012,8 +7186,8 @@
         </p:nvSpPr>
         <p:spPr>
           <a:xfrm>
-            <a:off x="1280160" y="4407408"/>
-            <a:ext cx="10332720" cy="822960"/>
+            <a:off x="1280160" y="4590288"/>
+            <a:ext cx="10241280" cy="868680"/>
           </a:xfrm>
           <a:prstGeom prst="rect">
             <a:avLst/>
@@ -8028,23 +7202,23 @@
           <a:p>
             <a:pPr algn="l"/>
             <a:r>
-              <a:rPr sz="2100" b="0">
+              <a:rPr sz="2200" b="0">
                 <a:solidFill>
                   <a:srgbClr val="F2F4F5"/>
                 </a:solidFill>
                 <a:latin typeface="Inter"/>
               </a:rPr>
-              <a:t>Сервис: 3 GET + 3 POST · geojson/json/shp</a:t>
-            </a:r>
-            <a:r>
-              <a:rPr sz="1500" b="0">
+              <a:t>Одна команда сервиса + открыть страницу</a:t>
+            </a:r>
+            <a:r>
+              <a:rPr sz="1400" b="0">
                 <a:solidFill>
                   <a:srgbClr val="7D8690"/>
                 </a:solidFill>
                 <a:latin typeface="Inter"/>
               </a:rPr>
               <a:t>
-фронт на localhost:8000 · демо-серия в репо</a:t>
+демо из коробки</a:t>
             </a:r>
           </a:p>
         </p:txBody>

</xml_diff>

<commit_message>
feat: deck v6 visual (photo backdrops, giant numerals, dark viz)
</commit_message>
<xml_diff>
--- a/docs/slides-deck.pptx
+++ b/docs/slides-deck.pptx
@@ -511,77 +511,7 @@
           <a:lstStyle/>
           <a:p>
             <a:r>
-              <a:t>Сразу показываем что готово, без прелюдий.</a:t>
-            </a:r>
-          </a:p>
-        </p:txBody>
-      </p:sp>
-      <p:sp>
-        <p:nvSpPr>
-          <p:cNvPr id="4" name="Slide Number Placeholder 3"/>
-          <p:cNvSpPr>
-            <a:spLocks noGrp="1"/>
-          </p:cNvSpPr>
-          <p:nvPr>
-            <p:ph type="sldNum" idx="5" sz="quarter"/>
-          </p:nvPr>
-        </p:nvSpPr>
-        <p:spPr/>
-      </p:sp>
-    </p:spTree>
-  </p:cSld>
-  <p:clrMapOvr>
-    <a:masterClrMapping/>
-  </p:clrMapOvr>
-</p:notes>
-</file>
-
-<file path=ppt/notesSlides/notesSlide10.xml><?xml version="1.0" encoding="utf-8"?>
-<p:notes xmlns:a="http://schemas.openxmlformats.org/drawingml/2006/main" xmlns:p="http://schemas.openxmlformats.org/presentationml/2006/main" xmlns:r="http://schemas.openxmlformats.org/officeDocument/2006/relationships">
-  <p:cSld>
-    <p:spTree>
-      <p:nvGrpSpPr>
-        <p:cNvPr id="1" name=""/>
-        <p:cNvGrpSpPr/>
-        <p:nvPr/>
-      </p:nvGrpSpPr>
-      <p:grpSpPr>
-        <a:xfrm>
-          <a:off x="0" y="0"/>
-          <a:ext cx="0" cy="0"/>
-          <a:chOff x="0" y="0"/>
-          <a:chExt cx="0" cy="0"/>
-        </a:xfrm>
-      </p:grpSpPr>
-      <p:sp>
-        <p:nvSpPr>
-          <p:cNvPr id="2" name="Slide Image Placeholder 1"/>
-          <p:cNvSpPr>
-            <a:spLocks noGrp="1"/>
-          </p:cNvSpPr>
-          <p:nvPr>
-            <p:ph type="sldImg" idx="2"/>
-          </p:nvPr>
-        </p:nvSpPr>
-        <p:spPr/>
-      </p:sp>
-      <p:sp>
-        <p:nvSpPr>
-          <p:cNvPr id="3" name="Notes Placeholder 2"/>
-          <p:cNvSpPr>
-            <a:spLocks noGrp="1"/>
-          </p:cNvSpPr>
-          <p:nvPr>
-            <p:ph type="body" idx="3" sz="quarter"/>
-          </p:nvPr>
-        </p:nvSpPr>
-        <p:spPr/>
-        <p:txBody>
-          <a:bodyPr/>
-          <a:lstStyle/>
-          <a:p>
-            <a:r>
-              <a:t>Коротко и уверенно. Дальше — вопросы и живое демо.</a:t>
+              <a:t>Открываем с команды и главной цифры.</a:t>
             </a:r>
           </a:p>
         </p:txBody>
@@ -651,7 +581,7 @@
           <a:lstStyle/>
           <a:p>
             <a:r>
-              <a:t>EDA за полминуты CPU-проходом. Тут видно что мы реально смотрели в данные.</a:t>
+              <a:t>Мотивация: ложные выезды дорого стоят, гари нужны региону.</a:t>
             </a:r>
           </a:p>
         </p:txBody>
@@ -721,7 +651,7 @@
           <a:lstStyle/>
           <a:p>
             <a:r>
-              <a:t>AF — наша сильная сторона. Картинка справа — предсказание модели.</a:t>
+              <a:t>Пять боксов — весь пайплайн одним взглядом.</a:t>
             </a:r>
           </a:p>
         </p:txBody>
@@ -791,7 +721,7 @@
           <a:lstStyle/>
           <a:p>
             <a:r>
-              <a:t>История про инженерную честность: убивать нерабочее — тоже работа.</a:t>
+              <a:t>AF — сильная сторона. Справа предсказание модели.</a:t>
             </a:r>
           </a:p>
         </p:txBody>
@@ -861,7 +791,7 @@
           <a:lstStyle/>
           <a:p>
             <a:r>
-              <a:t>Цифры медленно. В топе чата 0.8+, но наш файл валиден и честен.</a:t>
+              <a:t>Честная история: гиганта убили, выиграл трудяга.</a:t>
             </a:r>
           </a:p>
         </p:txBody>
@@ -931,7 +861,7 @@
           <a:lstStyle/>
           <a:p>
             <a:r>
-              <a:t>Пауза. Это не мокап — живой фронт на нашем API: 17 точек, контуры по степеням, справка.</a:t>
+              <a:t>Формулу читать медленно. Файл примут с первого раза.</a:t>
             </a:r>
           </a:p>
         </p:txBody>
@@ -1001,7 +931,7 @@
           <a:lstStyle/>
           <a:p>
             <a:r>
-              <a:t>Слои выключаются, степени фильтруются, справка пересчитывается из слоёв.</a:t>
+              <a:t>Пауза: живой фронт, не мокап.</a:t>
             </a:r>
           </a:p>
         </p:txBody>
@@ -1071,7 +1001,7 @@
           <a:lstStyle/>
           <a:p>
             <a:r>
-              <a:t>API делали под фронт, фронт — под жюри. Всё состыковано.</a:t>
+              <a:t>API делали под фронт, фронт — под жюри.</a:t>
             </a:r>
           </a:p>
         </p:txBody>
@@ -1141,7 +1071,7 @@
           <a:lstStyle/>
           <a:p>
             <a:r>
-              <a:t>Оргам важно: воспроизводимость, CPU-фолбэк, инструкция в README.</a:t>
+              <a:t>Оргам важно: заведётся и у них.</a:t>
             </a:r>
           </a:p>
         </p:txBody>
@@ -4140,14 +4070,6 @@
 <file path=ppt/slides/slide1.xml><?xml version="1.0" encoding="utf-8"?>
 <p:sld xmlns:a="http://schemas.openxmlformats.org/drawingml/2006/main" xmlns:p="http://schemas.openxmlformats.org/presentationml/2006/main" xmlns:r="http://schemas.openxmlformats.org/officeDocument/2006/relationships">
   <p:cSld>
-    <p:bg>
-      <p:bgPr>
-        <a:solidFill>
-          <a:srgbClr val="070A0D"/>
-        </a:solidFill>
-        <a:effectLst/>
-      </p:bgPr>
-    </p:bg>
     <p:spTree>
       <p:nvGrpSpPr>
         <p:cNvPr id="1" name=""/>
@@ -4155,95 +4077,53 @@
         <p:nvPr/>
       </p:nvGrpSpPr>
       <p:grpSpPr/>
-      <p:sp>
-        <p:nvSpPr>
-          <p:cNvPr id="2" name="TextBox 1"/>
-          <p:cNvSpPr txBox="1"/>
-          <p:nvPr/>
-        </p:nvSpPr>
-        <p:spPr>
-          <a:xfrm>
-            <a:off x="640080" y="548640"/>
-            <a:ext cx="10881360" cy="914400"/>
+      <p:pic>
+        <p:nvPicPr>
+          <p:cNvPr id="2" name="Picture 1" descr="01-map-full.png"/>
+          <p:cNvPicPr>
+            <a:picLocks noChangeAspect="1"/>
+          </p:cNvPicPr>
+          <p:nvPr/>
+        </p:nvPicPr>
+        <p:blipFill>
+          <a:blip r:embed="rId2"/>
+          <a:stretch>
+            <a:fillRect/>
+          </a:stretch>
+        </p:blipFill>
+        <p:spPr>
+          <a:xfrm>
+            <a:off x="0" y="0"/>
+            <a:ext cx="12188952" cy="6858000"/>
           </a:xfrm>
           <a:prstGeom prst="rect">
             <a:avLst/>
           </a:prstGeom>
-          <a:noFill/>
-        </p:spPr>
-        <p:txBody>
-          <a:bodyPr wrap="square">
-            <a:spAutoFit/>
-          </a:bodyPr>
-          <a:lstStyle/>
-          <a:p>
-            <a:pPr algn="l"/>
-            <a:r>
-              <a:rPr sz="6000" b="1">
-                <a:solidFill>
-                  <a:srgbClr val="F2F4F5"/>
-                </a:solidFill>
-                <a:latin typeface="Inter"/>
-              </a:rPr>
-              <a:t>ЖИМ НОГАМИ</a:t>
-            </a:r>
-          </a:p>
-        </p:txBody>
-      </p:sp>
-      <p:sp>
-        <p:nvSpPr>
-          <p:cNvPr id="3" name="TextBox 2"/>
-          <p:cNvSpPr txBox="1"/>
-          <p:nvPr/>
-        </p:nvSpPr>
-        <p:spPr>
-          <a:xfrm>
-            <a:off x="640080" y="1737360"/>
-            <a:ext cx="10881360" cy="640080"/>
-          </a:xfrm>
-          <a:prstGeom prst="rect">
-            <a:avLst/>
-          </a:prstGeom>
-          <a:noFill/>
-        </p:spPr>
-        <p:txBody>
-          <a:bodyPr wrap="square">
-            <a:spAutoFit/>
-          </a:bodyPr>
-          <a:lstStyle/>
-          <a:p>
-            <a:pPr algn="l"/>
-            <a:r>
-              <a:rPr sz="2100" b="0">
-                <a:solidFill>
-                  <a:srgbClr val="B8C0C8"/>
-                </a:solidFill>
-                <a:latin typeface="Inter"/>
-              </a:rPr>
-              <a:t>Мониторинг лесных пожаров: от сырых снимков до живой карты за один уикенд</a:t>
-            </a:r>
-          </a:p>
-        </p:txBody>
-      </p:sp>
-      <p:sp>
-        <p:nvSpPr>
-          <p:cNvPr id="4" name="Oval 3"/>
+        </p:spPr>
+      </p:pic>
+      <p:sp>
+        <p:nvSpPr>
+          <p:cNvPr id="3" name="Rounded Rectangle 2"/>
           <p:cNvSpPr/>
           <p:nvPr/>
         </p:nvSpPr>
         <p:spPr>
           <a:xfrm>
-            <a:off x="914400" y="2962656"/>
-            <a:ext cx="155448" cy="155448"/>
-          </a:xfrm>
-          <a:prstGeom prst="ellipse">
-            <a:avLst/>
+            <a:off x="457200" y="548640"/>
+            <a:ext cx="6949440" cy="5120640"/>
+          </a:xfrm>
+          <a:prstGeom prst="roundRect">
+            <a:avLst>
+              <a:gd name="adj" fmla="val 6000"/>
+            </a:avLst>
           </a:prstGeom>
           <a:solidFill>
-            <a:srgbClr val="62D99A"/>
+            <a:srgbClr val="0D1217"/>
           </a:solidFill>
-          <a:ln>
-            <a:noFill/>
+          <a:ln w="12700">
+            <a:solidFill>
+              <a:srgbClr val="2A333D"/>
+            </a:solidFill>
           </a:ln>
         </p:spPr>
         <p:style>
@@ -4270,61 +4150,16 @@
       </p:sp>
       <p:sp>
         <p:nvSpPr>
-          <p:cNvPr id="5" name="TextBox 4"/>
-          <p:cNvSpPr txBox="1"/>
-          <p:nvPr/>
-        </p:nvSpPr>
-        <p:spPr>
-          <a:xfrm>
-            <a:off x="1280160" y="2761488"/>
-            <a:ext cx="10241280" cy="868680"/>
-          </a:xfrm>
-          <a:prstGeom prst="rect">
-            <a:avLst/>
-          </a:prstGeom>
-          <a:noFill/>
-        </p:spPr>
-        <p:txBody>
-          <a:bodyPr wrap="square">
-            <a:spAutoFit/>
-          </a:bodyPr>
-          <a:lstStyle/>
-          <a:p>
-            <a:pPr algn="l"/>
-            <a:r>
-              <a:rPr sz="2100" b="0">
-                <a:solidFill>
-                  <a:srgbClr val="F2F4F5"/>
-                </a:solidFill>
-                <a:latin typeface="Inter"/>
-              </a:rPr>
-              <a:t>Обучили две нейросети — детектор огня и картировальщик гарей</a:t>
-            </a:r>
-            <a:r>
-              <a:rPr sz="1400" b="0">
-                <a:solidFill>
-                  <a:srgbClr val="7D8690"/>
-                </a:solidFill>
-                <a:latin typeface="Inter"/>
-              </a:rPr>
-              <a:t>
-Score 0.654 · файл-ответ валиден и воспроизводим</a:t>
-            </a:r>
-          </a:p>
-        </p:txBody>
-      </p:sp>
-      <p:sp>
-        <p:nvSpPr>
-          <p:cNvPr id="6" name="Oval 5"/>
+          <p:cNvPr id="4" name="Rounded Rectangle 3"/>
           <p:cNvSpPr/>
           <p:nvPr/>
         </p:nvSpPr>
         <p:spPr>
           <a:xfrm>
-            <a:off x="914400" y="4059935"/>
-            <a:ext cx="155448" cy="155448"/>
-          </a:xfrm>
-          <a:prstGeom prst="ellipse">
+            <a:off x="457200" y="685800"/>
+            <a:ext cx="82296" cy="4846320"/>
+          </a:xfrm>
+          <a:prstGeom prst="roundRect">
             <a:avLst/>
           </a:prstGeom>
           <a:solidFill>
@@ -4358,14 +4193,14 @@
       </p:sp>
       <p:sp>
         <p:nvSpPr>
-          <p:cNvPr id="7" name="TextBox 6"/>
+          <p:cNvPr id="5" name="TextBox 4"/>
           <p:cNvSpPr txBox="1"/>
           <p:nvPr/>
         </p:nvSpPr>
         <p:spPr>
           <a:xfrm>
-            <a:off x="1280160" y="3858768"/>
-            <a:ext cx="10241280" cy="868680"/>
+            <a:off x="822960" y="822960"/>
+            <a:ext cx="6309360" cy="457200"/>
           </a:xfrm>
           <a:prstGeom prst="rect">
             <a:avLst/>
@@ -4380,46 +4215,258 @@
           <a:p>
             <a:pPr algn="l"/>
             <a:r>
-              <a:rPr sz="2100" b="0">
-                <a:solidFill>
-                  <a:srgbClr val="F2F4F5"/>
+              <a:rPr sz="1500" b="1">
+                <a:solidFill>
+                  <a:srgbClr val="62D99A"/>
                 </a:solidFill>
                 <a:latin typeface="Inter"/>
               </a:rPr>
-              <a:t>Подняли сервис и тёмную веб-карту с точками, контурами и справкой</a:t>
-            </a:r>
-            <a:r>
-              <a:rPr sz="1400" b="0">
-                <a:solidFill>
-                  <a:srgbClr val="7D8690"/>
+              <a:t>KOSMOHACK 2026 · SCORE 0.654</a:t>
+            </a:r>
+          </a:p>
+        </p:txBody>
+      </p:sp>
+      <p:sp>
+        <p:nvSpPr>
+          <p:cNvPr id="6" name="TextBox 5"/>
+          <p:cNvSpPr txBox="1"/>
+          <p:nvPr/>
+        </p:nvSpPr>
+        <p:spPr>
+          <a:xfrm>
+            <a:off x="822960" y="1280160"/>
+            <a:ext cx="6309360" cy="1737360"/>
+          </a:xfrm>
+          <a:prstGeom prst="rect">
+            <a:avLst/>
+          </a:prstGeom>
+          <a:noFill/>
+        </p:spPr>
+        <p:txBody>
+          <a:bodyPr wrap="square">
+            <a:spAutoFit/>
+          </a:bodyPr>
+          <a:lstStyle/>
+          <a:p>
+            <a:pPr algn="l"/>
+            <a:r>
+              <a:rPr sz="7200" b="1">
+                <a:solidFill>
+                  <a:srgbClr val="F2F4F5"/>
                 </a:solidFill>
                 <a:latin typeface="Inter"/>
               </a:rPr>
-              <a:t>
-то, что вы увидите дальше — работает прямо сейчас</a:t>
-            </a:r>
-          </a:p>
-        </p:txBody>
-      </p:sp>
-      <p:sp>
-        <p:nvSpPr>
-          <p:cNvPr id="8" name="Oval 7"/>
+              <a:t>ЖИМ
+НОГАМИ</a:t>
+            </a:r>
+          </a:p>
+        </p:txBody>
+      </p:sp>
+      <p:sp>
+        <p:nvSpPr>
+          <p:cNvPr id="7" name="TextBox 6"/>
+          <p:cNvSpPr txBox="1"/>
+          <p:nvPr/>
+        </p:nvSpPr>
+        <p:spPr>
+          <a:xfrm>
+            <a:off x="822960" y="3749039"/>
+            <a:ext cx="6309360" cy="914400"/>
+          </a:xfrm>
+          <a:prstGeom prst="rect">
+            <a:avLst/>
+          </a:prstGeom>
+          <a:noFill/>
+        </p:spPr>
+        <p:txBody>
+          <a:bodyPr wrap="square">
+            <a:spAutoFit/>
+          </a:bodyPr>
+          <a:lstStyle/>
+          <a:p>
+            <a:pPr algn="l"/>
+            <a:r>
+              <a:rPr sz="2100" b="0">
+                <a:solidFill>
+                  <a:srgbClr val="B8C0C8"/>
+                </a:solidFill>
+                <a:latin typeface="Inter"/>
+              </a:rPr>
+              <a:t>Мониторинг лесных пожаров — от снимков до живой карты за уикенд</a:t>
+            </a:r>
+          </a:p>
+        </p:txBody>
+      </p:sp>
+      <p:sp>
+        <p:nvSpPr>
+          <p:cNvPr id="8" name="TextBox 7"/>
+          <p:cNvSpPr txBox="1"/>
+          <p:nvPr/>
+        </p:nvSpPr>
+        <p:spPr>
+          <a:xfrm>
+            <a:off x="822960" y="4754880"/>
+            <a:ext cx="6309360" cy="365760"/>
+          </a:xfrm>
+          <a:prstGeom prst="rect">
+            <a:avLst/>
+          </a:prstGeom>
+          <a:noFill/>
+        </p:spPr>
+        <p:txBody>
+          <a:bodyPr wrap="square">
+            <a:spAutoFit/>
+          </a:bodyPr>
+          <a:lstStyle/>
+          <a:p>
+            <a:pPr algn="l"/>
+            <a:r>
+              <a:rPr sz="1500" b="0">
+                <a:solidFill>
+                  <a:srgbClr val="7D8690"/>
+                </a:solidFill>
+                <a:latin typeface="Inter"/>
+              </a:rPr>
+              <a:t>AF-детекция · BS-гари · сервис · submission FINAL</a:t>
+            </a:r>
+          </a:p>
+        </p:txBody>
+      </p:sp>
+      <p:sp>
+        <p:nvSpPr>
+          <p:cNvPr id="9" name="TextBox 8"/>
+          <p:cNvSpPr txBox="1"/>
+          <p:nvPr/>
+        </p:nvSpPr>
+        <p:spPr>
+          <a:xfrm>
+            <a:off x="457200" y="6400800"/>
+            <a:ext cx="7315200" cy="274320"/>
+          </a:xfrm>
+          <a:prstGeom prst="rect">
+            <a:avLst/>
+          </a:prstGeom>
+          <a:noFill/>
+        </p:spPr>
+        <p:txBody>
+          <a:bodyPr wrap="square">
+            <a:spAutoFit/>
+          </a:bodyPr>
+          <a:lstStyle/>
+          <a:p>
+            <a:pPr algn="l"/>
+            <a:r>
+              <a:rPr sz="1100" b="1">
+                <a:solidFill>
+                  <a:srgbClr val="7D8690"/>
+                </a:solidFill>
+                <a:latin typeface="Inter"/>
+              </a:rPr>
+              <a:t>ЖИМ НОГАМИ · KOSMOHACK 2026</a:t>
+            </a:r>
+          </a:p>
+        </p:txBody>
+      </p:sp>
+      <p:sp>
+        <p:nvSpPr>
+          <p:cNvPr id="10" name="TextBox 9"/>
+          <p:cNvSpPr txBox="1"/>
+          <p:nvPr/>
+        </p:nvSpPr>
+        <p:spPr>
+          <a:xfrm>
+            <a:off x="10789920" y="6400800"/>
+            <a:ext cx="914400" cy="274320"/>
+          </a:xfrm>
+          <a:prstGeom prst="rect">
+            <a:avLst/>
+          </a:prstGeom>
+          <a:noFill/>
+        </p:spPr>
+        <p:txBody>
+          <a:bodyPr wrap="square">
+            <a:spAutoFit/>
+          </a:bodyPr>
+          <a:lstStyle/>
+          <a:p>
+            <a:pPr algn="r"/>
+            <a:r>
+              <a:rPr sz="1100" b="1">
+                <a:solidFill>
+                  <a:srgbClr val="7D8690"/>
+                </a:solidFill>
+                <a:latin typeface="Inter"/>
+              </a:rPr>
+              <a:t>01</a:t>
+            </a:r>
+          </a:p>
+        </p:txBody>
+      </p:sp>
+    </p:spTree>
+  </p:cSld>
+  <p:clrMapOvr>
+    <a:masterClrMapping/>
+  </p:clrMapOvr>
+</p:sld>
+</file>
+
+<file path=ppt/slides/slide10.xml><?xml version="1.0" encoding="utf-8"?>
+<p:sld xmlns:a="http://schemas.openxmlformats.org/drawingml/2006/main" xmlns:p="http://schemas.openxmlformats.org/presentationml/2006/main" xmlns:r="http://schemas.openxmlformats.org/officeDocument/2006/relationships">
+  <p:cSld>
+    <p:spTree>
+      <p:nvGrpSpPr>
+        <p:cNvPr id="1" name=""/>
+        <p:cNvGrpSpPr/>
+        <p:nvPr/>
+      </p:nvGrpSpPr>
+      <p:grpSpPr/>
+      <p:pic>
+        <p:nvPicPr>
+          <p:cNvPr id="2" name="Picture 1" descr="02-burned-only.png"/>
+          <p:cNvPicPr>
+            <a:picLocks noChangeAspect="1"/>
+          </p:cNvPicPr>
+          <p:nvPr/>
+        </p:nvPicPr>
+        <p:blipFill>
+          <a:blip r:embed="rId2"/>
+          <a:stretch>
+            <a:fillRect/>
+          </a:stretch>
+        </p:blipFill>
+        <p:spPr>
+          <a:xfrm>
+            <a:off x="0" y="0"/>
+            <a:ext cx="12188952" cy="6858000"/>
+          </a:xfrm>
+          <a:prstGeom prst="rect">
+            <a:avLst/>
+          </a:prstGeom>
+        </p:spPr>
+      </p:pic>
+      <p:sp>
+        <p:nvSpPr>
+          <p:cNvPr id="3" name="Rounded Rectangle 2"/>
           <p:cNvSpPr/>
           <p:nvPr/>
         </p:nvSpPr>
         <p:spPr>
           <a:xfrm>
-            <a:off x="914400" y="5157216"/>
-            <a:ext cx="155448" cy="155448"/>
-          </a:xfrm>
-          <a:prstGeom prst="ellipse">
-            <a:avLst/>
+            <a:off x="2926080" y="1463040"/>
+            <a:ext cx="6309360" cy="3657600"/>
+          </a:xfrm>
+          <a:prstGeom prst="roundRect">
+            <a:avLst>
+              <a:gd name="adj" fmla="val 6000"/>
+            </a:avLst>
           </a:prstGeom>
           <a:solidFill>
-            <a:srgbClr val="F2F4F5"/>
+            <a:srgbClr val="0D1217"/>
           </a:solidFill>
-          <a:ln>
-            <a:noFill/>
+          <a:ln w="12700">
+            <a:solidFill>
+              <a:srgbClr val="2A333D"/>
+            </a:solidFill>
           </a:ln>
         </p:spPr>
         <p:style>
@@ -4446,161 +4493,20 @@
       </p:sp>
       <p:sp>
         <p:nvSpPr>
-          <p:cNvPr id="9" name="TextBox 8"/>
-          <p:cNvSpPr txBox="1"/>
-          <p:nvPr/>
-        </p:nvSpPr>
-        <p:spPr>
-          <a:xfrm>
-            <a:off x="1280160" y="4956048"/>
-            <a:ext cx="10241280" cy="868680"/>
-          </a:xfrm>
-          <a:prstGeom prst="rect">
-            <a:avLst/>
-          </a:prstGeom>
-          <a:noFill/>
-        </p:spPr>
-        <p:txBody>
-          <a:bodyPr wrap="square">
-            <a:spAutoFit/>
-          </a:bodyPr>
-          <a:lstStyle/>
-          <a:p>
-            <a:pPr algn="l"/>
-            <a:r>
-              <a:rPr sz="2100" b="0">
-                <a:solidFill>
-                  <a:srgbClr val="F2F4F5"/>
-                </a:solidFill>
-                <a:latin typeface="Inter"/>
-              </a:rPr>
-              <a:t>Всё открыто: код, веса, отчёт</a:t>
-            </a:r>
-            <a:r>
-              <a:rPr sz="1400" b="0">
-                <a:solidFill>
-                  <a:srgbClr val="7D8690"/>
-                </a:solidFill>
-                <a:latin typeface="Inter"/>
-              </a:rPr>
-              <a:t>
-клонируй и запускай одной командой</a:t>
-            </a:r>
-          </a:p>
-        </p:txBody>
-      </p:sp>
-    </p:spTree>
-  </p:cSld>
-  <p:clrMapOvr>
-    <a:masterClrMapping/>
-  </p:clrMapOvr>
-</p:sld>
-</file>
-
-<file path=ppt/slides/slide10.xml><?xml version="1.0" encoding="utf-8"?>
-<p:sld xmlns:a="http://schemas.openxmlformats.org/drawingml/2006/main" xmlns:p="http://schemas.openxmlformats.org/presentationml/2006/main" xmlns:r="http://schemas.openxmlformats.org/officeDocument/2006/relationships">
-  <p:cSld>
-    <p:bg>
-      <p:bgPr>
-        <a:solidFill>
-          <a:srgbClr val="070A0D"/>
-        </a:solidFill>
-        <a:effectLst/>
-      </p:bgPr>
-    </p:bg>
-    <p:spTree>
-      <p:nvGrpSpPr>
-        <p:cNvPr id="1" name=""/>
-        <p:cNvGrpSpPr/>
-        <p:nvPr/>
-      </p:nvGrpSpPr>
-      <p:grpSpPr/>
-      <p:sp>
-        <p:nvSpPr>
-          <p:cNvPr id="2" name="TextBox 1"/>
-          <p:cNvSpPr txBox="1"/>
-          <p:nvPr/>
-        </p:nvSpPr>
-        <p:spPr>
-          <a:xfrm>
-            <a:off x="640080" y="1645920"/>
-            <a:ext cx="10881360" cy="1097280"/>
-          </a:xfrm>
-          <a:prstGeom prst="rect">
-            <a:avLst/>
-          </a:prstGeom>
-          <a:noFill/>
-        </p:spPr>
-        <p:txBody>
-          <a:bodyPr wrap="square">
-            <a:spAutoFit/>
-          </a:bodyPr>
-          <a:lstStyle/>
-          <a:p>
-            <a:pPr algn="ctr"/>
-            <a:r>
-              <a:rPr sz="6400" b="1">
-                <a:solidFill>
-                  <a:srgbClr val="F2F4F5"/>
-                </a:solidFill>
-                <a:latin typeface="Inter"/>
-              </a:rPr>
-              <a:t>ЖИМ НОГАМИ</a:t>
-            </a:r>
-          </a:p>
-        </p:txBody>
-      </p:sp>
-      <p:sp>
-        <p:nvSpPr>
-          <p:cNvPr id="3" name="TextBox 2"/>
-          <p:cNvSpPr txBox="1"/>
-          <p:nvPr/>
-        </p:nvSpPr>
-        <p:spPr>
-          <a:xfrm>
-            <a:off x="640080" y="3017520"/>
-            <a:ext cx="10881360" cy="731520"/>
-          </a:xfrm>
-          <a:prstGeom prst="rect">
-            <a:avLst/>
-          </a:prstGeom>
-          <a:noFill/>
-        </p:spPr>
-        <p:txBody>
-          <a:bodyPr wrap="square">
-            <a:spAutoFit/>
-          </a:bodyPr>
-          <a:lstStyle/>
-          <a:p>
-            <a:pPr algn="ctr"/>
-            <a:r>
-              <a:rPr sz="2200" b="0">
-                <a:solidFill>
-                  <a:srgbClr val="B8C0C8"/>
-                </a:solidFill>
-                <a:latin typeface="Inter"/>
-              </a:rPr>
-              <a:t>код, веса и отчёт — в репозитории · вопросы?</a:t>
-            </a:r>
-          </a:p>
-        </p:txBody>
-      </p:sp>
-      <p:sp>
-        <p:nvSpPr>
-          <p:cNvPr id="4" name="Oval 3"/>
+          <p:cNvPr id="4" name="Rounded Rectangle 3"/>
           <p:cNvSpPr/>
           <p:nvPr/>
         </p:nvSpPr>
         <p:spPr>
           <a:xfrm>
-            <a:off x="5989320" y="4389120"/>
-            <a:ext cx="182880" cy="182880"/>
-          </a:xfrm>
-          <a:prstGeom prst="ellipse">
+            <a:off x="2926080" y="1600200"/>
+            <a:ext cx="82296" cy="3383280"/>
+          </a:xfrm>
+          <a:prstGeom prst="roundRect">
             <a:avLst/>
           </a:prstGeom>
           <a:solidFill>
-            <a:srgbClr val="62D99A"/>
+            <a:srgbClr val="FF6B35"/>
           </a:solidFill>
           <a:ln>
             <a:noFill/>
@@ -4628,6 +4534,112 @@
           </a:p>
         </p:txBody>
       </p:sp>
+      <p:sp>
+        <p:nvSpPr>
+          <p:cNvPr id="5" name="TextBox 4"/>
+          <p:cNvSpPr txBox="1"/>
+          <p:nvPr/>
+        </p:nvSpPr>
+        <p:spPr>
+          <a:xfrm>
+            <a:off x="2926080" y="1737360"/>
+            <a:ext cx="6309360" cy="914400"/>
+          </a:xfrm>
+          <a:prstGeom prst="rect">
+            <a:avLst/>
+          </a:prstGeom>
+          <a:noFill/>
+        </p:spPr>
+        <p:txBody>
+          <a:bodyPr wrap="square">
+            <a:spAutoFit/>
+          </a:bodyPr>
+          <a:lstStyle/>
+          <a:p>
+            <a:pPr algn="ctr"/>
+            <a:r>
+              <a:rPr sz="5200" b="1">
+                <a:solidFill>
+                  <a:srgbClr val="F2F4F5"/>
+                </a:solidFill>
+                <a:latin typeface="Inter"/>
+              </a:rPr>
+              <a:t>ЖИМ НОГАМИ</a:t>
+            </a:r>
+          </a:p>
+        </p:txBody>
+      </p:sp>
+      <p:sp>
+        <p:nvSpPr>
+          <p:cNvPr id="6" name="TextBox 5"/>
+          <p:cNvSpPr txBox="1"/>
+          <p:nvPr/>
+        </p:nvSpPr>
+        <p:spPr>
+          <a:xfrm>
+            <a:off x="2926080" y="2926080"/>
+            <a:ext cx="6309360" cy="1097280"/>
+          </a:xfrm>
+          <a:prstGeom prst="rect">
+            <a:avLst/>
+          </a:prstGeom>
+          <a:noFill/>
+        </p:spPr>
+        <p:txBody>
+          <a:bodyPr wrap="square">
+            <a:spAutoFit/>
+          </a:bodyPr>
+          <a:lstStyle/>
+          <a:p>
+            <a:pPr algn="ctr"/>
+            <a:r>
+              <a:rPr sz="2000" b="0">
+                <a:solidFill>
+                  <a:srgbClr val="B8C0C8"/>
+                </a:solidFill>
+                <a:latin typeface="Inter"/>
+              </a:rPr>
+              <a:t>спасибо · вопросы?
+код, веса и отчёт — в репозитории</a:t>
+            </a:r>
+          </a:p>
+        </p:txBody>
+      </p:sp>
+      <p:sp>
+        <p:nvSpPr>
+          <p:cNvPr id="7" name="TextBox 6"/>
+          <p:cNvSpPr txBox="1"/>
+          <p:nvPr/>
+        </p:nvSpPr>
+        <p:spPr>
+          <a:xfrm>
+            <a:off x="2926080" y="4389120"/>
+            <a:ext cx="6309360" cy="365760"/>
+          </a:xfrm>
+          <a:prstGeom prst="rect">
+            <a:avLst/>
+          </a:prstGeom>
+          <a:noFill/>
+        </p:spPr>
+        <p:txBody>
+          <a:bodyPr wrap="square">
+            <a:spAutoFit/>
+          </a:bodyPr>
+          <a:lstStyle/>
+          <a:p>
+            <a:pPr algn="ctr"/>
+            <a:r>
+              <a:rPr sz="1400" b="0">
+                <a:solidFill>
+                  <a:srgbClr val="7D8690"/>
+                </a:solidFill>
+                <a:latin typeface="Inter"/>
+              </a:rPr>
+              <a:t>Score 0.654 · submission FINAL</a:t>
+            </a:r>
+          </a:p>
+        </p:txBody>
+      </p:sp>
     </p:spTree>
   </p:cSld>
   <p:clrMapOvr>
@@ -4639,14 +4651,6 @@
 <file path=ppt/slides/slide2.xml><?xml version="1.0" encoding="utf-8"?>
 <p:sld xmlns:a="http://schemas.openxmlformats.org/drawingml/2006/main" xmlns:p="http://schemas.openxmlformats.org/presentationml/2006/main" xmlns:r="http://schemas.openxmlformats.org/officeDocument/2006/relationships">
   <p:cSld>
-    <p:bg>
-      <p:bgPr>
-        <a:solidFill>
-          <a:srgbClr val="070A0D"/>
-        </a:solidFill>
-        <a:effectLst/>
-      </p:bgPr>
-    </p:bg>
     <p:spTree>
       <p:nvGrpSpPr>
         <p:cNvPr id="1" name=""/>
@@ -4654,60 +4658,53 @@
         <p:nvPr/>
       </p:nvGrpSpPr>
       <p:grpSpPr/>
-      <p:sp>
-        <p:nvSpPr>
-          <p:cNvPr id="2" name="TextBox 1"/>
-          <p:cNvSpPr txBox="1"/>
-          <p:nvPr/>
-        </p:nvSpPr>
-        <p:spPr>
-          <a:xfrm>
-            <a:off x="640080" y="274320"/>
-            <a:ext cx="10881360" cy="365760"/>
+      <p:pic>
+        <p:nvPicPr>
+          <p:cNvPr id="2" name="Picture 1" descr="02-burned-only.png"/>
+          <p:cNvPicPr>
+            <a:picLocks noChangeAspect="1"/>
+          </p:cNvPicPr>
+          <p:nvPr/>
+        </p:nvPicPr>
+        <p:blipFill>
+          <a:blip r:embed="rId2"/>
+          <a:stretch>
+            <a:fillRect/>
+          </a:stretch>
+        </p:blipFill>
+        <p:spPr>
+          <a:xfrm>
+            <a:off x="0" y="0"/>
+            <a:ext cx="12188952" cy="6858000"/>
           </a:xfrm>
           <a:prstGeom prst="rect">
             <a:avLst/>
           </a:prstGeom>
-          <a:noFill/>
-        </p:spPr>
-        <p:txBody>
-          <a:bodyPr wrap="square">
-            <a:spAutoFit/>
-          </a:bodyPr>
-          <a:lstStyle/>
-          <a:p>
-            <a:pPr algn="l"/>
-            <a:r>
-              <a:rPr sz="1200" b="1">
-                <a:solidFill>
-                  <a:srgbClr val="7D8690"/>
-                </a:solidFill>
-                <a:latin typeface="Inter"/>
-              </a:rPr>
-              <a:t>ЖИМ НОГАМИ · KOSMOHACK</a:t>
-            </a:r>
-          </a:p>
-        </p:txBody>
-      </p:sp>
-      <p:sp>
-        <p:nvSpPr>
-          <p:cNvPr id="3" name="Oval 2"/>
+        </p:spPr>
+      </p:pic>
+      <p:sp>
+        <p:nvSpPr>
+          <p:cNvPr id="3" name="Rounded Rectangle 2"/>
           <p:cNvSpPr/>
           <p:nvPr/>
         </p:nvSpPr>
         <p:spPr>
           <a:xfrm>
-            <a:off x="11658600" y="384048"/>
-            <a:ext cx="128016" cy="128016"/>
-          </a:xfrm>
-          <a:prstGeom prst="ellipse">
-            <a:avLst/>
+            <a:off x="457200" y="457200"/>
+            <a:ext cx="5669280" cy="5486400"/>
+          </a:xfrm>
+          <a:prstGeom prst="roundRect">
+            <a:avLst>
+              <a:gd name="adj" fmla="val 6000"/>
+            </a:avLst>
           </a:prstGeom>
           <a:solidFill>
-            <a:srgbClr val="62D99A"/>
+            <a:srgbClr val="0D1217"/>
           </a:solidFill>
-          <a:ln>
-            <a:noFill/>
+          <a:ln w="12700">
+            <a:solidFill>
+              <a:srgbClr val="2A333D"/>
+            </a:solidFill>
           </a:ln>
         </p:spPr>
         <p:style>
@@ -4734,55 +4731,20 @@
       </p:sp>
       <p:sp>
         <p:nvSpPr>
-          <p:cNvPr id="4" name="TextBox 3"/>
-          <p:cNvSpPr txBox="1"/>
-          <p:nvPr/>
-        </p:nvSpPr>
-        <p:spPr>
-          <a:xfrm>
-            <a:off x="640080" y="777240"/>
-            <a:ext cx="10881360" cy="1097280"/>
-          </a:xfrm>
-          <a:prstGeom prst="rect">
-            <a:avLst/>
-          </a:prstGeom>
-          <a:noFill/>
-        </p:spPr>
-        <p:txBody>
-          <a:bodyPr wrap="square">
-            <a:spAutoFit/>
-          </a:bodyPr>
-          <a:lstStyle/>
-          <a:p>
-            <a:pPr algn="l"/>
-            <a:r>
-              <a:rPr sz="3800" b="1">
-                <a:solidFill>
-                  <a:srgbClr val="F2F4F5"/>
-                </a:solidFill>
-                <a:latin typeface="Inter"/>
-              </a:rPr>
-              <a:t>Сначала — разобрали данные до винтика</a:t>
-            </a:r>
-          </a:p>
-        </p:txBody>
-      </p:sp>
-      <p:sp>
-        <p:nvSpPr>
-          <p:cNvPr id="5" name="Oval 4"/>
+          <p:cNvPr id="4" name="Rounded Rectangle 3"/>
           <p:cNvSpPr/>
           <p:nvPr/>
         </p:nvSpPr>
         <p:spPr>
           <a:xfrm>
-            <a:off x="914400" y="2414016"/>
-            <a:ext cx="155448" cy="155448"/>
-          </a:xfrm>
-          <a:prstGeom prst="ellipse">
+            <a:off x="457200" y="594360"/>
+            <a:ext cx="82296" cy="5212080"/>
+          </a:xfrm>
+          <a:prstGeom prst="roundRect">
             <a:avLst/>
           </a:prstGeom>
           <a:solidFill>
-            <a:srgbClr val="E6C65C"/>
+            <a:srgbClr val="FF6B35"/>
           </a:solidFill>
           <a:ln>
             <a:noFill/>
@@ -4812,14 +4774,14 @@
       </p:sp>
       <p:sp>
         <p:nvSpPr>
-          <p:cNvPr id="6" name="TextBox 5"/>
+          <p:cNvPr id="5" name="TextBox 4"/>
           <p:cNvSpPr txBox="1"/>
           <p:nvPr/>
         </p:nvSpPr>
         <p:spPr>
           <a:xfrm>
-            <a:off x="1280160" y="2212848"/>
-            <a:ext cx="10241280" cy="868680"/>
+            <a:off x="822960" y="685800"/>
+            <a:ext cx="5029200" cy="457200"/>
           </a:xfrm>
           <a:prstGeom prst="rect">
             <a:avLst/>
@@ -4834,23 +4796,49 @@
           <a:p>
             <a:pPr algn="l"/>
             <a:r>
-              <a:rPr sz="2100" b="0">
-                <a:solidFill>
-                  <a:srgbClr val="F2F4F5"/>
+              <a:rPr sz="1500" b="1">
+                <a:solidFill>
+                  <a:srgbClr val="FF6B35"/>
                 </a:solidFill>
                 <a:latin typeface="Inter"/>
               </a:rPr>
-              <a:t>Огня в выборке 0.035% — 21 пиксель на снимок</a:t>
-            </a:r>
-            <a:r>
-              <a:rPr sz="1400" b="0">
-                <a:solidFill>
-                  <a:srgbClr val="7D8690"/>
+              <a:t>Проблема</a:t>
+            </a:r>
+          </a:p>
+        </p:txBody>
+      </p:sp>
+      <p:sp>
+        <p:nvSpPr>
+          <p:cNvPr id="6" name="TextBox 5"/>
+          <p:cNvSpPr txBox="1"/>
+          <p:nvPr/>
+        </p:nvSpPr>
+        <p:spPr>
+          <a:xfrm>
+            <a:off x="822960" y="1143000"/>
+            <a:ext cx="5029200" cy="1005840"/>
+          </a:xfrm>
+          <a:prstGeom prst="rect">
+            <a:avLst/>
+          </a:prstGeom>
+          <a:noFill/>
+        </p:spPr>
+        <p:txBody>
+          <a:bodyPr wrap="square">
+            <a:spAutoFit/>
+          </a:bodyPr>
+          <a:lstStyle/>
+          <a:p>
+            <a:pPr algn="l"/>
+            <a:r>
+              <a:rPr sz="4000" b="1">
+                <a:solidFill>
+                  <a:srgbClr val="F2F4F5"/>
                 </a:solidFill>
                 <a:latin typeface="Inter"/>
               </a:rPr>
-              <a:t>
-поэтому oversample, Dice+Focal и порог по micro-метрике, а не по средней</a:t>
+              <a:t>Огонь видно.
+Заводы — тоже</a:t>
             </a:r>
           </a:p>
         </p:txBody>
@@ -4863,14 +4851,14 @@
         </p:nvSpPr>
         <p:spPr>
           <a:xfrm>
-            <a:off x="914400" y="3557016"/>
+            <a:off x="822960" y="3383280"/>
             <a:ext cx="155448" cy="155448"/>
           </a:xfrm>
           <a:prstGeom prst="ellipse">
             <a:avLst/>
           </a:prstGeom>
           <a:solidFill>
-            <a:srgbClr val="FF6B35"/>
+            <a:srgbClr val="EF5B5B"/>
           </a:solidFill>
           <a:ln>
             <a:noFill/>
@@ -4906,8 +4894,8 @@
         </p:nvSpPr>
         <p:spPr>
           <a:xfrm>
-            <a:off x="1280160" y="3355848"/>
-            <a:ext cx="10241280" cy="868680"/>
+            <a:off x="1097280" y="3310128"/>
+            <a:ext cx="4572000" cy="548640"/>
           </a:xfrm>
           <a:prstGeom prst="rect">
             <a:avLst/>
@@ -4922,23 +4910,13 @@
           <a:p>
             <a:pPr algn="l"/>
             <a:r>
-              <a:rPr sz="2100" b="0">
-                <a:solidFill>
-                  <a:srgbClr val="F2F4F5"/>
+              <a:rPr sz="1900" b="0">
+                <a:solidFill>
+                  <a:srgbClr val="B8C0C8"/>
                 </a:solidFill>
                 <a:latin typeface="Inter"/>
               </a:rPr>
-              <a:t>Метаданным не поверили и правильно сделали</a:t>
-            </a:r>
-            <a:r>
-              <a:rPr sz="1400" b="0">
-                <a:solidFill>
-                  <a:srgbClr val="7D8690"/>
-                </a:solidFill>
-                <a:latin typeface="Inter"/>
-              </a:rPr>
-              <a:t>
-облачность из таблицы не сошлась с растрами — взяли маску из снимков</a:t>
+              <a:t>Ложняки FIRMS на факелах и ТЭЦ</a:t>
             </a:r>
           </a:p>
         </p:txBody>
@@ -4951,14 +4929,14 @@
         </p:nvSpPr>
         <p:spPr>
           <a:xfrm>
-            <a:off x="914400" y="4700016"/>
+            <a:off x="822960" y="4069080"/>
             <a:ext cx="155448" cy="155448"/>
           </a:xfrm>
           <a:prstGeom prst="ellipse">
             <a:avLst/>
           </a:prstGeom>
           <a:solidFill>
-            <a:srgbClr val="62D99A"/>
+            <a:srgbClr val="E6C65C"/>
           </a:solidFill>
           <a:ln>
             <a:noFill/>
@@ -4994,8 +4972,8 @@
         </p:nvSpPr>
         <p:spPr>
           <a:xfrm>
-            <a:off x="1280160" y="4498848"/>
-            <a:ext cx="10241280" cy="868680"/>
+            <a:off x="1097280" y="3995928"/>
+            <a:ext cx="4572000" cy="548640"/>
           </a:xfrm>
           <a:prstGeom prst="rect">
             <a:avLst/>
@@ -5010,23 +4988,161 @@
           <a:p>
             <a:pPr algn="l"/>
             <a:r>
-              <a:rPr sz="2100" b="0">
-                <a:solidFill>
-                  <a:srgbClr val="F2F4F5"/>
+              <a:rPr sz="1900" b="0">
+                <a:solidFill>
+                  <a:srgbClr val="B8C0C8"/>
                 </a:solidFill>
                 <a:latin typeface="Inter"/>
               </a:rPr>
-              <a:t>Пороги гарей вывели под каждый ландшафт</a:t>
-            </a:r>
-            <a:r>
-              <a:rPr sz="1400" b="0">
-                <a:solidFill>
-                  <a:srgbClr val="7D8690"/>
+              <a:t>Пропуски малых очагов и дыма</a:t>
+            </a:r>
+          </a:p>
+        </p:txBody>
+      </p:sp>
+      <p:sp>
+        <p:nvSpPr>
+          <p:cNvPr id="11" name="Oval 10"/>
+          <p:cNvSpPr/>
+          <p:nvPr/>
+        </p:nvSpPr>
+        <p:spPr>
+          <a:xfrm>
+            <a:off x="822960" y="4754880"/>
+            <a:ext cx="155448" cy="155448"/>
+          </a:xfrm>
+          <a:prstGeom prst="ellipse">
+            <a:avLst/>
+          </a:prstGeom>
+          <a:solidFill>
+            <a:srgbClr val="FF6B35"/>
+          </a:solidFill>
+          <a:ln>
+            <a:noFill/>
+          </a:ln>
+        </p:spPr>
+        <p:style>
+          <a:lnRef idx="1">
+            <a:schemeClr val="accent1"/>
+          </a:lnRef>
+          <a:fillRef idx="3">
+            <a:schemeClr val="accent1"/>
+          </a:fillRef>
+          <a:effectRef idx="2">
+            <a:schemeClr val="accent1"/>
+          </a:effectRef>
+          <a:fontRef idx="minor">
+            <a:schemeClr val="lt1"/>
+          </a:fontRef>
+        </p:style>
+        <p:txBody>
+          <a:bodyPr rtlCol="0" anchor="ctr"/>
+          <a:lstStyle/>
+          <a:p>
+            <a:pPr algn="ctr"/>
+          </a:p>
+        </p:txBody>
+      </p:sp>
+      <p:sp>
+        <p:nvSpPr>
+          <p:cNvPr id="12" name="TextBox 11"/>
+          <p:cNvSpPr txBox="1"/>
+          <p:nvPr/>
+        </p:nvSpPr>
+        <p:spPr>
+          <a:xfrm>
+            <a:off x="1097280" y="4681728"/>
+            <a:ext cx="4572000" cy="548640"/>
+          </a:xfrm>
+          <a:prstGeom prst="rect">
+            <a:avLst/>
+          </a:prstGeom>
+          <a:noFill/>
+        </p:spPr>
+        <p:txBody>
+          <a:bodyPr wrap="square">
+            <a:spAutoFit/>
+          </a:bodyPr>
+          <a:lstStyle/>
+          <a:p>
+            <a:pPr algn="l"/>
+            <a:r>
+              <a:rPr sz="1900" b="0">
+                <a:solidFill>
+                  <a:srgbClr val="B8C0C8"/>
                 </a:solidFill>
                 <a:latin typeface="Inter"/>
               </a:rPr>
-              <a:t>
-лес, степь, пашня и пойма горят по-разному — один порог врёт всем</a:t>
+              <a:t>Гари считают вручную, неделями</a:t>
+            </a:r>
+          </a:p>
+        </p:txBody>
+      </p:sp>
+      <p:sp>
+        <p:nvSpPr>
+          <p:cNvPr id="13" name="TextBox 12"/>
+          <p:cNvSpPr txBox="1"/>
+          <p:nvPr/>
+        </p:nvSpPr>
+        <p:spPr>
+          <a:xfrm>
+            <a:off x="457200" y="6400800"/>
+            <a:ext cx="7315200" cy="274320"/>
+          </a:xfrm>
+          <a:prstGeom prst="rect">
+            <a:avLst/>
+          </a:prstGeom>
+          <a:noFill/>
+        </p:spPr>
+        <p:txBody>
+          <a:bodyPr wrap="square">
+            <a:spAutoFit/>
+          </a:bodyPr>
+          <a:lstStyle/>
+          <a:p>
+            <a:pPr algn="l"/>
+            <a:r>
+              <a:rPr sz="1100" b="1">
+                <a:solidFill>
+                  <a:srgbClr val="7D8690"/>
+                </a:solidFill>
+                <a:latin typeface="Inter"/>
+              </a:rPr>
+              <a:t>ЖИМ НОГАМИ · KOSMOHACK 2026</a:t>
+            </a:r>
+          </a:p>
+        </p:txBody>
+      </p:sp>
+      <p:sp>
+        <p:nvSpPr>
+          <p:cNvPr id="14" name="TextBox 13"/>
+          <p:cNvSpPr txBox="1"/>
+          <p:nvPr/>
+        </p:nvSpPr>
+        <p:spPr>
+          <a:xfrm>
+            <a:off x="10789920" y="6400800"/>
+            <a:ext cx="914400" cy="274320"/>
+          </a:xfrm>
+          <a:prstGeom prst="rect">
+            <a:avLst/>
+          </a:prstGeom>
+          <a:noFill/>
+        </p:spPr>
+        <p:txBody>
+          <a:bodyPr wrap="square">
+            <a:spAutoFit/>
+          </a:bodyPr>
+          <a:lstStyle/>
+          <a:p>
+            <a:pPr algn="r"/>
+            <a:r>
+              <a:rPr sz="1100" b="1">
+                <a:solidFill>
+                  <a:srgbClr val="7D8690"/>
+                </a:solidFill>
+                <a:latin typeface="Inter"/>
+              </a:rPr>
+              <a:t>02</a:t>
             </a:r>
           </a:p>
         </p:txBody>
@@ -5065,8 +5181,8 @@
         </p:nvSpPr>
         <p:spPr>
           <a:xfrm>
-            <a:off x="640080" y="274320"/>
-            <a:ext cx="10881360" cy="365760"/>
+            <a:off x="640080" y="457200"/>
+            <a:ext cx="10881360" cy="731520"/>
           </a:xfrm>
           <a:prstGeom prst="rect">
             <a:avLst/>
@@ -5081,36 +5197,40 @@
           <a:p>
             <a:pPr algn="l"/>
             <a:r>
-              <a:rPr sz="1200" b="1">
-                <a:solidFill>
-                  <a:srgbClr val="7D8690"/>
+              <a:rPr sz="3800" b="1">
+                <a:solidFill>
+                  <a:srgbClr val="F2F4F5"/>
                 </a:solidFill>
                 <a:latin typeface="Inter"/>
               </a:rPr>
-              <a:t>ЖИМ НОГАМИ · KOSMOHACK</a:t>
-            </a:r>
-          </a:p>
-        </p:txBody>
-      </p:sp>
-      <p:sp>
-        <p:nvSpPr>
-          <p:cNvPr id="3" name="Oval 2"/>
+              <a:t>Конвейер</a:t>
+            </a:r>
+          </a:p>
+        </p:txBody>
+      </p:sp>
+      <p:sp>
+        <p:nvSpPr>
+          <p:cNvPr id="3" name="Rounded Rectangle 2"/>
           <p:cNvSpPr/>
           <p:nvPr/>
         </p:nvSpPr>
         <p:spPr>
           <a:xfrm>
-            <a:off x="11658600" y="384048"/>
-            <a:ext cx="128016" cy="128016"/>
-          </a:xfrm>
-          <a:prstGeom prst="ellipse">
-            <a:avLst/>
+            <a:off x="640080" y="2011680"/>
+            <a:ext cx="2103120" cy="2377440"/>
+          </a:xfrm>
+          <a:prstGeom prst="roundRect">
+            <a:avLst>
+              <a:gd name="adj" fmla="val 6000"/>
+            </a:avLst>
           </a:prstGeom>
           <a:solidFill>
-            <a:srgbClr val="62D99A"/>
+            <a:srgbClr val="0D1217"/>
           </a:solidFill>
-          <a:ln>
-            <a:noFill/>
+          <a:ln w="12700">
+            <a:solidFill>
+              <a:srgbClr val="2A333D"/>
+            </a:solidFill>
           </a:ln>
         </p:spPr>
         <p:style>
@@ -5137,55 +5257,20 @@
       </p:sp>
       <p:sp>
         <p:nvSpPr>
-          <p:cNvPr id="4" name="TextBox 3"/>
-          <p:cNvSpPr txBox="1"/>
-          <p:nvPr/>
-        </p:nvSpPr>
-        <p:spPr>
-          <a:xfrm>
-            <a:off x="640080" y="777240"/>
-            <a:ext cx="10881360" cy="1097280"/>
-          </a:xfrm>
-          <a:prstGeom prst="rect">
-            <a:avLst/>
-          </a:prstGeom>
-          <a:noFill/>
-        </p:spPr>
-        <p:txBody>
-          <a:bodyPr wrap="square">
-            <a:spAutoFit/>
-          </a:bodyPr>
-          <a:lstStyle/>
-          <a:p>
-            <a:pPr algn="l"/>
-            <a:r>
-              <a:rPr sz="3800" b="1">
-                <a:solidFill>
-                  <a:srgbClr val="F2F4F5"/>
-                </a:solidFill>
-                <a:latin typeface="Inter"/>
-              </a:rPr>
-              <a:t>Детектор огня: 5 минут — и готово</a:t>
-            </a:r>
-          </a:p>
-        </p:txBody>
-      </p:sp>
-      <p:sp>
-        <p:nvSpPr>
-          <p:cNvPr id="5" name="Oval 4"/>
+          <p:cNvPr id="4" name="Rounded Rectangle 3"/>
           <p:cNvSpPr/>
           <p:nvPr/>
         </p:nvSpPr>
         <p:spPr>
           <a:xfrm>
-            <a:off x="914400" y="2414016"/>
-            <a:ext cx="155448" cy="155448"/>
-          </a:xfrm>
-          <a:prstGeom prst="ellipse">
+            <a:off x="640080" y="2148840"/>
+            <a:ext cx="82296" cy="2103120"/>
+          </a:xfrm>
+          <a:prstGeom prst="roundRect">
             <a:avLst/>
           </a:prstGeom>
           <a:solidFill>
-            <a:srgbClr val="62D99A"/>
+            <a:srgbClr val="EF5B5B"/>
           </a:solidFill>
           <a:ln>
             <a:noFill/>
@@ -5215,14 +5300,14 @@
       </p:sp>
       <p:sp>
         <p:nvSpPr>
-          <p:cNvPr id="6" name="TextBox 5"/>
+          <p:cNvPr id="5" name="TextBox 4"/>
           <p:cNvSpPr txBox="1"/>
           <p:nvPr/>
         </p:nvSpPr>
         <p:spPr>
           <a:xfrm>
-            <a:off x="1280160" y="2212848"/>
-            <a:ext cx="10241280" cy="868680"/>
+            <a:off x="960120" y="2331720"/>
+            <a:ext cx="1554480" cy="1737360"/>
           </a:xfrm>
           <a:prstGeom prst="rect">
             <a:avLst/>
@@ -5237,46 +5322,85 @@
           <a:p>
             <a:pPr algn="l"/>
             <a:r>
-              <a:rPr sz="2100" b="0">
+              <a:rPr sz="2100" b="1">
                 <a:solidFill>
                   <a:srgbClr val="F2F4F5"/>
                 </a:solidFill>
                 <a:latin typeface="Inter"/>
               </a:rPr>
-              <a:t>Unet + EfficientNet-B4 · 12 каналов: видимый, тепло, покров, рельеф, погода</a:t>
-            </a:r>
-            <a:r>
-              <a:rPr sz="1400" b="0">
+              <a:t>VIIRS AF</a:t>
+            </a:r>
+            <a:r>
+              <a:rPr sz="1500" b="0">
                 <a:solidFill>
                   <a:srgbClr val="7D8690"/>
                 </a:solidFill>
                 <a:latin typeface="Inter"/>
               </a:rPr>
               <a:t>
-полное обучение за 295 секунд на арендной RTX PRO 4500</a:t>
-            </a:r>
-          </a:p>
-        </p:txBody>
-      </p:sp>
-      <p:sp>
-        <p:nvSpPr>
-          <p:cNvPr id="7" name="Oval 6"/>
+Unet · 12ch</a:t>
+            </a:r>
+          </a:p>
+        </p:txBody>
+      </p:sp>
+      <p:sp>
+        <p:nvSpPr>
+          <p:cNvPr id="6" name="TextBox 5"/>
+          <p:cNvSpPr txBox="1"/>
+          <p:nvPr/>
+        </p:nvSpPr>
+        <p:spPr>
+          <a:xfrm>
+            <a:off x="2743200" y="2834640"/>
+            <a:ext cx="365760" cy="457200"/>
+          </a:xfrm>
+          <a:prstGeom prst="rect">
+            <a:avLst/>
+          </a:prstGeom>
+          <a:noFill/>
+        </p:spPr>
+        <p:txBody>
+          <a:bodyPr wrap="square">
+            <a:spAutoFit/>
+          </a:bodyPr>
+          <a:lstStyle/>
+          <a:p>
+            <a:pPr algn="l"/>
+            <a:r>
+              <a:rPr sz="3000" b="0">
+                <a:solidFill>
+                  <a:srgbClr val="FF6B35"/>
+                </a:solidFill>
+                <a:latin typeface="Inter"/>
+              </a:rPr>
+              <a:t>›</a:t>
+            </a:r>
+          </a:p>
+        </p:txBody>
+      </p:sp>
+      <p:sp>
+        <p:nvSpPr>
+          <p:cNvPr id="7" name="Rounded Rectangle 6"/>
           <p:cNvSpPr/>
           <p:nvPr/>
         </p:nvSpPr>
         <p:spPr>
           <a:xfrm>
-            <a:off x="914400" y="3557016"/>
-            <a:ext cx="155448" cy="155448"/>
-          </a:xfrm>
-          <a:prstGeom prst="ellipse">
-            <a:avLst/>
+            <a:off x="2944368" y="2011680"/>
+            <a:ext cx="2103120" cy="2377440"/>
+          </a:xfrm>
+          <a:prstGeom prst="roundRect">
+            <a:avLst>
+              <a:gd name="adj" fmla="val 6000"/>
+            </a:avLst>
           </a:prstGeom>
           <a:solidFill>
-            <a:srgbClr val="F2F4F5"/>
+            <a:srgbClr val="0D1217"/>
           </a:solidFill>
-          <a:ln>
-            <a:noFill/>
+          <a:ln w="12700">
+            <a:solidFill>
+              <a:srgbClr val="2A333D"/>
+            </a:solidFill>
           </a:ln>
         </p:spPr>
         <p:style>
@@ -5303,61 +5427,16 @@
       </p:sp>
       <p:sp>
         <p:nvSpPr>
-          <p:cNvPr id="8" name="TextBox 7"/>
-          <p:cNvSpPr txBox="1"/>
-          <p:nvPr/>
-        </p:nvSpPr>
-        <p:spPr>
-          <a:xfrm>
-            <a:off x="1280160" y="3355848"/>
-            <a:ext cx="10241280" cy="868680"/>
-          </a:xfrm>
-          <a:prstGeom prst="rect">
-            <a:avLst/>
-          </a:prstGeom>
-          <a:noFill/>
-        </p:spPr>
-        <p:txBody>
-          <a:bodyPr wrap="square">
-            <a:spAutoFit/>
-          </a:bodyPr>
-          <a:lstStyle/>
-          <a:p>
-            <a:pPr algn="l"/>
-            <a:r>
-              <a:rPr sz="2100" b="0">
-                <a:solidFill>
-                  <a:srgbClr val="F2F4F5"/>
-                </a:solidFill>
-                <a:latin typeface="Inter"/>
-              </a:rPr>
-              <a:t>F1 0.8434 · днём 0.85, ночью 0.80</a:t>
-            </a:r>
-            <a:r>
-              <a:rPr sz="1400" b="0">
-                <a:solidFill>
-                  <a:srgbClr val="7D8690"/>
-                </a:solidFill>
-                <a:latin typeface="Inter"/>
-              </a:rPr>
-              <a:t>
-ночью видны только тепловые каналы — отсюда разрыв</a:t>
-            </a:r>
-          </a:p>
-        </p:txBody>
-      </p:sp>
-      <p:sp>
-        <p:nvSpPr>
-          <p:cNvPr id="9" name="Oval 8"/>
+          <p:cNvPr id="8" name="Rounded Rectangle 7"/>
           <p:cNvSpPr/>
           <p:nvPr/>
         </p:nvSpPr>
         <p:spPr>
           <a:xfrm>
-            <a:off x="914400" y="4700016"/>
-            <a:ext cx="155448" cy="155448"/>
-          </a:xfrm>
-          <a:prstGeom prst="ellipse">
+            <a:off x="2944368" y="2148840"/>
+            <a:ext cx="82296" cy="2103120"/>
+          </a:xfrm>
+          <a:prstGeom prst="roundRect">
             <a:avLst/>
           </a:prstGeom>
           <a:solidFill>
@@ -5391,14 +5470,14 @@
       </p:sp>
       <p:sp>
         <p:nvSpPr>
-          <p:cNvPr id="10" name="TextBox 9"/>
+          <p:cNvPr id="9" name="TextBox 8"/>
           <p:cNvSpPr txBox="1"/>
           <p:nvPr/>
         </p:nvSpPr>
         <p:spPr>
           <a:xfrm>
-            <a:off x="1280160" y="4498848"/>
-            <a:ext cx="10241280" cy="868680"/>
+            <a:off x="3264408" y="2331720"/>
+            <a:ext cx="1554480" cy="1737360"/>
           </a:xfrm>
           <a:prstGeom prst="rect">
             <a:avLst/>
@@ -5413,51 +5492,642 @@
           <a:p>
             <a:pPr algn="l"/>
             <a:r>
-              <a:rPr sz="2100" b="0">
+              <a:rPr sz="2100" b="1">
                 <a:solidFill>
                   <a:srgbClr val="F2F4F5"/>
                 </a:solidFill>
                 <a:latin typeface="Inter"/>
               </a:rPr>
-              <a:t>Факелы от пожаров на одном снимке неотличимы</a:t>
-            </a:r>
-            <a:r>
-              <a:rPr sz="1400" b="0">
+              <a:t>S2 BS</a:t>
+            </a:r>
+            <a:r>
+              <a:rPr sz="1500" b="0">
                 <a:solidFill>
                   <a:srgbClr val="7D8690"/>
                 </a:solidFill>
                 <a:latin typeface="Inter"/>
               </a:rPr>
               <a:t>
-давим их контекстом застройки и историей — честно пишем в отчёт</a:t>
-            </a:r>
-          </a:p>
-        </p:txBody>
-      </p:sp>
-      <p:pic>
-        <p:nvPicPr>
-          <p:cNvPr id="11" name="Picture 10" descr="af_viz_sample.png"/>
-          <p:cNvPicPr>
-            <a:picLocks noChangeAspect="1"/>
-          </p:cNvPicPr>
-          <p:nvPr/>
-        </p:nvPicPr>
-        <p:blipFill>
-          <a:blip r:embed="rId2"/>
-          <a:stretch>
-            <a:fillRect/>
-          </a:stretch>
-        </p:blipFill>
-        <p:spPr>
-          <a:xfrm>
-            <a:off x="9144000" y="4480560"/>
-            <a:ext cx="2377440" cy="792480"/>
+Unet · 27ch</a:t>
+            </a:r>
+          </a:p>
+        </p:txBody>
+      </p:sp>
+      <p:sp>
+        <p:nvSpPr>
+          <p:cNvPr id="10" name="TextBox 9"/>
+          <p:cNvSpPr txBox="1"/>
+          <p:nvPr/>
+        </p:nvSpPr>
+        <p:spPr>
+          <a:xfrm>
+            <a:off x="5047488" y="2834640"/>
+            <a:ext cx="365760" cy="457200"/>
           </a:xfrm>
           <a:prstGeom prst="rect">
             <a:avLst/>
           </a:prstGeom>
-        </p:spPr>
-      </p:pic>
+          <a:noFill/>
+        </p:spPr>
+        <p:txBody>
+          <a:bodyPr wrap="square">
+            <a:spAutoFit/>
+          </a:bodyPr>
+          <a:lstStyle/>
+          <a:p>
+            <a:pPr algn="l"/>
+            <a:r>
+              <a:rPr sz="3000" b="0">
+                <a:solidFill>
+                  <a:srgbClr val="FF6B35"/>
+                </a:solidFill>
+                <a:latin typeface="Inter"/>
+              </a:rPr>
+              <a:t>›</a:t>
+            </a:r>
+          </a:p>
+        </p:txBody>
+      </p:sp>
+      <p:sp>
+        <p:nvSpPr>
+          <p:cNvPr id="11" name="Rounded Rectangle 10"/>
+          <p:cNvSpPr/>
+          <p:nvPr/>
+        </p:nvSpPr>
+        <p:spPr>
+          <a:xfrm>
+            <a:off x="5248656" y="2011680"/>
+            <a:ext cx="2103120" cy="2377440"/>
+          </a:xfrm>
+          <a:prstGeom prst="roundRect">
+            <a:avLst>
+              <a:gd name="adj" fmla="val 6000"/>
+            </a:avLst>
+          </a:prstGeom>
+          <a:solidFill>
+            <a:srgbClr val="0D1217"/>
+          </a:solidFill>
+          <a:ln w="12700">
+            <a:solidFill>
+              <a:srgbClr val="2A333D"/>
+            </a:solidFill>
+          </a:ln>
+        </p:spPr>
+        <p:style>
+          <a:lnRef idx="1">
+            <a:schemeClr val="accent1"/>
+          </a:lnRef>
+          <a:fillRef idx="3">
+            <a:schemeClr val="accent1"/>
+          </a:fillRef>
+          <a:effectRef idx="2">
+            <a:schemeClr val="accent1"/>
+          </a:effectRef>
+          <a:fontRef idx="minor">
+            <a:schemeClr val="lt1"/>
+          </a:fontRef>
+        </p:style>
+        <p:txBody>
+          <a:bodyPr rtlCol="0" anchor="ctr"/>
+          <a:lstStyle/>
+          <a:p>
+            <a:pPr algn="ctr"/>
+          </a:p>
+        </p:txBody>
+      </p:sp>
+      <p:sp>
+        <p:nvSpPr>
+          <p:cNvPr id="12" name="Rounded Rectangle 11"/>
+          <p:cNvSpPr/>
+          <p:nvPr/>
+        </p:nvSpPr>
+        <p:spPr>
+          <a:xfrm>
+            <a:off x="5248656" y="2148840"/>
+            <a:ext cx="82296" cy="2103120"/>
+          </a:xfrm>
+          <a:prstGeom prst="roundRect">
+            <a:avLst/>
+          </a:prstGeom>
+          <a:solidFill>
+            <a:srgbClr val="FF6B35"/>
+          </a:solidFill>
+          <a:ln>
+            <a:noFill/>
+          </a:ln>
+        </p:spPr>
+        <p:style>
+          <a:lnRef idx="1">
+            <a:schemeClr val="accent1"/>
+          </a:lnRef>
+          <a:fillRef idx="3">
+            <a:schemeClr val="accent1"/>
+          </a:fillRef>
+          <a:effectRef idx="2">
+            <a:schemeClr val="accent1"/>
+          </a:effectRef>
+          <a:fontRef idx="minor">
+            <a:schemeClr val="lt1"/>
+          </a:fontRef>
+        </p:style>
+        <p:txBody>
+          <a:bodyPr rtlCol="0" anchor="ctr"/>
+          <a:lstStyle/>
+          <a:p>
+            <a:pPr algn="ctr"/>
+          </a:p>
+        </p:txBody>
+      </p:sp>
+      <p:sp>
+        <p:nvSpPr>
+          <p:cNvPr id="13" name="TextBox 12"/>
+          <p:cNvSpPr txBox="1"/>
+          <p:nvPr/>
+        </p:nvSpPr>
+        <p:spPr>
+          <a:xfrm>
+            <a:off x="5568696" y="2331720"/>
+            <a:ext cx="1554480" cy="1737360"/>
+          </a:xfrm>
+          <a:prstGeom prst="rect">
+            <a:avLst/>
+          </a:prstGeom>
+          <a:noFill/>
+        </p:spPr>
+        <p:txBody>
+          <a:bodyPr wrap="square">
+            <a:spAutoFit/>
+          </a:bodyPr>
+          <a:lstStyle/>
+          <a:p>
+            <a:pPr algn="l"/>
+            <a:r>
+              <a:rPr sz="2100" b="1">
+                <a:solidFill>
+                  <a:srgbClr val="F2F4F5"/>
+                </a:solidFill>
+                <a:latin typeface="Inter"/>
+              </a:rPr>
+              <a:t>inference</a:t>
+            </a:r>
+            <a:r>
+              <a:rPr sz="1500" b="0">
+                <a:solidFill>
+                  <a:srgbClr val="7D8690"/>
+                </a:solidFill>
+                <a:latin typeface="Inter"/>
+              </a:rPr>
+              <a:t>
+~28 сек</a:t>
+            </a:r>
+          </a:p>
+        </p:txBody>
+      </p:sp>
+      <p:sp>
+        <p:nvSpPr>
+          <p:cNvPr id="14" name="TextBox 13"/>
+          <p:cNvSpPr txBox="1"/>
+          <p:nvPr/>
+        </p:nvSpPr>
+        <p:spPr>
+          <a:xfrm>
+            <a:off x="7351775" y="2834640"/>
+            <a:ext cx="365760" cy="457200"/>
+          </a:xfrm>
+          <a:prstGeom prst="rect">
+            <a:avLst/>
+          </a:prstGeom>
+          <a:noFill/>
+        </p:spPr>
+        <p:txBody>
+          <a:bodyPr wrap="square">
+            <a:spAutoFit/>
+          </a:bodyPr>
+          <a:lstStyle/>
+          <a:p>
+            <a:pPr algn="l"/>
+            <a:r>
+              <a:rPr sz="3000" b="0">
+                <a:solidFill>
+                  <a:srgbClr val="FF6B35"/>
+                </a:solidFill>
+                <a:latin typeface="Inter"/>
+              </a:rPr>
+              <a:t>›</a:t>
+            </a:r>
+          </a:p>
+        </p:txBody>
+      </p:sp>
+      <p:sp>
+        <p:nvSpPr>
+          <p:cNvPr id="15" name="Rounded Rectangle 14"/>
+          <p:cNvSpPr/>
+          <p:nvPr/>
+        </p:nvSpPr>
+        <p:spPr>
+          <a:xfrm>
+            <a:off x="7552944" y="2011680"/>
+            <a:ext cx="2103120" cy="2377440"/>
+          </a:xfrm>
+          <a:prstGeom prst="roundRect">
+            <a:avLst>
+              <a:gd name="adj" fmla="val 6000"/>
+            </a:avLst>
+          </a:prstGeom>
+          <a:solidFill>
+            <a:srgbClr val="0D1217"/>
+          </a:solidFill>
+          <a:ln w="12700">
+            <a:solidFill>
+              <a:srgbClr val="2A333D"/>
+            </a:solidFill>
+          </a:ln>
+        </p:spPr>
+        <p:style>
+          <a:lnRef idx="1">
+            <a:schemeClr val="accent1"/>
+          </a:lnRef>
+          <a:fillRef idx="3">
+            <a:schemeClr val="accent1"/>
+          </a:fillRef>
+          <a:effectRef idx="2">
+            <a:schemeClr val="accent1"/>
+          </a:effectRef>
+          <a:fontRef idx="minor">
+            <a:schemeClr val="lt1"/>
+          </a:fontRef>
+        </p:style>
+        <p:txBody>
+          <a:bodyPr rtlCol="0" anchor="ctr"/>
+          <a:lstStyle/>
+          <a:p>
+            <a:pPr algn="ctr"/>
+          </a:p>
+        </p:txBody>
+      </p:sp>
+      <p:sp>
+        <p:nvSpPr>
+          <p:cNvPr id="16" name="Rounded Rectangle 15"/>
+          <p:cNvSpPr/>
+          <p:nvPr/>
+        </p:nvSpPr>
+        <p:spPr>
+          <a:xfrm>
+            <a:off x="7552944" y="2148840"/>
+            <a:ext cx="82296" cy="2103120"/>
+          </a:xfrm>
+          <a:prstGeom prst="roundRect">
+            <a:avLst/>
+          </a:prstGeom>
+          <a:solidFill>
+            <a:srgbClr val="62D99A"/>
+          </a:solidFill>
+          <a:ln>
+            <a:noFill/>
+          </a:ln>
+        </p:spPr>
+        <p:style>
+          <a:lnRef idx="1">
+            <a:schemeClr val="accent1"/>
+          </a:lnRef>
+          <a:fillRef idx="3">
+            <a:schemeClr val="accent1"/>
+          </a:fillRef>
+          <a:effectRef idx="2">
+            <a:schemeClr val="accent1"/>
+          </a:effectRef>
+          <a:fontRef idx="minor">
+            <a:schemeClr val="lt1"/>
+          </a:fontRef>
+        </p:style>
+        <p:txBody>
+          <a:bodyPr rtlCol="0" anchor="ctr"/>
+          <a:lstStyle/>
+          <a:p>
+            <a:pPr algn="ctr"/>
+          </a:p>
+        </p:txBody>
+      </p:sp>
+      <p:sp>
+        <p:nvSpPr>
+          <p:cNvPr id="17" name="TextBox 16"/>
+          <p:cNvSpPr txBox="1"/>
+          <p:nvPr/>
+        </p:nvSpPr>
+        <p:spPr>
+          <a:xfrm>
+            <a:off x="7872984" y="2331720"/>
+            <a:ext cx="1554480" cy="1737360"/>
+          </a:xfrm>
+          <a:prstGeom prst="rect">
+            <a:avLst/>
+          </a:prstGeom>
+          <a:noFill/>
+        </p:spPr>
+        <p:txBody>
+          <a:bodyPr wrap="square">
+            <a:spAutoFit/>
+          </a:bodyPr>
+          <a:lstStyle/>
+          <a:p>
+            <a:pPr algn="l"/>
+            <a:r>
+              <a:rPr sz="2100" b="1">
+                <a:solidFill>
+                  <a:srgbClr val="F2F4F5"/>
+                </a:solidFill>
+                <a:latin typeface="Inter"/>
+              </a:rPr>
+              <a:t>CSV-ответ</a:t>
+            </a:r>
+            <a:r>
+              <a:rPr sz="1500" b="0">
+                <a:solidFill>
+                  <a:srgbClr val="7D8690"/>
+                </a:solidFill>
+                <a:latin typeface="Inter"/>
+              </a:rPr>
+              <a:t>
+447 строк</a:t>
+            </a:r>
+          </a:p>
+        </p:txBody>
+      </p:sp>
+      <p:sp>
+        <p:nvSpPr>
+          <p:cNvPr id="18" name="TextBox 17"/>
+          <p:cNvSpPr txBox="1"/>
+          <p:nvPr/>
+        </p:nvSpPr>
+        <p:spPr>
+          <a:xfrm>
+            <a:off x="9656064" y="2834640"/>
+            <a:ext cx="365760" cy="457200"/>
+          </a:xfrm>
+          <a:prstGeom prst="rect">
+            <a:avLst/>
+          </a:prstGeom>
+          <a:noFill/>
+        </p:spPr>
+        <p:txBody>
+          <a:bodyPr wrap="square">
+            <a:spAutoFit/>
+          </a:bodyPr>
+          <a:lstStyle/>
+          <a:p>
+            <a:pPr algn="l"/>
+            <a:r>
+              <a:rPr sz="3000" b="0">
+                <a:solidFill>
+                  <a:srgbClr val="FF6B35"/>
+                </a:solidFill>
+                <a:latin typeface="Inter"/>
+              </a:rPr>
+              <a:t>›</a:t>
+            </a:r>
+          </a:p>
+        </p:txBody>
+      </p:sp>
+      <p:sp>
+        <p:nvSpPr>
+          <p:cNvPr id="19" name="Rounded Rectangle 18"/>
+          <p:cNvSpPr/>
+          <p:nvPr/>
+        </p:nvSpPr>
+        <p:spPr>
+          <a:xfrm>
+            <a:off x="9857232" y="2011680"/>
+            <a:ext cx="2103120" cy="2377440"/>
+          </a:xfrm>
+          <a:prstGeom prst="roundRect">
+            <a:avLst>
+              <a:gd name="adj" fmla="val 6000"/>
+            </a:avLst>
+          </a:prstGeom>
+          <a:solidFill>
+            <a:srgbClr val="0D1217"/>
+          </a:solidFill>
+          <a:ln w="12700">
+            <a:solidFill>
+              <a:srgbClr val="2A333D"/>
+            </a:solidFill>
+          </a:ln>
+        </p:spPr>
+        <p:style>
+          <a:lnRef idx="1">
+            <a:schemeClr val="accent1"/>
+          </a:lnRef>
+          <a:fillRef idx="3">
+            <a:schemeClr val="accent1"/>
+          </a:fillRef>
+          <a:effectRef idx="2">
+            <a:schemeClr val="accent1"/>
+          </a:effectRef>
+          <a:fontRef idx="minor">
+            <a:schemeClr val="lt1"/>
+          </a:fontRef>
+        </p:style>
+        <p:txBody>
+          <a:bodyPr rtlCol="0" anchor="ctr"/>
+          <a:lstStyle/>
+          <a:p>
+            <a:pPr algn="ctr"/>
+          </a:p>
+        </p:txBody>
+      </p:sp>
+      <p:sp>
+        <p:nvSpPr>
+          <p:cNvPr id="20" name="Rounded Rectangle 19"/>
+          <p:cNvSpPr/>
+          <p:nvPr/>
+        </p:nvSpPr>
+        <p:spPr>
+          <a:xfrm>
+            <a:off x="9857232" y="2148840"/>
+            <a:ext cx="82296" cy="2103120"/>
+          </a:xfrm>
+          <a:prstGeom prst="roundRect">
+            <a:avLst/>
+          </a:prstGeom>
+          <a:solidFill>
+            <a:srgbClr val="F2F4F5"/>
+          </a:solidFill>
+          <a:ln>
+            <a:noFill/>
+          </a:ln>
+        </p:spPr>
+        <p:style>
+          <a:lnRef idx="1">
+            <a:schemeClr val="accent1"/>
+          </a:lnRef>
+          <a:fillRef idx="3">
+            <a:schemeClr val="accent1"/>
+          </a:fillRef>
+          <a:effectRef idx="2">
+            <a:schemeClr val="accent1"/>
+          </a:effectRef>
+          <a:fontRef idx="minor">
+            <a:schemeClr val="lt1"/>
+          </a:fontRef>
+        </p:style>
+        <p:txBody>
+          <a:bodyPr rtlCol="0" anchor="ctr"/>
+          <a:lstStyle/>
+          <a:p>
+            <a:pPr algn="ctr"/>
+          </a:p>
+        </p:txBody>
+      </p:sp>
+      <p:sp>
+        <p:nvSpPr>
+          <p:cNvPr id="21" name="TextBox 20"/>
+          <p:cNvSpPr txBox="1"/>
+          <p:nvPr/>
+        </p:nvSpPr>
+        <p:spPr>
+          <a:xfrm>
+            <a:off x="10177272" y="2331720"/>
+            <a:ext cx="1554480" cy="1737360"/>
+          </a:xfrm>
+          <a:prstGeom prst="rect">
+            <a:avLst/>
+          </a:prstGeom>
+          <a:noFill/>
+        </p:spPr>
+        <p:txBody>
+          <a:bodyPr wrap="square">
+            <a:spAutoFit/>
+          </a:bodyPr>
+          <a:lstStyle/>
+          <a:p>
+            <a:pPr algn="l"/>
+            <a:r>
+              <a:rPr sz="2100" b="1">
+                <a:solidFill>
+                  <a:srgbClr val="F2F4F5"/>
+                </a:solidFill>
+                <a:latin typeface="Inter"/>
+              </a:rPr>
+              <a:t>сервис</a:t>
+            </a:r>
+            <a:r>
+              <a:rPr sz="1500" b="0">
+                <a:solidFill>
+                  <a:srgbClr val="7D8690"/>
+                </a:solidFill>
+                <a:latin typeface="Inter"/>
+              </a:rPr>
+              <a:t>
+карта + API</a:t>
+            </a:r>
+          </a:p>
+        </p:txBody>
+      </p:sp>
+      <p:sp>
+        <p:nvSpPr>
+          <p:cNvPr id="22" name="TextBox 21"/>
+          <p:cNvSpPr txBox="1"/>
+          <p:nvPr/>
+        </p:nvSpPr>
+        <p:spPr>
+          <a:xfrm>
+            <a:off x="640080" y="4937760"/>
+            <a:ext cx="10881360" cy="731520"/>
+          </a:xfrm>
+          <a:prstGeom prst="rect">
+            <a:avLst/>
+          </a:prstGeom>
+          <a:noFill/>
+        </p:spPr>
+        <p:txBody>
+          <a:bodyPr wrap="square">
+            <a:spAutoFit/>
+          </a:bodyPr>
+          <a:lstStyle/>
+          <a:p>
+            <a:pPr algn="ctr"/>
+            <a:r>
+              <a:rPr sz="1700" b="0">
+                <a:solidFill>
+                  <a:srgbClr val="7D8690"/>
+                </a:solidFill>
+                <a:latin typeface="Inter"/>
+              </a:rPr>
+              <a:t>Сплит по очагам · сиды 19 · гео теста не трогаем · повтор = тот же файл</a:t>
+            </a:r>
+          </a:p>
+        </p:txBody>
+      </p:sp>
+      <p:sp>
+        <p:nvSpPr>
+          <p:cNvPr id="23" name="TextBox 22"/>
+          <p:cNvSpPr txBox="1"/>
+          <p:nvPr/>
+        </p:nvSpPr>
+        <p:spPr>
+          <a:xfrm>
+            <a:off x="457200" y="6400800"/>
+            <a:ext cx="7315200" cy="274320"/>
+          </a:xfrm>
+          <a:prstGeom prst="rect">
+            <a:avLst/>
+          </a:prstGeom>
+          <a:noFill/>
+        </p:spPr>
+        <p:txBody>
+          <a:bodyPr wrap="square">
+            <a:spAutoFit/>
+          </a:bodyPr>
+          <a:lstStyle/>
+          <a:p>
+            <a:pPr algn="l"/>
+            <a:r>
+              <a:rPr sz="1100" b="1">
+                <a:solidFill>
+                  <a:srgbClr val="7D8690"/>
+                </a:solidFill>
+                <a:latin typeface="Inter"/>
+              </a:rPr>
+              <a:t>ЖИМ НОГАМИ · KOSMOHACK 2026</a:t>
+            </a:r>
+          </a:p>
+        </p:txBody>
+      </p:sp>
+      <p:sp>
+        <p:nvSpPr>
+          <p:cNvPr id="24" name="TextBox 23"/>
+          <p:cNvSpPr txBox="1"/>
+          <p:nvPr/>
+        </p:nvSpPr>
+        <p:spPr>
+          <a:xfrm>
+            <a:off x="10789920" y="6400800"/>
+            <a:ext cx="914400" cy="274320"/>
+          </a:xfrm>
+          <a:prstGeom prst="rect">
+            <a:avLst/>
+          </a:prstGeom>
+          <a:noFill/>
+        </p:spPr>
+        <p:txBody>
+          <a:bodyPr wrap="square">
+            <a:spAutoFit/>
+          </a:bodyPr>
+          <a:lstStyle/>
+          <a:p>
+            <a:pPr algn="r"/>
+            <a:r>
+              <a:rPr sz="1100" b="1">
+                <a:solidFill>
+                  <a:srgbClr val="7D8690"/>
+                </a:solidFill>
+                <a:latin typeface="Inter"/>
+              </a:rPr>
+              <a:t>03</a:t>
+            </a:r>
+          </a:p>
+        </p:txBody>
+      </p:sp>
     </p:spTree>
   </p:cSld>
   <p:clrMapOvr>
@@ -5492,8 +6162,8 @@
         </p:nvSpPr>
         <p:spPr>
           <a:xfrm>
-            <a:off x="640080" y="274320"/>
-            <a:ext cx="10881360" cy="365760"/>
+            <a:off x="640080" y="457200"/>
+            <a:ext cx="10881360" cy="548640"/>
           </a:xfrm>
           <a:prstGeom prst="rect">
             <a:avLst/>
@@ -5508,70 +6178,27 @@
           <a:p>
             <a:pPr algn="l"/>
             <a:r>
-              <a:rPr sz="1200" b="1">
-                <a:solidFill>
-                  <a:srgbClr val="7D8690"/>
+              <a:rPr sz="1500" b="1">
+                <a:solidFill>
+                  <a:srgbClr val="FF6B35"/>
                 </a:solidFill>
                 <a:latin typeface="Inter"/>
               </a:rPr>
-              <a:t>ЖИМ НОГАМИ · KOSMOHACK</a:t>
-            </a:r>
-          </a:p>
-        </p:txBody>
-      </p:sp>
-      <p:sp>
-        <p:nvSpPr>
-          <p:cNvPr id="3" name="Oval 2"/>
-          <p:cNvSpPr/>
-          <p:nvPr/>
-        </p:nvSpPr>
-        <p:spPr>
-          <a:xfrm>
-            <a:off x="11658600" y="384048"/>
-            <a:ext cx="128016" cy="128016"/>
-          </a:xfrm>
-          <a:prstGeom prst="ellipse">
-            <a:avLst/>
-          </a:prstGeom>
-          <a:solidFill>
-            <a:srgbClr val="62D99A"/>
-          </a:solidFill>
-          <a:ln>
-            <a:noFill/>
-          </a:ln>
-        </p:spPr>
-        <p:style>
-          <a:lnRef idx="1">
-            <a:schemeClr val="accent1"/>
-          </a:lnRef>
-          <a:fillRef idx="3">
-            <a:schemeClr val="accent1"/>
-          </a:fillRef>
-          <a:effectRef idx="2">
-            <a:schemeClr val="accent1"/>
-          </a:effectRef>
-          <a:fontRef idx="minor">
-            <a:schemeClr val="lt1"/>
-          </a:fontRef>
-        </p:style>
-        <p:txBody>
-          <a:bodyPr rtlCol="0" anchor="ctr"/>
-          <a:lstStyle/>
-          <a:p>
-            <a:pPr algn="ctr"/>
-          </a:p>
-        </p:txBody>
-      </p:sp>
-      <p:sp>
-        <p:nvSpPr>
-          <p:cNvPr id="4" name="TextBox 3"/>
+              <a:t>Детектор огня</a:t>
+            </a:r>
+          </a:p>
+        </p:txBody>
+      </p:sp>
+      <p:sp>
+        <p:nvSpPr>
+          <p:cNvPr id="3" name="TextBox 2"/>
           <p:cNvSpPr txBox="1"/>
           <p:nvPr/>
         </p:nvSpPr>
         <p:spPr>
           <a:xfrm>
-            <a:off x="640080" y="777240"/>
-            <a:ext cx="10881360" cy="1097280"/>
+            <a:off x="640080" y="1005840"/>
+            <a:ext cx="4572000" cy="1280160"/>
           </a:xfrm>
           <a:prstGeom prst="rect">
             <a:avLst/>
@@ -5586,70 +6213,27 @@
           <a:p>
             <a:pPr algn="l"/>
             <a:r>
-              <a:rPr sz="3800" b="1">
-                <a:solidFill>
-                  <a:srgbClr val="F2F4F5"/>
+              <a:rPr sz="11000" b="1">
+                <a:solidFill>
+                  <a:srgbClr val="62D99A"/>
                 </a:solidFill>
                 <a:latin typeface="Inter"/>
               </a:rPr>
-              <a:t>Гари: похоронили гиганта, выиграл трудяга</a:t>
-            </a:r>
-          </a:p>
-        </p:txBody>
-      </p:sp>
-      <p:sp>
-        <p:nvSpPr>
-          <p:cNvPr id="5" name="Oval 4"/>
-          <p:cNvSpPr/>
-          <p:nvPr/>
-        </p:nvSpPr>
-        <p:spPr>
-          <a:xfrm>
-            <a:off x="914400" y="2414016"/>
-            <a:ext cx="155448" cy="155448"/>
-          </a:xfrm>
-          <a:prstGeom prst="ellipse">
-            <a:avLst/>
-          </a:prstGeom>
-          <a:solidFill>
-            <a:srgbClr val="EF5B5B"/>
-          </a:solidFill>
-          <a:ln>
-            <a:noFill/>
-          </a:ln>
-        </p:spPr>
-        <p:style>
-          <a:lnRef idx="1">
-            <a:schemeClr val="accent1"/>
-          </a:lnRef>
-          <a:fillRef idx="3">
-            <a:schemeClr val="accent1"/>
-          </a:fillRef>
-          <a:effectRef idx="2">
-            <a:schemeClr val="accent1"/>
-          </a:effectRef>
-          <a:fontRef idx="minor">
-            <a:schemeClr val="lt1"/>
-          </a:fontRef>
-        </p:style>
-        <p:txBody>
-          <a:bodyPr rtlCol="0" anchor="ctr"/>
-          <a:lstStyle/>
-          <a:p>
-            <a:pPr algn="ctr"/>
-          </a:p>
-        </p:txBody>
-      </p:sp>
-      <p:sp>
-        <p:nvSpPr>
-          <p:cNvPr id="6" name="TextBox 5"/>
+              <a:t>0.84</a:t>
+            </a:r>
+          </a:p>
+        </p:txBody>
+      </p:sp>
+      <p:sp>
+        <p:nvSpPr>
+          <p:cNvPr id="4" name="TextBox 3"/>
           <p:cNvSpPr txBox="1"/>
           <p:nvPr/>
         </p:nvSpPr>
         <p:spPr>
           <a:xfrm>
-            <a:off x="1280160" y="2212848"/>
-            <a:ext cx="10241280" cy="868680"/>
+            <a:off x="640080" y="2651760"/>
+            <a:ext cx="4572000" cy="457200"/>
           </a:xfrm>
           <a:prstGeom prst="rect">
             <a:avLst/>
@@ -5664,80 +6248,96 @@
           <a:p>
             <a:pPr algn="l"/>
             <a:r>
-              <a:rPr sz="2100" b="0">
-                <a:solidFill>
-                  <a:srgbClr val="F2F4F5"/>
+              <a:rPr sz="1900" b="0">
+                <a:solidFill>
+                  <a:srgbClr val="B8C0C8"/>
                 </a:solidFill>
                 <a:latin typeface="Inter"/>
               </a:rPr>
-              <a:t>Prithvi-300M сдох: IoU 0.16 — хуже тупого бейзлайна плюс nan-лосс</a:t>
-            </a:r>
-            <a:r>
-              <a:rPr sz="1400" b="0">
+              <a:t>micro-F1 · день 0.85 / ночь 0.80</a:t>
+            </a:r>
+          </a:p>
+        </p:txBody>
+      </p:sp>
+      <p:sp>
+        <p:nvSpPr>
+          <p:cNvPr id="5" name="TextBox 4"/>
+          <p:cNvSpPr txBox="1"/>
+          <p:nvPr/>
+        </p:nvSpPr>
+        <p:spPr>
+          <a:xfrm>
+            <a:off x="640080" y="3291840"/>
+            <a:ext cx="4572000" cy="2011680"/>
+          </a:xfrm>
+          <a:prstGeom prst="rect">
+            <a:avLst/>
+          </a:prstGeom>
+          <a:noFill/>
+        </p:spPr>
+        <p:txBody>
+          <a:bodyPr wrap="square">
+            <a:spAutoFit/>
+          </a:bodyPr>
+          <a:lstStyle/>
+          <a:p>
+            <a:pPr algn="l"/>
+            <a:r>
+              <a:rPr sz="1900" b="1">
+                <a:solidFill>
+                  <a:srgbClr val="F2F4F5"/>
+                </a:solidFill>
+                <a:latin typeface="Inter"/>
+              </a:rPr>
+              <a:t>5 минут обучения</a:t>
+            </a:r>
+            <a:r>
+              <a:rPr sz="1600" b="0">
                 <a:solidFill>
                   <a:srgbClr val="7D8690"/>
                 </a:solidFill>
                 <a:latin typeface="Inter"/>
               </a:rPr>
               <a:t>
-закрыли ветку без сантиментов</a:t>
-            </a:r>
-          </a:p>
-        </p:txBody>
-      </p:sp>
-      <p:sp>
-        <p:nvSpPr>
-          <p:cNvPr id="7" name="Oval 6"/>
-          <p:cNvSpPr/>
-          <p:nvPr/>
-        </p:nvSpPr>
-        <p:spPr>
-          <a:xfrm>
-            <a:off x="914400" y="3557016"/>
-            <a:ext cx="155448" cy="155448"/>
-          </a:xfrm>
-          <a:prstGeom prst="ellipse">
-            <a:avLst/>
-          </a:prstGeom>
-          <a:solidFill>
-            <a:srgbClr val="62D99A"/>
-          </a:solidFill>
-          <a:ln>
-            <a:noFill/>
-          </a:ln>
-        </p:spPr>
-        <p:style>
-          <a:lnRef idx="1">
-            <a:schemeClr val="accent1"/>
-          </a:lnRef>
-          <a:fillRef idx="3">
-            <a:schemeClr val="accent1"/>
-          </a:fillRef>
-          <a:effectRef idx="2">
-            <a:schemeClr val="accent1"/>
-          </a:effectRef>
-          <a:fontRef idx="minor">
-            <a:schemeClr val="lt1"/>
-          </a:fontRef>
-        </p:style>
-        <p:txBody>
-          <a:bodyPr rtlCol="0" anchor="ctr"/>
-          <a:lstStyle/>
-          <a:p>
-            <a:pPr algn="ctr"/>
-          </a:p>
-        </p:txBody>
-      </p:sp>
-      <p:sp>
-        <p:nvSpPr>
-          <p:cNvPr id="8" name="TextBox 7"/>
+Порог 0.15 + фильтр застройки · факелы на одном снимке неотличимы — пишем честно</a:t>
+            </a:r>
+          </a:p>
+        </p:txBody>
+      </p:sp>
+      <p:pic>
+        <p:nvPicPr>
+          <p:cNvPr id="6" name="Picture 5" descr="af_viz_dark.png"/>
+          <p:cNvPicPr>
+            <a:picLocks noChangeAspect="1"/>
+          </p:cNvPicPr>
+          <p:nvPr/>
+        </p:nvPicPr>
+        <p:blipFill>
+          <a:blip r:embed="rId2"/>
+          <a:stretch>
+            <a:fillRect/>
+          </a:stretch>
+        </p:blipFill>
+        <p:spPr>
+          <a:xfrm>
+            <a:off x="6035040" y="1097280"/>
+            <a:ext cx="5486400" cy="1964440"/>
+          </a:xfrm>
+          <a:prstGeom prst="rect">
+            <a:avLst/>
+          </a:prstGeom>
+        </p:spPr>
+      </p:pic>
+      <p:sp>
+        <p:nvSpPr>
+          <p:cNvPr id="7" name="TextBox 6"/>
           <p:cNvSpPr txBox="1"/>
           <p:nvPr/>
         </p:nvSpPr>
         <p:spPr>
           <a:xfrm>
-            <a:off x="1280160" y="3355848"/>
-            <a:ext cx="10241280" cy="868680"/>
+            <a:off x="457200" y="6400800"/>
+            <a:ext cx="7315200" cy="274320"/>
           </a:xfrm>
           <a:prstGeom prst="rect">
             <a:avLst/>
@@ -5752,80 +6352,27 @@
           <a:p>
             <a:pPr algn="l"/>
             <a:r>
-              <a:rPr sz="2100" b="0">
-                <a:solidFill>
-                  <a:srgbClr val="F2F4F5"/>
+              <a:rPr sz="1100" b="1">
+                <a:solidFill>
+                  <a:srgbClr val="7D8690"/>
                 </a:solidFill>
                 <a:latin typeface="Inter"/>
               </a:rPr>
-              <a:t>Обычный Unet выиграл: IoU 0.52 · mIoU 0.54</a:t>
-            </a:r>
-            <a:r>
-              <a:rPr sz="1400" b="0">
-                <a:solidFill>
-                  <a:srgbClr val="7D8690"/>
-                </a:solidFill>
-                <a:latin typeface="Inter"/>
-              </a:rPr>
-              <a:t>
-27 каналов, 91 эпоха — фриз, который сдаём</a:t>
-            </a:r>
-          </a:p>
-        </p:txBody>
-      </p:sp>
-      <p:sp>
-        <p:nvSpPr>
-          <p:cNvPr id="9" name="Oval 8"/>
-          <p:cNvSpPr/>
-          <p:nvPr/>
-        </p:nvSpPr>
-        <p:spPr>
-          <a:xfrm>
-            <a:off x="914400" y="4700016"/>
-            <a:ext cx="155448" cy="155448"/>
-          </a:xfrm>
-          <a:prstGeom prst="ellipse">
-            <a:avLst/>
-          </a:prstGeom>
-          <a:solidFill>
-            <a:srgbClr val="FF6B35"/>
-          </a:solidFill>
-          <a:ln>
-            <a:noFill/>
-          </a:ln>
-        </p:spPr>
-        <p:style>
-          <a:lnRef idx="1">
-            <a:schemeClr val="accent1"/>
-          </a:lnRef>
-          <a:fillRef idx="3">
-            <a:schemeClr val="accent1"/>
-          </a:fillRef>
-          <a:effectRef idx="2">
-            <a:schemeClr val="accent1"/>
-          </a:effectRef>
-          <a:fontRef idx="minor">
-            <a:schemeClr val="lt1"/>
-          </a:fontRef>
-        </p:style>
-        <p:txBody>
-          <a:bodyPr rtlCol="0" anchor="ctr"/>
-          <a:lstStyle/>
-          <a:p>
-            <a:pPr algn="ctr"/>
-          </a:p>
-        </p:txBody>
-      </p:sp>
-      <p:sp>
-        <p:nvSpPr>
-          <p:cNvPr id="10" name="TextBox 9"/>
+              <a:t>ЖИМ НОГАМИ · KOSMOHACK 2026</a:t>
+            </a:r>
+          </a:p>
+        </p:txBody>
+      </p:sp>
+      <p:sp>
+        <p:nvSpPr>
+          <p:cNvPr id="8" name="TextBox 7"/>
           <p:cNvSpPr txBox="1"/>
           <p:nvPr/>
         </p:nvSpPr>
         <p:spPr>
           <a:xfrm>
-            <a:off x="1280160" y="4498848"/>
-            <a:ext cx="10241280" cy="868680"/>
+            <a:off x="10789920" y="6400800"/>
+            <a:ext cx="914400" cy="274320"/>
           </a:xfrm>
           <a:prstGeom prst="rect">
             <a:avLst/>
@@ -5838,25 +6385,15 @@
           </a:bodyPr>
           <a:lstStyle/>
           <a:p>
-            <a:pPr algn="l"/>
-            <a:r>
-              <a:rPr sz="2100" b="0">
-                <a:solidFill>
-                  <a:srgbClr val="F2F4F5"/>
+            <a:pPr algn="r"/>
+            <a:r>
+              <a:rPr sz="1100" b="1">
+                <a:solidFill>
+                  <a:srgbClr val="7D8690"/>
                 </a:solidFill>
                 <a:latin typeface="Inter"/>
               </a:rPr>
-              <a:t>Две добивки проиграли фризу (0.62 и 0.63 против 0.65)</a:t>
-            </a:r>
-            <a:r>
-              <a:rPr sz="1400" b="0">
-                <a:solidFill>
-                  <a:srgbClr val="7D8690"/>
-                </a:solidFill>
-                <a:latin typeface="Inter"/>
-              </a:rPr>
-              <a:t>
-поэтому сдаём проверенное, а не последнее</a:t>
+              <a:t>04</a:t>
             </a:r>
           </a:p>
         </p:txBody>
@@ -5895,8 +6432,8 @@
         </p:nvSpPr>
         <p:spPr>
           <a:xfrm>
-            <a:off x="640080" y="274320"/>
-            <a:ext cx="10881360" cy="365760"/>
+            <a:off x="640080" y="457200"/>
+            <a:ext cx="10881360" cy="548640"/>
           </a:xfrm>
           <a:prstGeom prst="rect">
             <a:avLst/>
@@ -5911,70 +6448,27 @@
           <a:p>
             <a:pPr algn="l"/>
             <a:r>
-              <a:rPr sz="1200" b="1">
-                <a:solidFill>
-                  <a:srgbClr val="7D8690"/>
+              <a:rPr sz="1500" b="1">
+                <a:solidFill>
+                  <a:srgbClr val="E6C65C"/>
                 </a:solidFill>
                 <a:latin typeface="Inter"/>
               </a:rPr>
-              <a:t>ЖИМ НОГАМИ · KOSMOHACK</a:t>
-            </a:r>
-          </a:p>
-        </p:txBody>
-      </p:sp>
-      <p:sp>
-        <p:nvSpPr>
-          <p:cNvPr id="3" name="Oval 2"/>
-          <p:cNvSpPr/>
-          <p:nvPr/>
-        </p:nvSpPr>
-        <p:spPr>
-          <a:xfrm>
-            <a:off x="11658600" y="384048"/>
-            <a:ext cx="128016" cy="128016"/>
-          </a:xfrm>
-          <a:prstGeom prst="ellipse">
-            <a:avLst/>
-          </a:prstGeom>
-          <a:solidFill>
-            <a:srgbClr val="62D99A"/>
-          </a:solidFill>
-          <a:ln>
-            <a:noFill/>
-          </a:ln>
-        </p:spPr>
-        <p:style>
-          <a:lnRef idx="1">
-            <a:schemeClr val="accent1"/>
-          </a:lnRef>
-          <a:fillRef idx="3">
-            <a:schemeClr val="accent1"/>
-          </a:fillRef>
-          <a:effectRef idx="2">
-            <a:schemeClr val="accent1"/>
-          </a:effectRef>
-          <a:fontRef idx="minor">
-            <a:schemeClr val="lt1"/>
-          </a:fontRef>
-        </p:style>
-        <p:txBody>
-          <a:bodyPr rtlCol="0" anchor="ctr"/>
-          <a:lstStyle/>
-          <a:p>
-            <a:pPr algn="ctr"/>
-          </a:p>
-        </p:txBody>
-      </p:sp>
-      <p:sp>
-        <p:nvSpPr>
-          <p:cNvPr id="4" name="TextBox 3"/>
+              <a:t>Карты гарей</a:t>
+            </a:r>
+          </a:p>
+        </p:txBody>
+      </p:sp>
+      <p:sp>
+        <p:nvSpPr>
+          <p:cNvPr id="3" name="TextBox 2"/>
           <p:cNvSpPr txBox="1"/>
           <p:nvPr/>
         </p:nvSpPr>
         <p:spPr>
           <a:xfrm>
-            <a:off x="640080" y="777240"/>
-            <a:ext cx="10881360" cy="1097280"/>
+            <a:off x="640080" y="1005840"/>
+            <a:ext cx="4572000" cy="1280160"/>
           </a:xfrm>
           <a:prstGeom prst="rect">
             <a:avLst/>
@@ -5989,74 +6483,27 @@
           <a:p>
             <a:pPr algn="l"/>
             <a:r>
-              <a:rPr sz="3800" b="1">
-                <a:solidFill>
-                  <a:srgbClr val="F2F4F5"/>
+              <a:rPr sz="11000" b="1">
+                <a:solidFill>
+                  <a:srgbClr val="E6C65C"/>
                 </a:solidFill>
                 <a:latin typeface="Inter"/>
               </a:rPr>
-              <a:t>Итог: 0.654 — честные</a:t>
-            </a:r>
-          </a:p>
-        </p:txBody>
-      </p:sp>
-      <p:sp>
-        <p:nvSpPr>
-          <p:cNvPr id="5" name="Rounded Rectangle 4"/>
-          <p:cNvSpPr/>
-          <p:nvPr/>
-        </p:nvSpPr>
-        <p:spPr>
-          <a:xfrm>
-            <a:off x="640080" y="2194560"/>
-            <a:ext cx="10881360" cy="1463040"/>
-          </a:xfrm>
-          <a:prstGeom prst="roundRect">
-            <a:avLst>
-              <a:gd name="adj" fmla="val 7000"/>
-            </a:avLst>
-          </a:prstGeom>
-          <a:solidFill>
-            <a:srgbClr val="0D1217"/>
-          </a:solidFill>
-          <a:ln w="12700">
-            <a:solidFill>
-              <a:srgbClr val="2A333D"/>
-            </a:solidFill>
-          </a:ln>
-        </p:spPr>
-        <p:style>
-          <a:lnRef idx="1">
-            <a:schemeClr val="accent1"/>
-          </a:lnRef>
-          <a:fillRef idx="3">
-            <a:schemeClr val="accent1"/>
-          </a:fillRef>
-          <a:effectRef idx="2">
-            <a:schemeClr val="accent1"/>
-          </a:effectRef>
-          <a:fontRef idx="minor">
-            <a:schemeClr val="lt1"/>
-          </a:fontRef>
-        </p:style>
-        <p:txBody>
-          <a:bodyPr rtlCol="0" anchor="ctr"/>
-          <a:lstStyle/>
-          <a:p>
-            <a:pPr algn="ctr"/>
-          </a:p>
-        </p:txBody>
-      </p:sp>
-      <p:sp>
-        <p:nvSpPr>
-          <p:cNvPr id="6" name="TextBox 5"/>
+              <a:t>0.52</a:t>
+            </a:r>
+          </a:p>
+        </p:txBody>
+      </p:sp>
+      <p:sp>
+        <p:nvSpPr>
+          <p:cNvPr id="4" name="TextBox 3"/>
           <p:cNvSpPr txBox="1"/>
           <p:nvPr/>
         </p:nvSpPr>
         <p:spPr>
           <a:xfrm>
-            <a:off x="914400" y="2377440"/>
-            <a:ext cx="10332720" cy="1097280"/>
+            <a:off x="640080" y="2651760"/>
+            <a:ext cx="4572000" cy="457200"/>
           </a:xfrm>
           <a:prstGeom prst="rect">
             <a:avLst/>
@@ -6071,80 +6518,96 @@
           <a:p>
             <a:pPr algn="l"/>
             <a:r>
-              <a:rPr sz="2700" b="1">
-                <a:solidFill>
-                  <a:srgbClr val="F2F4F5"/>
+              <a:rPr sz="1900" b="0">
+                <a:solidFill>
+                  <a:srgbClr val="B8C0C8"/>
                 </a:solidFill>
                 <a:latin typeface="Inter"/>
               </a:rPr>
-              <a:t>0.35 × 0.8434  +  0.35 × 0.5239  +  0.30 × 0.5430  =  0.654</a:t>
-            </a:r>
-            <a:r>
-              <a:rPr sz="1500" b="0">
+              <a:t>IoU · mIoU severity 0.54</a:t>
+            </a:r>
+          </a:p>
+        </p:txBody>
+      </p:sp>
+      <p:sp>
+        <p:nvSpPr>
+          <p:cNvPr id="5" name="TextBox 4"/>
+          <p:cNvSpPr txBox="1"/>
+          <p:nvPr/>
+        </p:nvSpPr>
+        <p:spPr>
+          <a:xfrm>
+            <a:off x="640080" y="3291840"/>
+            <a:ext cx="4572000" cy="2011680"/>
+          </a:xfrm>
+          <a:prstGeom prst="rect">
+            <a:avLst/>
+          </a:prstGeom>
+          <a:noFill/>
+        </p:spPr>
+        <p:txBody>
+          <a:bodyPr wrap="square">
+            <a:spAutoFit/>
+          </a:bodyPr>
+          <a:lstStyle/>
+          <a:p>
+            <a:pPr algn="l"/>
+            <a:r>
+              <a:rPr sz="1900" b="1">
+                <a:solidFill>
+                  <a:srgbClr val="F2F4F5"/>
+                </a:solidFill>
+                <a:latin typeface="Inter"/>
+              </a:rPr>
+              <a:t>Prithvi-300M похоронен: 0.16</a:t>
+            </a:r>
+            <a:r>
+              <a:rPr sz="1600" b="0">
                 <a:solidFill>
                   <a:srgbClr val="7D8690"/>
                 </a:solidFill>
                 <a:latin typeface="Inter"/>
               </a:rPr>
               <a:t>
-447 строк · RLE валиден · два прогона идентичны · md5 зафиксирован</a:t>
-            </a:r>
-          </a:p>
-        </p:txBody>
-      </p:sp>
-      <p:sp>
-        <p:nvSpPr>
-          <p:cNvPr id="7" name="Oval 6"/>
-          <p:cNvSpPr/>
-          <p:nvPr/>
-        </p:nvSpPr>
-        <p:spPr>
-          <a:xfrm>
-            <a:off x="914400" y="4334255"/>
-            <a:ext cx="155448" cy="155448"/>
-          </a:xfrm>
-          <a:prstGeom prst="ellipse">
-            <a:avLst/>
-          </a:prstGeom>
-          <a:solidFill>
-            <a:srgbClr val="62D99A"/>
-          </a:solidFill>
-          <a:ln>
-            <a:noFill/>
-          </a:ln>
-        </p:spPr>
-        <p:style>
-          <a:lnRef idx="1">
-            <a:schemeClr val="accent1"/>
-          </a:lnRef>
-          <a:fillRef idx="3">
-            <a:schemeClr val="accent1"/>
-          </a:fillRef>
-          <a:effectRef idx="2">
-            <a:schemeClr val="accent1"/>
-          </a:effectRef>
-          <a:fontRef idx="minor">
-            <a:schemeClr val="lt1"/>
-          </a:fontRef>
-        </p:style>
-        <p:txBody>
-          <a:bodyPr rtlCol="0" anchor="ctr"/>
-          <a:lstStyle/>
-          <a:p>
-            <a:pPr algn="ctr"/>
-          </a:p>
-        </p:txBody>
-      </p:sp>
-      <p:sp>
-        <p:nvSpPr>
-          <p:cNvPr id="8" name="TextBox 7"/>
+Пороги dNBR под каждый ландшафт · retry-ветки проиграли фризу ep91</a:t>
+            </a:r>
+          </a:p>
+        </p:txBody>
+      </p:sp>
+      <p:pic>
+        <p:nvPicPr>
+          <p:cNvPr id="6" name="Picture 5" descr="02-burned-only.png"/>
+          <p:cNvPicPr>
+            <a:picLocks noChangeAspect="1"/>
+          </p:cNvPicPr>
+          <p:nvPr/>
+        </p:nvPicPr>
+        <p:blipFill>
+          <a:blip r:embed="rId2"/>
+          <a:stretch>
+            <a:fillRect/>
+          </a:stretch>
+        </p:blipFill>
+        <p:spPr>
+          <a:xfrm>
+            <a:off x="6035040" y="1097280"/>
+            <a:ext cx="5486400" cy="4663440"/>
+          </a:xfrm>
+          <a:prstGeom prst="rect">
+            <a:avLst/>
+          </a:prstGeom>
+        </p:spPr>
+      </p:pic>
+      <p:sp>
+        <p:nvSpPr>
+          <p:cNvPr id="7" name="TextBox 6"/>
           <p:cNvSpPr txBox="1"/>
           <p:nvPr/>
         </p:nvSpPr>
         <p:spPr>
           <a:xfrm>
-            <a:off x="1280160" y="4133087"/>
-            <a:ext cx="10241280" cy="868680"/>
+            <a:off x="457200" y="6400800"/>
+            <a:ext cx="7315200" cy="274320"/>
           </a:xfrm>
           <a:prstGeom prst="rect">
             <a:avLst/>
@@ -6159,23 +6622,48 @@
           <a:p>
             <a:pPr algn="l"/>
             <a:r>
-              <a:rPr sz="1900" b="0">
-                <a:solidFill>
-                  <a:srgbClr val="F2F4F5"/>
+              <a:rPr sz="1100" b="1">
+                <a:solidFill>
+                  <a:srgbClr val="7D8690"/>
                 </a:solidFill>
                 <a:latin typeface="Inter"/>
               </a:rPr>
-              <a:t>Файл примут с первого раза</a:t>
-            </a:r>
-            <a:r>
-              <a:rPr sz="1400" b="0">
+              <a:t>ЖИМ НОГАМИ · KOSMOHACK 2026</a:t>
+            </a:r>
+          </a:p>
+        </p:txBody>
+      </p:sp>
+      <p:sp>
+        <p:nvSpPr>
+          <p:cNvPr id="8" name="TextBox 7"/>
+          <p:cNvSpPr txBox="1"/>
+          <p:nvPr/>
+        </p:nvSpPr>
+        <p:spPr>
+          <a:xfrm>
+            <a:off x="10789920" y="6400800"/>
+            <a:ext cx="914400" cy="274320"/>
+          </a:xfrm>
+          <a:prstGeom prst="rect">
+            <a:avLst/>
+          </a:prstGeom>
+          <a:noFill/>
+        </p:spPr>
+        <p:txBody>
+          <a:bodyPr wrap="square">
+            <a:spAutoFit/>
+          </a:bodyPr>
+          <a:lstStyle/>
+          <a:p>
+            <a:pPr algn="r"/>
+            <a:r>
+              <a:rPr sz="1100" b="1">
                 <a:solidFill>
                   <a:srgbClr val="7D8690"/>
                 </a:solidFill>
                 <a:latin typeface="Inter"/>
               </a:rPr>
-              <a:t>
-пары совпадают с шаблоном, NaN ноль, пересечений ноль</a:t>
+              <a:t>05</a:t>
             </a:r>
           </a:p>
         </p:txBody>
@@ -6206,30 +6694,216 @@
         <p:nvPr/>
       </p:nvGrpSpPr>
       <p:grpSpPr/>
-      <p:pic>
-        <p:nvPicPr>
-          <p:cNvPr id="2" name="Picture 1" descr="01-map-full.png"/>
-          <p:cNvPicPr>
-            <a:picLocks noChangeAspect="1"/>
-          </p:cNvPicPr>
-          <p:nvPr/>
-        </p:nvPicPr>
-        <p:blipFill>
-          <a:blip r:embed="rId2"/>
-          <a:stretch>
-            <a:fillRect/>
-          </a:stretch>
-        </p:blipFill>
-        <p:spPr>
-          <a:xfrm>
-            <a:off x="0" y="0"/>
-            <a:ext cx="12188952" cy="6858000"/>
+      <p:sp>
+        <p:nvSpPr>
+          <p:cNvPr id="2" name="TextBox 1"/>
+          <p:cNvSpPr txBox="1"/>
+          <p:nvPr/>
+        </p:nvSpPr>
+        <p:spPr>
+          <a:xfrm>
+            <a:off x="640080" y="457200"/>
+            <a:ext cx="10881360" cy="548640"/>
           </a:xfrm>
           <a:prstGeom prst="rect">
             <a:avLst/>
           </a:prstGeom>
-        </p:spPr>
-      </p:pic>
+          <a:noFill/>
+        </p:spPr>
+        <p:txBody>
+          <a:bodyPr wrap="square">
+            <a:spAutoFit/>
+          </a:bodyPr>
+          <a:lstStyle/>
+          <a:p>
+            <a:pPr algn="l"/>
+            <a:r>
+              <a:rPr sz="1500" b="1">
+                <a:solidFill>
+                  <a:srgbClr val="62D99A"/>
+                </a:solidFill>
+                <a:latin typeface="Inter"/>
+              </a:rPr>
+              <a:t>Метрика · FINAL</a:t>
+            </a:r>
+          </a:p>
+        </p:txBody>
+      </p:sp>
+      <p:sp>
+        <p:nvSpPr>
+          <p:cNvPr id="3" name="TextBox 2"/>
+          <p:cNvSpPr txBox="1"/>
+          <p:nvPr/>
+        </p:nvSpPr>
+        <p:spPr>
+          <a:xfrm>
+            <a:off x="640080" y="1005840"/>
+            <a:ext cx="10881360" cy="1371600"/>
+          </a:xfrm>
+          <a:prstGeom prst="rect">
+            <a:avLst/>
+          </a:prstGeom>
+          <a:noFill/>
+        </p:spPr>
+        <p:txBody>
+          <a:bodyPr wrap="square">
+            <a:spAutoFit/>
+          </a:bodyPr>
+          <a:lstStyle/>
+          <a:p>
+            <a:pPr algn="ctr"/>
+            <a:r>
+              <a:rPr sz="11000" b="1">
+                <a:solidFill>
+                  <a:srgbClr val="F2F4F5"/>
+                </a:solidFill>
+                <a:latin typeface="Inter"/>
+              </a:rPr>
+              <a:t>0.654</a:t>
+            </a:r>
+          </a:p>
+        </p:txBody>
+      </p:sp>
+      <p:sp>
+        <p:nvSpPr>
+          <p:cNvPr id="4" name="TextBox 3"/>
+          <p:cNvSpPr txBox="1"/>
+          <p:nvPr/>
+        </p:nvSpPr>
+        <p:spPr>
+          <a:xfrm>
+            <a:off x="640080" y="2651760"/>
+            <a:ext cx="10881360" cy="548640"/>
+          </a:xfrm>
+          <a:prstGeom prst="rect">
+            <a:avLst/>
+          </a:prstGeom>
+          <a:noFill/>
+        </p:spPr>
+        <p:txBody>
+          <a:bodyPr wrap="square">
+            <a:spAutoFit/>
+          </a:bodyPr>
+          <a:lstStyle/>
+          <a:p>
+            <a:pPr algn="ctr"/>
+            <a:r>
+              <a:rPr sz="2200" b="0">
+                <a:solidFill>
+                  <a:srgbClr val="B8C0C8"/>
+                </a:solidFill>
+                <a:latin typeface="Inter"/>
+              </a:rPr>
+              <a:t>0.35 × 0.8434  +  0.35 × 0.5239  +  0.30 × 0.5430</a:t>
+            </a:r>
+          </a:p>
+        </p:txBody>
+      </p:sp>
+      <p:sp>
+        <p:nvSpPr>
+          <p:cNvPr id="5" name="TextBox 4"/>
+          <p:cNvSpPr txBox="1"/>
+          <p:nvPr/>
+        </p:nvSpPr>
+        <p:spPr>
+          <a:xfrm>
+            <a:off x="640080" y="3474720"/>
+            <a:ext cx="10881360" cy="1463040"/>
+          </a:xfrm>
+          <a:prstGeom prst="rect">
+            <a:avLst/>
+          </a:prstGeom>
+          <a:noFill/>
+        </p:spPr>
+        <p:txBody>
+          <a:bodyPr wrap="square">
+            <a:spAutoFit/>
+          </a:bodyPr>
+          <a:lstStyle/>
+          <a:p>
+            <a:pPr algn="ctr"/>
+            <a:r>
+              <a:rPr sz="1800" b="0">
+                <a:solidFill>
+                  <a:srgbClr val="7D8690"/>
+                </a:solidFill>
+                <a:latin typeface="Inter"/>
+              </a:rPr>
+              <a:t>447 строк = шаблону · RLE валиден · NaN 0 · пересечений 0 · md5 97b86c67 · переобучение запрещено</a:t>
+            </a:r>
+          </a:p>
+        </p:txBody>
+      </p:sp>
+      <p:sp>
+        <p:nvSpPr>
+          <p:cNvPr id="6" name="TextBox 5"/>
+          <p:cNvSpPr txBox="1"/>
+          <p:nvPr/>
+        </p:nvSpPr>
+        <p:spPr>
+          <a:xfrm>
+            <a:off x="457200" y="6400800"/>
+            <a:ext cx="7315200" cy="274320"/>
+          </a:xfrm>
+          <a:prstGeom prst="rect">
+            <a:avLst/>
+          </a:prstGeom>
+          <a:noFill/>
+        </p:spPr>
+        <p:txBody>
+          <a:bodyPr wrap="square">
+            <a:spAutoFit/>
+          </a:bodyPr>
+          <a:lstStyle/>
+          <a:p>
+            <a:pPr algn="l"/>
+            <a:r>
+              <a:rPr sz="1100" b="1">
+                <a:solidFill>
+                  <a:srgbClr val="7D8690"/>
+                </a:solidFill>
+                <a:latin typeface="Inter"/>
+              </a:rPr>
+              <a:t>ЖИМ НОГАМИ · KOSMOHACK 2026</a:t>
+            </a:r>
+          </a:p>
+        </p:txBody>
+      </p:sp>
+      <p:sp>
+        <p:nvSpPr>
+          <p:cNvPr id="7" name="TextBox 6"/>
+          <p:cNvSpPr txBox="1"/>
+          <p:nvPr/>
+        </p:nvSpPr>
+        <p:spPr>
+          <a:xfrm>
+            <a:off x="10789920" y="6400800"/>
+            <a:ext cx="914400" cy="274320"/>
+          </a:xfrm>
+          <a:prstGeom prst="rect">
+            <a:avLst/>
+          </a:prstGeom>
+          <a:noFill/>
+        </p:spPr>
+        <p:txBody>
+          <a:bodyPr wrap="square">
+            <a:spAutoFit/>
+          </a:bodyPr>
+          <a:lstStyle/>
+          <a:p>
+            <a:pPr algn="r"/>
+            <a:r>
+              <a:rPr sz="1100" b="1">
+                <a:solidFill>
+                  <a:srgbClr val="7D8690"/>
+                </a:solidFill>
+                <a:latin typeface="Inter"/>
+              </a:rPr>
+              <a:t>06</a:t>
+            </a:r>
+          </a:p>
+        </p:txBody>
+      </p:sp>
     </p:spTree>
   </p:cSld>
   <p:clrMapOvr>
@@ -6256,122 +6930,9 @@
         <p:nvPr/>
       </p:nvGrpSpPr>
       <p:grpSpPr/>
-      <p:sp>
-        <p:nvSpPr>
-          <p:cNvPr id="2" name="TextBox 1"/>
-          <p:cNvSpPr txBox="1"/>
-          <p:nvPr/>
-        </p:nvSpPr>
-        <p:spPr>
-          <a:xfrm>
-            <a:off x="640080" y="274320"/>
-            <a:ext cx="10881360" cy="365760"/>
-          </a:xfrm>
-          <a:prstGeom prst="rect">
-            <a:avLst/>
-          </a:prstGeom>
-          <a:noFill/>
-        </p:spPr>
-        <p:txBody>
-          <a:bodyPr wrap="square">
-            <a:spAutoFit/>
-          </a:bodyPr>
-          <a:lstStyle/>
-          <a:p>
-            <a:pPr algn="l"/>
-            <a:r>
-              <a:rPr sz="1200" b="1">
-                <a:solidFill>
-                  <a:srgbClr val="7D8690"/>
-                </a:solidFill>
-                <a:latin typeface="Inter"/>
-              </a:rPr>
-              <a:t>ЖИМ НОГАМИ · KOSMOHACK</a:t>
-            </a:r>
-          </a:p>
-        </p:txBody>
-      </p:sp>
-      <p:sp>
-        <p:nvSpPr>
-          <p:cNvPr id="3" name="Oval 2"/>
-          <p:cNvSpPr/>
-          <p:nvPr/>
-        </p:nvSpPr>
-        <p:spPr>
-          <a:xfrm>
-            <a:off x="11658600" y="384048"/>
-            <a:ext cx="128016" cy="128016"/>
-          </a:xfrm>
-          <a:prstGeom prst="ellipse">
-            <a:avLst/>
-          </a:prstGeom>
-          <a:solidFill>
-            <a:srgbClr val="62D99A"/>
-          </a:solidFill>
-          <a:ln>
-            <a:noFill/>
-          </a:ln>
-        </p:spPr>
-        <p:style>
-          <a:lnRef idx="1">
-            <a:schemeClr val="accent1"/>
-          </a:lnRef>
-          <a:fillRef idx="3">
-            <a:schemeClr val="accent1"/>
-          </a:fillRef>
-          <a:effectRef idx="2">
-            <a:schemeClr val="accent1"/>
-          </a:effectRef>
-          <a:fontRef idx="minor">
-            <a:schemeClr val="lt1"/>
-          </a:fontRef>
-        </p:style>
-        <p:txBody>
-          <a:bodyPr rtlCol="0" anchor="ctr"/>
-          <a:lstStyle/>
-          <a:p>
-            <a:pPr algn="ctr"/>
-          </a:p>
-        </p:txBody>
-      </p:sp>
-      <p:sp>
-        <p:nvSpPr>
-          <p:cNvPr id="4" name="TextBox 3"/>
-          <p:cNvSpPr txBox="1"/>
-          <p:nvPr/>
-        </p:nvSpPr>
-        <p:spPr>
-          <a:xfrm>
-            <a:off x="640080" y="640080"/>
-            <a:ext cx="10881360" cy="1097280"/>
-          </a:xfrm>
-          <a:prstGeom prst="rect">
-            <a:avLst/>
-          </a:prstGeom>
-          <a:noFill/>
-        </p:spPr>
-        <p:txBody>
-          <a:bodyPr wrap="square">
-            <a:spAutoFit/>
-          </a:bodyPr>
-          <a:lstStyle/>
-          <a:p>
-            <a:pPr algn="l"/>
-            <a:r>
-              <a:rPr sz="3400" b="1">
-                <a:solidFill>
-                  <a:srgbClr val="F2F4F5"/>
-                </a:solidFill>
-                <a:latin typeface="Inter"/>
-              </a:rPr>
-              <a:t>Карта умеет: слои, степени, справка</a:t>
-            </a:r>
-          </a:p>
-        </p:txBody>
-      </p:sp>
       <p:pic>
         <p:nvPicPr>
-          <p:cNvPr id="5" name="Picture 4" descr="02-burned-only.png"/>
+          <p:cNvPr id="2" name="Picture 1" descr="01-map-full.png"/>
           <p:cNvPicPr>
             <a:picLocks noChangeAspect="1"/>
           </p:cNvPicPr>
@@ -6385,32 +6946,8 @@
         </p:blipFill>
         <p:spPr>
           <a:xfrm>
-            <a:off x="640080" y="1828800"/>
-            <a:ext cx="6949440" cy="3909060"/>
-          </a:xfrm>
-          <a:prstGeom prst="rect">
-            <a:avLst/>
-          </a:prstGeom>
-        </p:spPr>
-      </p:pic>
-      <p:pic>
-        <p:nvPicPr>
-          <p:cNvPr id="6" name="Picture 5" descr="03-analytics.png"/>
-          <p:cNvPicPr>
-            <a:picLocks noChangeAspect="1"/>
-          </p:cNvPicPr>
-          <p:nvPr/>
-        </p:nvPicPr>
-        <p:blipFill>
-          <a:blip r:embed="rId3"/>
-          <a:stretch>
-            <a:fillRect/>
-          </a:stretch>
-        </p:blipFill>
-        <p:spPr>
-          <a:xfrm>
-            <a:off x="7863840" y="2926080"/>
-            <a:ext cx="3657600" cy="467617"/>
+            <a:off x="0" y="0"/>
+            <a:ext cx="12188952" cy="6858000"/>
           </a:xfrm>
           <a:prstGeom prst="rect">
             <a:avLst/>
@@ -6451,8 +6988,8 @@
         </p:nvSpPr>
         <p:spPr>
           <a:xfrm>
-            <a:off x="640080" y="274320"/>
-            <a:ext cx="10881360" cy="365760"/>
+            <a:off x="640080" y="457200"/>
+            <a:ext cx="10881360" cy="548640"/>
           </a:xfrm>
           <a:prstGeom prst="rect">
             <a:avLst/>
@@ -6467,27 +7004,62 @@
           <a:p>
             <a:pPr algn="l"/>
             <a:r>
-              <a:rPr sz="1200" b="1">
-                <a:solidFill>
-                  <a:srgbClr val="7D8690"/>
+              <a:rPr sz="1500" b="1">
+                <a:solidFill>
+                  <a:srgbClr val="FF6B35"/>
                 </a:solidFill>
                 <a:latin typeface="Inter"/>
               </a:rPr>
-              <a:t>ЖИМ НОГАМИ · KOSMOHACK</a:t>
-            </a:r>
-          </a:p>
-        </p:txBody>
-      </p:sp>
-      <p:sp>
-        <p:nvSpPr>
-          <p:cNvPr id="3" name="Oval 2"/>
+              <a:t>Сервис</a:t>
+            </a:r>
+          </a:p>
+        </p:txBody>
+      </p:sp>
+      <p:sp>
+        <p:nvSpPr>
+          <p:cNvPr id="3" name="TextBox 2"/>
+          <p:cNvSpPr txBox="1"/>
+          <p:nvPr/>
+        </p:nvSpPr>
+        <p:spPr>
+          <a:xfrm>
+            <a:off x="640080" y="914400"/>
+            <a:ext cx="10881360" cy="1097280"/>
+          </a:xfrm>
+          <a:prstGeom prst="rect">
+            <a:avLst/>
+          </a:prstGeom>
+          <a:noFill/>
+        </p:spPr>
+        <p:txBody>
+          <a:bodyPr wrap="square">
+            <a:spAutoFit/>
+          </a:bodyPr>
+          <a:lstStyle/>
+          <a:p>
+            <a:pPr algn="l"/>
+            <a:r>
+              <a:rPr sz="6400" b="1">
+                <a:solidFill>
+                  <a:srgbClr val="F2F4F5"/>
+                </a:solidFill>
+                <a:latin typeface="Inter"/>
+              </a:rPr>
+              <a:t>Живое API</a:t>
+            </a:r>
+          </a:p>
+        </p:txBody>
+      </p:sp>
+      <p:sp>
+        <p:nvSpPr>
+          <p:cNvPr id="4" name="Oval 3"/>
           <p:cNvSpPr/>
           <p:nvPr/>
         </p:nvSpPr>
         <p:spPr>
           <a:xfrm>
-            <a:off x="11658600" y="384048"/>
-            <a:ext cx="128016" cy="128016"/>
+            <a:off x="914400" y="3566160"/>
+            <a:ext cx="155448" cy="155448"/>
           </a:xfrm>
           <a:prstGeom prst="ellipse">
             <a:avLst/>
@@ -6523,14 +7095,14 @@
       </p:sp>
       <p:sp>
         <p:nvSpPr>
-          <p:cNvPr id="4" name="TextBox 3"/>
+          <p:cNvPr id="5" name="TextBox 4"/>
           <p:cNvSpPr txBox="1"/>
           <p:nvPr/>
         </p:nvSpPr>
         <p:spPr>
           <a:xfrm>
-            <a:off x="640080" y="777240"/>
-            <a:ext cx="10881360" cy="1097280"/>
+            <a:off x="1280160" y="3493008"/>
+            <a:ext cx="10241280" cy="731520"/>
           </a:xfrm>
           <a:prstGeom prst="rect">
             <a:avLst/>
@@ -6545,33 +7117,43 @@
           <a:p>
             <a:pPr algn="l"/>
             <a:r>
-              <a:rPr sz="3800" b="1">
+              <a:rPr sz="2100" b="0">
                 <a:solidFill>
                   <a:srgbClr val="F2F4F5"/>
                 </a:solidFill>
                 <a:latin typeface="Inter"/>
               </a:rPr>
-              <a:t>Под картой — настоящее API</a:t>
-            </a:r>
-          </a:p>
-        </p:txBody>
-      </p:sp>
-      <p:sp>
-        <p:nvSpPr>
-          <p:cNvPr id="5" name="Oval 4"/>
+              <a:t>3 GET + 3 POST</a:t>
+            </a:r>
+            <a:r>
+              <a:rPr sz="1500" b="0">
+                <a:solidFill>
+                  <a:srgbClr val="7D8690"/>
+                </a:solidFill>
+                <a:latin typeface="Inter"/>
+              </a:rPr>
+              <a:t>
+точки · полигоны · аналитика · shp-архив</a:t>
+            </a:r>
+          </a:p>
+        </p:txBody>
+      </p:sp>
+      <p:sp>
+        <p:nvSpPr>
+          <p:cNvPr id="6" name="Oval 5"/>
           <p:cNvSpPr/>
           <p:nvPr/>
         </p:nvSpPr>
         <p:spPr>
           <a:xfrm>
-            <a:off x="914400" y="2414016"/>
+            <a:off x="914400" y="4389120"/>
             <a:ext cx="155448" cy="155448"/>
           </a:xfrm>
           <a:prstGeom prst="ellipse">
             <a:avLst/>
           </a:prstGeom>
           <a:solidFill>
-            <a:srgbClr val="62D99A"/>
+            <a:srgbClr val="F2F4F5"/>
           </a:solidFill>
           <a:ln>
             <a:noFill/>
@@ -6601,14 +7183,14 @@
       </p:sp>
       <p:sp>
         <p:nvSpPr>
-          <p:cNvPr id="6" name="TextBox 5"/>
+          <p:cNvPr id="7" name="TextBox 6"/>
           <p:cNvSpPr txBox="1"/>
           <p:nvPr/>
         </p:nvSpPr>
         <p:spPr>
           <a:xfrm>
-            <a:off x="1280160" y="2212848"/>
-            <a:ext cx="10241280" cy="868680"/>
+            <a:off x="1280160" y="4315968"/>
+            <a:ext cx="10241280" cy="731520"/>
           </a:xfrm>
           <a:prstGeom prst="rect">
             <a:avLst/>
@@ -6629,37 +7211,37 @@
                 </a:solidFill>
                 <a:latin typeface="Inter"/>
               </a:rPr>
-              <a:t>3 GET по прямоугольнику + 3 POST по полигону</a:t>
-            </a:r>
-            <a:r>
-              <a:rPr sz="1400" b="0">
+              <a:t>9 curl-проверок — все зелёные</a:t>
+            </a:r>
+            <a:r>
+              <a:rPr sz="1500" b="0">
                 <a:solidFill>
                   <a:srgbClr val="7D8690"/>
                 </a:solidFill>
                 <a:latin typeface="Inter"/>
               </a:rPr>
               <a:t>
-точки, полигоны, аналитика — geojson, json, shp-архив</a:t>
-            </a:r>
-          </a:p>
-        </p:txBody>
-      </p:sp>
-      <p:sp>
-        <p:nvSpPr>
-          <p:cNvPr id="7" name="Oval 6"/>
+серия лежит в репозитории</a:t>
+            </a:r>
+          </a:p>
+        </p:txBody>
+      </p:sp>
+      <p:sp>
+        <p:nvSpPr>
+          <p:cNvPr id="8" name="Oval 7"/>
           <p:cNvSpPr/>
           <p:nvPr/>
         </p:nvSpPr>
         <p:spPr>
           <a:xfrm>
-            <a:off x="914400" y="3557016"/>
+            <a:off x="914400" y="5212080"/>
             <a:ext cx="155448" cy="155448"/>
           </a:xfrm>
           <a:prstGeom prst="ellipse">
             <a:avLst/>
           </a:prstGeom>
           <a:solidFill>
-            <a:srgbClr val="F2F4F5"/>
+            <a:srgbClr val="E6C65C"/>
           </a:solidFill>
           <a:ln>
             <a:noFill/>
@@ -6689,14 +7271,14 @@
       </p:sp>
       <p:sp>
         <p:nvSpPr>
-          <p:cNvPr id="8" name="TextBox 7"/>
+          <p:cNvPr id="9" name="TextBox 8"/>
           <p:cNvSpPr txBox="1"/>
           <p:nvPr/>
         </p:nvSpPr>
         <p:spPr>
           <a:xfrm>
-            <a:off x="1280160" y="3355848"/>
-            <a:ext cx="10241280" cy="868680"/>
+            <a:off x="1280160" y="5138928"/>
+            <a:ext cx="10241280" cy="731520"/>
           </a:xfrm>
           <a:prstGeom prst="rect">
             <a:avLst/>
@@ -6717,61 +7299,18 @@
                 </a:solidFill>
                 <a:latin typeface="Inter"/>
               </a:rPr>
-              <a:t>Проверено серией из 9 curl-запросов</a:t>
-            </a:r>
-            <a:r>
-              <a:rPr sz="1400" b="0">
+              <a:t>Без базы — нечему падать</a:t>
+            </a:r>
+            <a:r>
+              <a:rPr sz="1500" b="0">
                 <a:solidFill>
                   <a:srgbClr val="7D8690"/>
                 </a:solidFill>
                 <a:latin typeface="Inter"/>
               </a:rPr>
               <a:t>
-все зелёные — файл серии лежит в репозитории</a:t>
-            </a:r>
-          </a:p>
-        </p:txBody>
-      </p:sp>
-      <p:sp>
-        <p:nvSpPr>
-          <p:cNvPr id="9" name="Oval 8"/>
-          <p:cNvSpPr/>
-          <p:nvPr/>
-        </p:nvSpPr>
-        <p:spPr>
-          <a:xfrm>
-            <a:off x="914400" y="4700016"/>
-            <a:ext cx="155448" cy="155448"/>
-          </a:xfrm>
-          <a:prstGeom prst="ellipse">
-            <a:avLst/>
-          </a:prstGeom>
-          <a:solidFill>
-            <a:srgbClr val="E6C65C"/>
-          </a:solidFill>
-          <a:ln>
-            <a:noFill/>
-          </a:ln>
-        </p:spPr>
-        <p:style>
-          <a:lnRef idx="1">
-            <a:schemeClr val="accent1"/>
-          </a:lnRef>
-          <a:fillRef idx="3">
-            <a:schemeClr val="accent1"/>
-          </a:fillRef>
-          <a:effectRef idx="2">
-            <a:schemeClr val="accent1"/>
-          </a:effectRef>
-          <a:fontRef idx="minor">
-            <a:schemeClr val="lt1"/>
-          </a:fontRef>
-        </p:style>
-        <p:txBody>
-          <a:bodyPr rtlCol="0" anchor="ctr"/>
-          <a:lstStyle/>
-          <a:p>
-            <a:pPr algn="ctr"/>
+файловый бэкенд</a:t>
+            </a:r>
           </a:p>
         </p:txBody>
       </p:sp>
@@ -6783,8 +7322,8 @@
         </p:nvSpPr>
         <p:spPr>
           <a:xfrm>
-            <a:off x="1280160" y="4498848"/>
-            <a:ext cx="10241280" cy="868680"/>
+            <a:off x="457200" y="6400800"/>
+            <a:ext cx="7315200" cy="274320"/>
           </a:xfrm>
           <a:prstGeom prst="rect">
             <a:avLst/>
@@ -6799,23 +7338,48 @@
           <a:p>
             <a:pPr algn="l"/>
             <a:r>
-              <a:rPr sz="2100" b="0">
-                <a:solidFill>
-                  <a:srgbClr val="F2F4F5"/>
+              <a:rPr sz="1100" b="1">
+                <a:solidFill>
+                  <a:srgbClr val="7D8690"/>
                 </a:solidFill>
                 <a:latin typeface="Inter"/>
               </a:rPr>
-              <a:t>Без базы данных — файловый бэкенд</a:t>
-            </a:r>
-            <a:r>
-              <a:rPr sz="1400" b="0">
+              <a:t>ЖИМ НОГАМИ · KOSMOHACK 2026</a:t>
+            </a:r>
+          </a:p>
+        </p:txBody>
+      </p:sp>
+      <p:sp>
+        <p:nvSpPr>
+          <p:cNvPr id="11" name="TextBox 10"/>
+          <p:cNvSpPr txBox="1"/>
+          <p:nvPr/>
+        </p:nvSpPr>
+        <p:spPr>
+          <a:xfrm>
+            <a:off x="10789920" y="6400800"/>
+            <a:ext cx="914400" cy="274320"/>
+          </a:xfrm>
+          <a:prstGeom prst="rect">
+            <a:avLst/>
+          </a:prstGeom>
+          <a:noFill/>
+        </p:spPr>
+        <p:txBody>
+          <a:bodyPr wrap="square">
+            <a:spAutoFit/>
+          </a:bodyPr>
+          <a:lstStyle/>
+          <a:p>
+            <a:pPr algn="r"/>
+            <a:r>
+              <a:rPr sz="1100" b="1">
                 <a:solidFill>
                   <a:srgbClr val="7D8690"/>
                 </a:solidFill>
                 <a:latin typeface="Inter"/>
               </a:rPr>
-              <a:t>
-нечему падать на защите</a:t>
+              <a:t>08</a:t>
             </a:r>
           </a:p>
         </p:txBody>
@@ -6854,8 +7418,8 @@
         </p:nvSpPr>
         <p:spPr>
           <a:xfrm>
-            <a:off x="640080" y="274320"/>
-            <a:ext cx="10881360" cy="365760"/>
+            <a:off x="640080" y="457200"/>
+            <a:ext cx="10881360" cy="548640"/>
           </a:xfrm>
           <a:prstGeom prst="rect">
             <a:avLst/>
@@ -6870,36 +7434,75 @@
           <a:p>
             <a:pPr algn="l"/>
             <a:r>
-              <a:rPr sz="1200" b="1">
-                <a:solidFill>
-                  <a:srgbClr val="7D8690"/>
+              <a:rPr sz="1500" b="1">
+                <a:solidFill>
+                  <a:srgbClr val="62D99A"/>
                 </a:solidFill>
                 <a:latin typeface="Inter"/>
               </a:rPr>
-              <a:t>ЖИМ НОГАМИ · KOSMOHACK</a:t>
-            </a:r>
-          </a:p>
-        </p:txBody>
-      </p:sp>
-      <p:sp>
-        <p:nvSpPr>
-          <p:cNvPr id="3" name="Oval 2"/>
+              <a:t>Воспроизводимость</a:t>
+            </a:r>
+          </a:p>
+        </p:txBody>
+      </p:sp>
+      <p:sp>
+        <p:nvSpPr>
+          <p:cNvPr id="3" name="TextBox 2"/>
+          <p:cNvSpPr txBox="1"/>
+          <p:nvPr/>
+        </p:nvSpPr>
+        <p:spPr>
+          <a:xfrm>
+            <a:off x="640080" y="914400"/>
+            <a:ext cx="10881360" cy="1097280"/>
+          </a:xfrm>
+          <a:prstGeom prst="rect">
+            <a:avLst/>
+          </a:prstGeom>
+          <a:noFill/>
+        </p:spPr>
+        <p:txBody>
+          <a:bodyPr wrap="square">
+            <a:spAutoFit/>
+          </a:bodyPr>
+          <a:lstStyle/>
+          <a:p>
+            <a:pPr algn="l"/>
+            <a:r>
+              <a:rPr sz="6400" b="1">
+                <a:solidFill>
+                  <a:srgbClr val="F2F4F5"/>
+                </a:solidFill>
+                <a:latin typeface="Inter"/>
+              </a:rPr>
+              <a:t>Одна команда</a:t>
+            </a:r>
+          </a:p>
+        </p:txBody>
+      </p:sp>
+      <p:sp>
+        <p:nvSpPr>
+          <p:cNvPr id="4" name="Rounded Rectangle 3"/>
           <p:cNvSpPr/>
           <p:nvPr/>
         </p:nvSpPr>
         <p:spPr>
           <a:xfrm>
-            <a:off x="11658600" y="384048"/>
-            <a:ext cx="128016" cy="128016"/>
-          </a:xfrm>
-          <a:prstGeom prst="ellipse">
-            <a:avLst/>
+            <a:off x="640080" y="2651760"/>
+            <a:ext cx="10881360" cy="1371600"/>
+          </a:xfrm>
+          <a:prstGeom prst="roundRect">
+            <a:avLst>
+              <a:gd name="adj" fmla="val 6000"/>
+            </a:avLst>
           </a:prstGeom>
           <a:solidFill>
-            <a:srgbClr val="62D99A"/>
+            <a:srgbClr val="0D1217"/>
           </a:solidFill>
-          <a:ln>
-            <a:noFill/>
+          <a:ln w="12700">
+            <a:solidFill>
+              <a:srgbClr val="2A333D"/>
+            </a:solidFill>
           </a:ln>
         </p:spPr>
         <p:style>
@@ -6926,51 +7529,16 @@
       </p:sp>
       <p:sp>
         <p:nvSpPr>
-          <p:cNvPr id="4" name="TextBox 3"/>
-          <p:cNvSpPr txBox="1"/>
-          <p:nvPr/>
-        </p:nvSpPr>
-        <p:spPr>
-          <a:xfrm>
-            <a:off x="640080" y="777240"/>
-            <a:ext cx="10881360" cy="1097280"/>
-          </a:xfrm>
-          <a:prstGeom prst="rect">
-            <a:avLst/>
-          </a:prstGeom>
-          <a:noFill/>
-        </p:spPr>
-        <p:txBody>
-          <a:bodyPr wrap="square">
-            <a:spAutoFit/>
-          </a:bodyPr>
-          <a:lstStyle/>
-          <a:p>
-            <a:pPr algn="l"/>
-            <a:r>
-              <a:rPr sz="3800" b="1">
-                <a:solidFill>
-                  <a:srgbClr val="F2F4F5"/>
-                </a:solidFill>
-                <a:latin typeface="Inter"/>
-              </a:rPr>
-              <a:t>Заведётся и у вас</a:t>
-            </a:r>
-          </a:p>
-        </p:txBody>
-      </p:sp>
-      <p:sp>
-        <p:nvSpPr>
-          <p:cNvPr id="5" name="Oval 4"/>
+          <p:cNvPr id="5" name="Rounded Rectangle 4"/>
           <p:cNvSpPr/>
           <p:nvPr/>
         </p:nvSpPr>
         <p:spPr>
           <a:xfrm>
-            <a:off x="914400" y="2414016"/>
-            <a:ext cx="155448" cy="155448"/>
-          </a:xfrm>
-          <a:prstGeom prst="ellipse">
+            <a:off x="640080" y="2788920"/>
+            <a:ext cx="82296" cy="1097280"/>
+          </a:xfrm>
+          <a:prstGeom prst="roundRect">
             <a:avLst/>
           </a:prstGeom>
           <a:solidFill>
@@ -7010,8 +7578,8 @@
         </p:nvSpPr>
         <p:spPr>
           <a:xfrm>
-            <a:off x="1280160" y="2212848"/>
-            <a:ext cx="10241280" cy="868680"/>
+            <a:off x="1005840" y="2834640"/>
+            <a:ext cx="10149840" cy="1005840"/>
           </a:xfrm>
           <a:prstGeom prst="rect">
             <a:avLst/>
@@ -7026,80 +7594,37 @@
           <a:p>
             <a:pPr algn="l"/>
             <a:r>
-              <a:rPr sz="2200" b="0">
+              <a:rPr sz="2100" b="1">
                 <a:solidFill>
                   <a:srgbClr val="F2F4F5"/>
                 </a:solidFill>
                 <a:latin typeface="Inter"/>
               </a:rPr>
-              <a:t>Веса лежат в репозитории</a:t>
-            </a:r>
-            <a:r>
-              <a:rPr sz="1400" b="0">
+              <a:t>inference.py --data-dir &lt;test&gt; --output submission.csv</a:t>
+            </a:r>
+            <a:r>
+              <a:rPr sz="1600" b="0">
                 <a:solidFill>
                   <a:srgbClr val="7D8690"/>
                 </a:solidFill>
                 <a:latin typeface="Inter"/>
               </a:rPr>
               <a:t>
-докачивать нечего</a:t>
-            </a:r>
-          </a:p>
-        </p:txBody>
-      </p:sp>
-      <p:sp>
-        <p:nvSpPr>
-          <p:cNvPr id="7" name="Oval 6"/>
-          <p:cNvSpPr/>
-          <p:nvPr/>
-        </p:nvSpPr>
-        <p:spPr>
-          <a:xfrm>
-            <a:off x="914400" y="3602736"/>
-            <a:ext cx="155448" cy="155448"/>
-          </a:xfrm>
-          <a:prstGeom prst="ellipse">
-            <a:avLst/>
-          </a:prstGeom>
-          <a:solidFill>
-            <a:srgbClr val="F2F4F5"/>
-          </a:solidFill>
-          <a:ln>
-            <a:noFill/>
-          </a:ln>
-        </p:spPr>
-        <p:style>
-          <a:lnRef idx="1">
-            <a:schemeClr val="accent1"/>
-          </a:lnRef>
-          <a:fillRef idx="3">
-            <a:schemeClr val="accent1"/>
-          </a:fillRef>
-          <a:effectRef idx="2">
-            <a:schemeClr val="accent1"/>
-          </a:effectRef>
-          <a:fontRef idx="minor">
-            <a:schemeClr val="lt1"/>
-          </a:fontRef>
-        </p:style>
-        <p:txBody>
-          <a:bodyPr rtlCol="0" anchor="ctr"/>
-          <a:lstStyle/>
-          <a:p>
-            <a:pPr algn="ctr"/>
-          </a:p>
-        </p:txBody>
-      </p:sp>
-      <p:sp>
-        <p:nvSpPr>
-          <p:cNvPr id="8" name="TextBox 7"/>
+Веса в репо · CPU-фолбэк · README для оргов</a:t>
+            </a:r>
+          </a:p>
+        </p:txBody>
+      </p:sp>
+      <p:sp>
+        <p:nvSpPr>
+          <p:cNvPr id="7" name="TextBox 6"/>
           <p:cNvSpPr txBox="1"/>
           <p:nvPr/>
         </p:nvSpPr>
         <p:spPr>
           <a:xfrm>
-            <a:off x="1280160" y="3401568"/>
-            <a:ext cx="10241280" cy="868680"/>
+            <a:off x="457200" y="6400800"/>
+            <a:ext cx="7315200" cy="274320"/>
           </a:xfrm>
           <a:prstGeom prst="rect">
             <a:avLst/>
@@ -7114,80 +7639,27 @@
           <a:p>
             <a:pPr algn="l"/>
             <a:r>
-              <a:rPr sz="2200" b="0">
-                <a:solidFill>
-                  <a:srgbClr val="F2F4F5"/>
+              <a:rPr sz="1100" b="1">
+                <a:solidFill>
+                  <a:srgbClr val="7D8690"/>
                 </a:solidFill>
                 <a:latin typeface="Inter"/>
               </a:rPr>
-              <a:t>Одна команда инференса — ~28 секунд</a:t>
-            </a:r>
-            <a:r>
-              <a:rPr sz="1400" b="0">
-                <a:solidFill>
-                  <a:srgbClr val="7D8690"/>
-                </a:solidFill>
-                <a:latin typeface="Inter"/>
-              </a:rPr>
-              <a:t>
-на CPU дольше, результат тот же</a:t>
-            </a:r>
-          </a:p>
-        </p:txBody>
-      </p:sp>
-      <p:sp>
-        <p:nvSpPr>
-          <p:cNvPr id="9" name="Oval 8"/>
-          <p:cNvSpPr/>
-          <p:nvPr/>
-        </p:nvSpPr>
-        <p:spPr>
-          <a:xfrm>
-            <a:off x="914400" y="4791455"/>
-            <a:ext cx="155448" cy="155448"/>
-          </a:xfrm>
-          <a:prstGeom prst="ellipse">
-            <a:avLst/>
-          </a:prstGeom>
-          <a:solidFill>
-            <a:srgbClr val="FF6B35"/>
-          </a:solidFill>
-          <a:ln>
-            <a:noFill/>
-          </a:ln>
-        </p:spPr>
-        <p:style>
-          <a:lnRef idx="1">
-            <a:schemeClr val="accent1"/>
-          </a:lnRef>
-          <a:fillRef idx="3">
-            <a:schemeClr val="accent1"/>
-          </a:fillRef>
-          <a:effectRef idx="2">
-            <a:schemeClr val="accent1"/>
-          </a:effectRef>
-          <a:fontRef idx="minor">
-            <a:schemeClr val="lt1"/>
-          </a:fontRef>
-        </p:style>
-        <p:txBody>
-          <a:bodyPr rtlCol="0" anchor="ctr"/>
-          <a:lstStyle/>
-          <a:p>
-            <a:pPr algn="ctr"/>
-          </a:p>
-        </p:txBody>
-      </p:sp>
-      <p:sp>
-        <p:nvSpPr>
-          <p:cNvPr id="10" name="TextBox 9"/>
+              <a:t>ЖИМ НОГАМИ · KOSMOHACK 2026</a:t>
+            </a:r>
+          </a:p>
+        </p:txBody>
+      </p:sp>
+      <p:sp>
+        <p:nvSpPr>
+          <p:cNvPr id="8" name="TextBox 7"/>
           <p:cNvSpPr txBox="1"/>
           <p:nvPr/>
         </p:nvSpPr>
         <p:spPr>
           <a:xfrm>
-            <a:off x="1280160" y="4590288"/>
-            <a:ext cx="10241280" cy="868680"/>
+            <a:off x="10789920" y="6400800"/>
+            <a:ext cx="914400" cy="274320"/>
           </a:xfrm>
           <a:prstGeom prst="rect">
             <a:avLst/>
@@ -7200,25 +7672,15 @@
           </a:bodyPr>
           <a:lstStyle/>
           <a:p>
-            <a:pPr algn="l"/>
-            <a:r>
-              <a:rPr sz="2200" b="0">
-                <a:solidFill>
-                  <a:srgbClr val="F2F4F5"/>
+            <a:pPr algn="r"/>
+            <a:r>
+              <a:rPr sz="1100" b="1">
+                <a:solidFill>
+                  <a:srgbClr val="7D8690"/>
                 </a:solidFill>
                 <a:latin typeface="Inter"/>
               </a:rPr>
-              <a:t>Одна команда сервиса + открыть страницу</a:t>
-            </a:r>
-            <a:r>
-              <a:rPr sz="1400" b="0">
-                <a:solidFill>
-                  <a:srgbClr val="7D8690"/>
-                </a:solidFill>
-                <a:latin typeface="Inter"/>
-              </a:rPr>
-              <a:t>
-демо из коробки</a:t>
+              <a:t>09</a:t>
             </a:r>
           </a:p>
         </p:txBody>

</xml_diff>